<commit_message>
Clarify pitch deck evidence and workflow visuals
</commit_message>
<xml_diff>
--- a/public/Wayfinder-Pitch-Deck.pptx
+++ b/public/Wayfinder-Pitch-Deck.pptx
@@ -2,22 +2,22 @@
 <file path=ppt/presentation.xml><?xml version="1.0" encoding="utf-8"?>
 <p:presentation xmlns:p="http://schemas.openxmlformats.org/presentationml/2006/main">
   <p:sldMasterIdLst>
-    <p:sldMasterId xmlns:r="http://schemas.openxmlformats.org/officeDocument/2006/relationships" id="2147483648" r:id="R327316dac0f64017"/>
+    <p:sldMasterId xmlns:r="http://schemas.openxmlformats.org/officeDocument/2006/relationships" id="2147483648" r:id="Ree90117731854253"/>
   </p:sldMasterIdLst>
   <p:notesMasterIdLst>
-    <p:notesMasterId xmlns:r="http://schemas.openxmlformats.org/officeDocument/2006/relationships" r:id="Rcb0f96274f2a4fbf"/>
+    <p:notesMasterId xmlns:r="http://schemas.openxmlformats.org/officeDocument/2006/relationships" r:id="Rf14cd63da9114a6e"/>
   </p:notesMasterIdLst>
   <p:sldIdLst>
-    <p:sldId xmlns:r="http://schemas.openxmlformats.org/officeDocument/2006/relationships" id="256" r:id="R71be430d12b74b5f"/>
-    <p:sldId xmlns:r="http://schemas.openxmlformats.org/officeDocument/2006/relationships" id="257" r:id="R80a7793943e84a6e"/>
-    <p:sldId xmlns:r="http://schemas.openxmlformats.org/officeDocument/2006/relationships" id="258" r:id="R6f1b7f6b333142df"/>
-    <p:sldId xmlns:r="http://schemas.openxmlformats.org/officeDocument/2006/relationships" id="259" r:id="Rc17d3a8736f14a12"/>
-    <p:sldId xmlns:r="http://schemas.openxmlformats.org/officeDocument/2006/relationships" id="260" r:id="R0327390e985d429e"/>
-    <p:sldId xmlns:r="http://schemas.openxmlformats.org/officeDocument/2006/relationships" id="261" r:id="Ra1f448ad4e174d63"/>
-    <p:sldId xmlns:r="http://schemas.openxmlformats.org/officeDocument/2006/relationships" id="262" r:id="R11e1b364eb8e40cc"/>
-    <p:sldId xmlns:r="http://schemas.openxmlformats.org/officeDocument/2006/relationships" id="263" r:id="Ra6ed324fd063483e"/>
-    <p:sldId xmlns:r="http://schemas.openxmlformats.org/officeDocument/2006/relationships" id="264" r:id="R27dac99436f34992"/>
-    <p:sldId xmlns:r="http://schemas.openxmlformats.org/officeDocument/2006/relationships" id="265" r:id="Rb7a0522bc17c469c"/>
+    <p:sldId xmlns:r="http://schemas.openxmlformats.org/officeDocument/2006/relationships" id="256" r:id="R7155646594fd4f8b"/>
+    <p:sldId xmlns:r="http://schemas.openxmlformats.org/officeDocument/2006/relationships" id="257" r:id="R5949bfe19d774930"/>
+    <p:sldId xmlns:r="http://schemas.openxmlformats.org/officeDocument/2006/relationships" id="258" r:id="R552771b5305a45f8"/>
+    <p:sldId xmlns:r="http://schemas.openxmlformats.org/officeDocument/2006/relationships" id="259" r:id="R26f2a5539e354a92"/>
+    <p:sldId xmlns:r="http://schemas.openxmlformats.org/officeDocument/2006/relationships" id="260" r:id="R2f9527f306984944"/>
+    <p:sldId xmlns:r="http://schemas.openxmlformats.org/officeDocument/2006/relationships" id="261" r:id="R76f70119590b48d7"/>
+    <p:sldId xmlns:r="http://schemas.openxmlformats.org/officeDocument/2006/relationships" id="262" r:id="R095d1a380b834f21"/>
+    <p:sldId xmlns:r="http://schemas.openxmlformats.org/officeDocument/2006/relationships" id="263" r:id="Rea37d20ae0a941fa"/>
+    <p:sldId xmlns:r="http://schemas.openxmlformats.org/officeDocument/2006/relationships" id="264" r:id="R918bd7355d7f4cf6"/>
+    <p:sldId xmlns:r="http://schemas.openxmlformats.org/officeDocument/2006/relationships" id="265" r:id="Rbef6ffd6262544d4"/>
   </p:sldIdLst>
   <p:sldSz cx="12192000" cy="6858000"/>
   <p:notesSz cx="6858000" cy="9144000"/>
@@ -731,7 +731,7 @@
           <a:lstStyle xmlns:a="http://schemas.openxmlformats.org/drawingml/2006/main"/>
           <a:p xmlns:a="http://schemas.openxmlformats.org/drawingml/2006/main">
             <a:r>
-              <a:t>The Evidence Gap. Wayfinder preserves the version trail instead of silently selecting one document. Product claims describe the working proof of concept and do not claim production coverage or legal certainty.</a:t>
+              <a:t>The Evidence Gap. Wayfinder preserves the version trail, then checks the audience and effective date before identifying the applicable position. Product claims describe the working proof of concept and do not claim production coverage or legal certainty.</a:t>
             </a:r>
           </a:p>
         </p:txBody>
@@ -871,7 +871,7 @@
           <a:lstStyle xmlns:a="http://schemas.openxmlformats.org/drawingml/2006/main"/>
           <a:p xmlns:a="http://schemas.openxmlformats.org/drawingml/2006/main">
             <a:r>
-              <a:t>The Working Prototype. A user describes the export transaction, confirms material facts, and receives the current position, required documents, deadlines, and an expert question package. Product claims describe the working proof of concept and do not claim production coverage or legal certainty.</a:t>
+              <a:t>The Working Prototype. The prototype guides a user from transaction facts to a source-cited action plan through three clear stages. Product claims describe the working proof of concept and do not claim production coverage or legal certainty.</a:t>
             </a:r>
           </a:p>
         </p:txBody>
@@ -1149,7 +1149,7 @@
   </p:cSld>
   <p:clrMap bg1="lt1" tx1="dk1" bg2="lt2" tx2="dk2" accent1="accent1" accent2="accent2" accent3="accent3" accent4="accent4" accent5="accent5" accent6="accent6" hlink="hlink" folHlink="folHlink"/>
   <p:sldLayoutIdLst>
-    <p:sldLayoutId xmlns:r="http://schemas.openxmlformats.org/officeDocument/2006/relationships" id="2147483649" r:id="R5f90176a505b4c65"/>
+    <p:sldLayoutId xmlns:r="http://schemas.openxmlformats.org/officeDocument/2006/relationships" id="2147483649" r:id="Rc32b542a83f840d7"/>
   </p:sldLayoutIdLst>
   <p:txStyles>
     <p:titleStyle>
@@ -1700,7 +1700,7 @@
           <p:cNvPr id="11" name="">
             <a:extLst xmlns:a="http://schemas.openxmlformats.org/drawingml/2006/main">
               <a:ext uri="{FF2B5EF4-FFF2-40B4-BE49-F238E27FC236}">
-                <a16:creationId xmlns:a16="http://schemas.microsoft.com/office/drawing/2014/main" id="{B049A5EE-07A9-4E78-AC37-288E78E44ECD}"/>
+                <a16:creationId xmlns:a16="http://schemas.microsoft.com/office/drawing/2014/main" id="{1F3B740D-CCA7-4617-94FC-47BAB4EA7B4C}"/>
               </a:ext>
             </a:extLst>
           </p:cNvPr>
@@ -1730,7 +1730,7 @@
           <p:cNvPr id="2" name="">
             <a:extLst xmlns:a="http://schemas.openxmlformats.org/drawingml/2006/main">
               <a:ext uri="{FF2B5EF4-FFF2-40B4-BE49-F238E27FC236}">
-                <a16:creationId xmlns:a16="http://schemas.microsoft.com/office/drawing/2014/main" id="{0FE0C5FB-619A-4EF8-8086-BB5BA75C5850}"/>
+                <a16:creationId xmlns:a16="http://schemas.microsoft.com/office/drawing/2014/main" id="{7BB99526-9031-4C0A-8CD5-8B52FC9C5E6A}"/>
               </a:ext>
             </a:extLst>
           </p:cNvPr>
@@ -1787,7 +1787,7 @@
           <p:cNvPr id="3" name="">
             <a:extLst xmlns:a="http://schemas.openxmlformats.org/drawingml/2006/main">
               <a:ext uri="{FF2B5EF4-FFF2-40B4-BE49-F238E27FC236}">
-                <a16:creationId xmlns:a16="http://schemas.microsoft.com/office/drawing/2014/main" id="{5852EBC0-615E-4F5B-A51E-EE59DA1CDBA0}"/>
+                <a16:creationId xmlns:a16="http://schemas.microsoft.com/office/drawing/2014/main" id="{356257C3-E199-4EF6-8AE4-224FC17C17FD}"/>
               </a:ext>
             </a:extLst>
           </p:cNvPr>
@@ -1844,7 +1844,7 @@
           <p:cNvPr id="4" name="">
             <a:extLst xmlns:a="http://schemas.openxmlformats.org/drawingml/2006/main">
               <a:ext uri="{FF2B5EF4-FFF2-40B4-BE49-F238E27FC236}">
-                <a16:creationId xmlns:a16="http://schemas.microsoft.com/office/drawing/2014/main" id="{DDA1EED3-F024-46D3-A35E-865F2E442D99}"/>
+                <a16:creationId xmlns:a16="http://schemas.microsoft.com/office/drawing/2014/main" id="{A9A339B7-2EB8-47D0-A0FD-6291D37DF8CE}"/>
               </a:ext>
             </a:extLst>
           </p:cNvPr>
@@ -1901,7 +1901,7 @@
           <p:cNvPr id="5" name="">
             <a:extLst xmlns:a="http://schemas.openxmlformats.org/drawingml/2006/main">
               <a:ext uri="{FF2B5EF4-FFF2-40B4-BE49-F238E27FC236}">
-                <a16:creationId xmlns:a16="http://schemas.microsoft.com/office/drawing/2014/main" id="{29DA42BB-CECB-486E-BA52-025E2253AB05}"/>
+                <a16:creationId xmlns:a16="http://schemas.microsoft.com/office/drawing/2014/main" id="{C98AF36F-E8DE-4293-8A23-D140E6F51C6B}"/>
               </a:ext>
             </a:extLst>
           </p:cNvPr>
@@ -1958,7 +1958,7 @@
           <p:cNvPr id="6" name="">
             <a:extLst xmlns:a="http://schemas.openxmlformats.org/drawingml/2006/main">
               <a:ext uri="{FF2B5EF4-FFF2-40B4-BE49-F238E27FC236}">
-                <a16:creationId xmlns:a16="http://schemas.microsoft.com/office/drawing/2014/main" id="{B00C03D5-0109-4558-8D25-D346A4AC75E5}"/>
+                <a16:creationId xmlns:a16="http://schemas.microsoft.com/office/drawing/2014/main" id="{5236C06C-19A5-4F66-9A05-4C9C300979C3}"/>
               </a:ext>
             </a:extLst>
           </p:cNvPr>
@@ -2015,7 +2015,7 @@
           <p:cNvPr id="7" name="">
             <a:extLst xmlns:a="http://schemas.openxmlformats.org/drawingml/2006/main">
               <a:ext uri="{FF2B5EF4-FFF2-40B4-BE49-F238E27FC236}">
-                <a16:creationId xmlns:a16="http://schemas.microsoft.com/office/drawing/2014/main" id="{29E5DB00-F13B-4A79-B8EF-F889E3E0EF40}"/>
+                <a16:creationId xmlns:a16="http://schemas.microsoft.com/office/drawing/2014/main" id="{2F009ECB-1F85-4B41-9D1E-37D04E3570F7}"/>
               </a:ext>
             </a:extLst>
           </p:cNvPr>
@@ -2072,7 +2072,7 @@
           <p:cNvPr id="8" name="">
             <a:extLst xmlns:a="http://schemas.openxmlformats.org/drawingml/2006/main">
               <a:ext uri="{FF2B5EF4-FFF2-40B4-BE49-F238E27FC236}">
-                <a16:creationId xmlns:a16="http://schemas.microsoft.com/office/drawing/2014/main" id="{57756A8B-C8BF-4069-A79B-14CDDDA417F8}"/>
+                <a16:creationId xmlns:a16="http://schemas.microsoft.com/office/drawing/2014/main" id="{28FCE713-8BB3-4EE8-8E40-9AC68FB41253}"/>
               </a:ext>
             </a:extLst>
           </p:cNvPr>
@@ -2104,7 +2104,7 @@
           <p:cNvPr id="9" name="">
             <a:extLst xmlns:a="http://schemas.openxmlformats.org/drawingml/2006/main">
               <a:ext uri="{FF2B5EF4-FFF2-40B4-BE49-F238E27FC236}">
-                <a16:creationId xmlns:a16="http://schemas.microsoft.com/office/drawing/2014/main" id="{656B62F4-1223-4356-BC17-2DD5324FC783}"/>
+                <a16:creationId xmlns:a16="http://schemas.microsoft.com/office/drawing/2014/main" id="{492F7992-0705-46E8-9E98-A69EBCE0EBEC}"/>
               </a:ext>
             </a:extLst>
           </p:cNvPr>
@@ -2161,7 +2161,7 @@
           <p:cNvPr id="10" name="">
             <a:extLst xmlns:a="http://schemas.openxmlformats.org/drawingml/2006/main">
               <a:ext uri="{FF2B5EF4-FFF2-40B4-BE49-F238E27FC236}">
-                <a16:creationId xmlns:a16="http://schemas.microsoft.com/office/drawing/2014/main" id="{F89D99DA-EAD6-4220-ADD5-3F30753F1F69}"/>
+                <a16:creationId xmlns:a16="http://schemas.microsoft.com/office/drawing/2014/main" id="{D082C24D-0FC0-4576-A25B-30D670EDF82B}"/>
               </a:ext>
             </a:extLst>
           </p:cNvPr>
@@ -2216,7 +2216,7 @@
     </p:spTree>
     <p:extLst>
       <p:ext uri="{BB962C8B-B14F-4D97-AF65-F5344CB8AC3E}">
-        <p14:creationId xmlns:p14="http://schemas.microsoft.com/office/powerpoint/2010/main" val="480935791"/>
+        <p14:creationId xmlns:p14="http://schemas.microsoft.com/office/powerpoint/2010/main" val="1269705034"/>
       </p:ext>
     </p:extLst>
   </p:cSld>
@@ -2247,7 +2247,7 @@
           <p:cNvPr id="22" name="">
             <a:extLst xmlns:a="http://schemas.openxmlformats.org/drawingml/2006/main">
               <a:ext uri="{FF2B5EF4-FFF2-40B4-BE49-F238E27FC236}">
-                <a16:creationId xmlns:a16="http://schemas.microsoft.com/office/drawing/2014/main" id="{D06DCEA4-8F45-463A-ACF3-D7F15AF21F67}"/>
+                <a16:creationId xmlns:a16="http://schemas.microsoft.com/office/drawing/2014/main" id="{BE010687-9622-4ECC-A39F-E7394061C37A}"/>
               </a:ext>
             </a:extLst>
           </p:cNvPr>
@@ -2277,7 +2277,7 @@
           <p:cNvPr id="2" name="">
             <a:extLst xmlns:a="http://schemas.openxmlformats.org/drawingml/2006/main">
               <a:ext uri="{FF2B5EF4-FFF2-40B4-BE49-F238E27FC236}">
-                <a16:creationId xmlns:a16="http://schemas.microsoft.com/office/drawing/2014/main" id="{C16144D6-775D-489A-BB67-1AE106C19774}"/>
+                <a16:creationId xmlns:a16="http://schemas.microsoft.com/office/drawing/2014/main" id="{E9230AE2-287D-47EE-B6CC-A6DF08E15EEE}"/>
               </a:ext>
             </a:extLst>
           </p:cNvPr>
@@ -2334,7 +2334,7 @@
           <p:cNvPr id="3" name="">
             <a:extLst xmlns:a="http://schemas.openxmlformats.org/drawingml/2006/main">
               <a:ext uri="{FF2B5EF4-FFF2-40B4-BE49-F238E27FC236}">
-                <a16:creationId xmlns:a16="http://schemas.microsoft.com/office/drawing/2014/main" id="{A1D49D1C-0A29-417E-B05A-7D0840EE68D2}"/>
+                <a16:creationId xmlns:a16="http://schemas.microsoft.com/office/drawing/2014/main" id="{6DF792D4-F7A3-423F-8A75-C2077A5F3BC2}"/>
               </a:ext>
             </a:extLst>
           </p:cNvPr>
@@ -2391,7 +2391,7 @@
           <p:cNvPr id="4" name="">
             <a:extLst xmlns:a="http://schemas.openxmlformats.org/drawingml/2006/main">
               <a:ext uri="{FF2B5EF4-FFF2-40B4-BE49-F238E27FC236}">
-                <a16:creationId xmlns:a16="http://schemas.microsoft.com/office/drawing/2014/main" id="{887E2581-4F41-4FDE-AE02-1960224362C2}"/>
+                <a16:creationId xmlns:a16="http://schemas.microsoft.com/office/drawing/2014/main" id="{D58044CE-B337-4958-9E3A-BD04C0219A9C}"/>
               </a:ext>
             </a:extLst>
           </p:cNvPr>
@@ -2448,7 +2448,7 @@
           <p:cNvPr id="5" name="">
             <a:extLst xmlns:a="http://schemas.openxmlformats.org/drawingml/2006/main">
               <a:ext uri="{FF2B5EF4-FFF2-40B4-BE49-F238E27FC236}">
-                <a16:creationId xmlns:a16="http://schemas.microsoft.com/office/drawing/2014/main" id="{7A286978-10A3-420E-BB20-DA6542A2044F}"/>
+                <a16:creationId xmlns:a16="http://schemas.microsoft.com/office/drawing/2014/main" id="{952901E7-1323-46CD-B77E-9552E73E120A}"/>
               </a:ext>
             </a:extLst>
           </p:cNvPr>
@@ -2505,7 +2505,7 @@
           <p:cNvPr id="6" name="">
             <a:extLst xmlns:a="http://schemas.openxmlformats.org/drawingml/2006/main">
               <a:ext uri="{FF2B5EF4-FFF2-40B4-BE49-F238E27FC236}">
-                <a16:creationId xmlns:a16="http://schemas.microsoft.com/office/drawing/2014/main" id="{91822D53-89FB-460A-A03A-AB070E5CDD0C}"/>
+                <a16:creationId xmlns:a16="http://schemas.microsoft.com/office/drawing/2014/main" id="{5F89D30D-DBA9-44A6-9F15-5717CCE3819F}"/>
               </a:ext>
             </a:extLst>
           </p:cNvPr>
@@ -2562,7 +2562,7 @@
           <p:cNvPr id="7" name="">
             <a:extLst xmlns:a="http://schemas.openxmlformats.org/drawingml/2006/main">
               <a:ext uri="{FF2B5EF4-FFF2-40B4-BE49-F238E27FC236}">
-                <a16:creationId xmlns:a16="http://schemas.microsoft.com/office/drawing/2014/main" id="{C785AB71-C0EC-4D94-9863-01B3CDACD8E0}"/>
+                <a16:creationId xmlns:a16="http://schemas.microsoft.com/office/drawing/2014/main" id="{5B9A6F7F-383D-4DDE-88BA-9A3829DF3E1A}"/>
               </a:ext>
             </a:extLst>
           </p:cNvPr>
@@ -2619,7 +2619,7 @@
           <p:cNvPr id="8" name="">
             <a:extLst xmlns:a="http://schemas.openxmlformats.org/drawingml/2006/main">
               <a:ext uri="{FF2B5EF4-FFF2-40B4-BE49-F238E27FC236}">
-                <a16:creationId xmlns:a16="http://schemas.microsoft.com/office/drawing/2014/main" id="{7A7D2B04-93A8-42AC-917A-45C3E8D3CDCE}"/>
+                <a16:creationId xmlns:a16="http://schemas.microsoft.com/office/drawing/2014/main" id="{4C98B5BB-A304-4B7A-8E7B-1FBE020AFF16}"/>
               </a:ext>
             </a:extLst>
           </p:cNvPr>
@@ -2651,7 +2651,7 @@
           <p:cNvPr id="9" name="">
             <a:extLst xmlns:a="http://schemas.openxmlformats.org/drawingml/2006/main">
               <a:ext uri="{FF2B5EF4-FFF2-40B4-BE49-F238E27FC236}">
-                <a16:creationId xmlns:a16="http://schemas.microsoft.com/office/drawing/2014/main" id="{D9900D97-514A-491B-A51B-07F0D350E8C5}"/>
+                <a16:creationId xmlns:a16="http://schemas.microsoft.com/office/drawing/2014/main" id="{8755E8E3-443E-429F-9106-F56BF7159501}"/>
               </a:ext>
             </a:extLst>
           </p:cNvPr>
@@ -2708,7 +2708,7 @@
           <p:cNvPr id="10" name="">
             <a:extLst xmlns:a="http://schemas.openxmlformats.org/drawingml/2006/main">
               <a:ext uri="{FF2B5EF4-FFF2-40B4-BE49-F238E27FC236}">
-                <a16:creationId xmlns:a16="http://schemas.microsoft.com/office/drawing/2014/main" id="{853A6BEF-46E2-468A-8B9B-09EB8EA53D85}"/>
+                <a16:creationId xmlns:a16="http://schemas.microsoft.com/office/drawing/2014/main" id="{8DB42945-F462-4851-AAF2-883795F8EEBC}"/>
               </a:ext>
             </a:extLst>
           </p:cNvPr>
@@ -2765,7 +2765,7 @@
           <p:cNvPr id="11" name="">
             <a:extLst xmlns:a="http://schemas.openxmlformats.org/drawingml/2006/main">
               <a:ext uri="{FF2B5EF4-FFF2-40B4-BE49-F238E27FC236}">
-                <a16:creationId xmlns:a16="http://schemas.microsoft.com/office/drawing/2014/main" id="{4F023999-D5AC-494C-ACFE-A3DBF4D37122}"/>
+                <a16:creationId xmlns:a16="http://schemas.microsoft.com/office/drawing/2014/main" id="{0A0A07A0-7C38-467E-AFEA-0C83C8399B8C}"/>
               </a:ext>
             </a:extLst>
           </p:cNvPr>
@@ -2797,7 +2797,7 @@
           <p:cNvPr id="12" name="">
             <a:extLst xmlns:a="http://schemas.openxmlformats.org/drawingml/2006/main">
               <a:ext uri="{FF2B5EF4-FFF2-40B4-BE49-F238E27FC236}">
-                <a16:creationId xmlns:a16="http://schemas.microsoft.com/office/drawing/2014/main" id="{B352719C-5C80-4D39-85FD-B3964886B3D5}"/>
+                <a16:creationId xmlns:a16="http://schemas.microsoft.com/office/drawing/2014/main" id="{C8C5FF80-9D6A-44DF-B713-5C48C2A409AC}"/>
               </a:ext>
             </a:extLst>
           </p:cNvPr>
@@ -2854,7 +2854,7 @@
           <p:cNvPr id="13" name="">
             <a:extLst xmlns:a="http://schemas.openxmlformats.org/drawingml/2006/main">
               <a:ext uri="{FF2B5EF4-FFF2-40B4-BE49-F238E27FC236}">
-                <a16:creationId xmlns:a16="http://schemas.microsoft.com/office/drawing/2014/main" id="{CC6306CD-003B-4C86-84F2-835DEDB2D168}"/>
+                <a16:creationId xmlns:a16="http://schemas.microsoft.com/office/drawing/2014/main" id="{DFDAD257-7CE5-414D-8F4A-4DBBE2FA6CBB}"/>
               </a:ext>
             </a:extLst>
           </p:cNvPr>
@@ -2911,7 +2911,7 @@
           <p:cNvPr id="14" name="">
             <a:extLst xmlns:a="http://schemas.openxmlformats.org/drawingml/2006/main">
               <a:ext uri="{FF2B5EF4-FFF2-40B4-BE49-F238E27FC236}">
-                <a16:creationId xmlns:a16="http://schemas.microsoft.com/office/drawing/2014/main" id="{AABC67DA-87CF-463E-9C69-F9F2D95152F2}"/>
+                <a16:creationId xmlns:a16="http://schemas.microsoft.com/office/drawing/2014/main" id="{7C326A25-1F27-40BD-AEE8-129B43F521F7}"/>
               </a:ext>
             </a:extLst>
           </p:cNvPr>
@@ -2943,7 +2943,7 @@
           <p:cNvPr id="15" name="">
             <a:extLst xmlns:a="http://schemas.openxmlformats.org/drawingml/2006/main">
               <a:ext uri="{FF2B5EF4-FFF2-40B4-BE49-F238E27FC236}">
-                <a16:creationId xmlns:a16="http://schemas.microsoft.com/office/drawing/2014/main" id="{3179ED65-5DDC-4CBF-95D9-1C79AABFAFE8}"/>
+                <a16:creationId xmlns:a16="http://schemas.microsoft.com/office/drawing/2014/main" id="{47F42801-53D4-4F5E-8027-195F957C200E}"/>
               </a:ext>
             </a:extLst>
           </p:cNvPr>
@@ -3000,7 +3000,7 @@
           <p:cNvPr id="16" name="">
             <a:extLst xmlns:a="http://schemas.openxmlformats.org/drawingml/2006/main">
               <a:ext uri="{FF2B5EF4-FFF2-40B4-BE49-F238E27FC236}">
-                <a16:creationId xmlns:a16="http://schemas.microsoft.com/office/drawing/2014/main" id="{ACC28AAE-0459-43D2-826B-9C9750321FAE}"/>
+                <a16:creationId xmlns:a16="http://schemas.microsoft.com/office/drawing/2014/main" id="{FD4451BF-FB65-45A8-9FEF-BBF388BBD608}"/>
               </a:ext>
             </a:extLst>
           </p:cNvPr>
@@ -3057,7 +3057,7 @@
           <p:cNvPr id="17" name="">
             <a:extLst xmlns:a="http://schemas.openxmlformats.org/drawingml/2006/main">
               <a:ext uri="{FF2B5EF4-FFF2-40B4-BE49-F238E27FC236}">
-                <a16:creationId xmlns:a16="http://schemas.microsoft.com/office/drawing/2014/main" id="{013EA785-2A0E-49D3-B7C8-AE4FF40411DB}"/>
+                <a16:creationId xmlns:a16="http://schemas.microsoft.com/office/drawing/2014/main" id="{6776C497-C93D-485C-AE47-F7A1F7260712}"/>
               </a:ext>
             </a:extLst>
           </p:cNvPr>
@@ -3089,7 +3089,7 @@
           <p:cNvPr id="18" name="">
             <a:extLst xmlns:a="http://schemas.openxmlformats.org/drawingml/2006/main">
               <a:ext uri="{FF2B5EF4-FFF2-40B4-BE49-F238E27FC236}">
-                <a16:creationId xmlns:a16="http://schemas.microsoft.com/office/drawing/2014/main" id="{8E2977BB-4C7E-4B7B-9852-82166EEB2CED}"/>
+                <a16:creationId xmlns:a16="http://schemas.microsoft.com/office/drawing/2014/main" id="{954D020E-38B0-40B6-A119-CA23B6FC951D}"/>
               </a:ext>
             </a:extLst>
           </p:cNvPr>
@@ -3146,7 +3146,7 @@
           <p:cNvPr id="19" name="">
             <a:extLst xmlns:a="http://schemas.openxmlformats.org/drawingml/2006/main">
               <a:ext uri="{FF2B5EF4-FFF2-40B4-BE49-F238E27FC236}">
-                <a16:creationId xmlns:a16="http://schemas.microsoft.com/office/drawing/2014/main" id="{573452F6-E5C3-4280-A1DD-D5B0FC35645C}"/>
+                <a16:creationId xmlns:a16="http://schemas.microsoft.com/office/drawing/2014/main" id="{8430D248-ECA0-45CE-8F08-07E6A8C86002}"/>
               </a:ext>
             </a:extLst>
           </p:cNvPr>
@@ -3203,7 +3203,7 @@
           <p:cNvPr id="20" name="">
             <a:extLst xmlns:a="http://schemas.openxmlformats.org/drawingml/2006/main">
               <a:ext uri="{FF2B5EF4-FFF2-40B4-BE49-F238E27FC236}">
-                <a16:creationId xmlns:a16="http://schemas.microsoft.com/office/drawing/2014/main" id="{92EBD826-0A61-4CD0-AFCB-19F5B1EA1CAC}"/>
+                <a16:creationId xmlns:a16="http://schemas.microsoft.com/office/drawing/2014/main" id="{1D66F576-C470-40CC-8605-CFE63F8FA453}"/>
               </a:ext>
             </a:extLst>
           </p:cNvPr>
@@ -3235,7 +3235,7 @@
           <p:cNvPr id="21" name="">
             <a:extLst xmlns:a="http://schemas.openxmlformats.org/drawingml/2006/main">
               <a:ext uri="{FF2B5EF4-FFF2-40B4-BE49-F238E27FC236}">
-                <a16:creationId xmlns:a16="http://schemas.microsoft.com/office/drawing/2014/main" id="{4E141203-68B4-4759-B03F-DF6D5985EDE9}"/>
+                <a16:creationId xmlns:a16="http://schemas.microsoft.com/office/drawing/2014/main" id="{8DE61571-5B4B-433A-875F-ABD1C4CD16AC}"/>
               </a:ext>
             </a:extLst>
           </p:cNvPr>
@@ -3290,7 +3290,7 @@
     </p:spTree>
     <p:extLst>
       <p:ext uri="{BB962C8B-B14F-4D97-AF65-F5344CB8AC3E}">
-        <p14:creationId xmlns:p14="http://schemas.microsoft.com/office/powerpoint/2010/main" val="1396805149"/>
+        <p14:creationId xmlns:p14="http://schemas.microsoft.com/office/powerpoint/2010/main" val="983909254"/>
       </p:ext>
     </p:extLst>
   </p:cSld>
@@ -3321,7 +3321,7 @@
           <p:cNvPr id="17" name="">
             <a:extLst xmlns:a="http://schemas.openxmlformats.org/drawingml/2006/main">
               <a:ext uri="{FF2B5EF4-FFF2-40B4-BE49-F238E27FC236}">
-                <a16:creationId xmlns:a16="http://schemas.microsoft.com/office/drawing/2014/main" id="{436FC79C-4DA6-4D07-A19B-0BF4504EBEF7}"/>
+                <a16:creationId xmlns:a16="http://schemas.microsoft.com/office/drawing/2014/main" id="{90EE9691-87BB-4EC7-82CA-77C343999448}"/>
               </a:ext>
             </a:extLst>
           </p:cNvPr>
@@ -3351,7 +3351,7 @@
           <p:cNvPr id="2" name="">
             <a:extLst xmlns:a="http://schemas.openxmlformats.org/drawingml/2006/main">
               <a:ext uri="{FF2B5EF4-FFF2-40B4-BE49-F238E27FC236}">
-                <a16:creationId xmlns:a16="http://schemas.microsoft.com/office/drawing/2014/main" id="{1BB1384B-DC44-4F8F-99A2-B63879E3ED8C}"/>
+                <a16:creationId xmlns:a16="http://schemas.microsoft.com/office/drawing/2014/main" id="{CF9A8A3D-9D86-4775-A900-E4800ACFAF43}"/>
               </a:ext>
             </a:extLst>
           </p:cNvPr>
@@ -3408,7 +3408,7 @@
           <p:cNvPr id="3" name="">
             <a:extLst xmlns:a="http://schemas.openxmlformats.org/drawingml/2006/main">
               <a:ext uri="{FF2B5EF4-FFF2-40B4-BE49-F238E27FC236}">
-                <a16:creationId xmlns:a16="http://schemas.microsoft.com/office/drawing/2014/main" id="{5E9A0BA2-2B1C-4627-AEBA-10F2E400D3EB}"/>
+                <a16:creationId xmlns:a16="http://schemas.microsoft.com/office/drawing/2014/main" id="{A743F6A0-3302-4D56-A3F9-0CF5A476B962}"/>
               </a:ext>
             </a:extLst>
           </p:cNvPr>
@@ -3465,7 +3465,7 @@
           <p:cNvPr id="4" name="">
             <a:extLst xmlns:a="http://schemas.openxmlformats.org/drawingml/2006/main">
               <a:ext uri="{FF2B5EF4-FFF2-40B4-BE49-F238E27FC236}">
-                <a16:creationId xmlns:a16="http://schemas.microsoft.com/office/drawing/2014/main" id="{3F117A3E-D164-4B6C-8620-A41DE4C231C4}"/>
+                <a16:creationId xmlns:a16="http://schemas.microsoft.com/office/drawing/2014/main" id="{A0698EC6-B3B9-42D1-8BC5-2577172D4B69}"/>
               </a:ext>
             </a:extLst>
           </p:cNvPr>
@@ -3522,7 +3522,7 @@
           <p:cNvPr id="5" name="">
             <a:extLst xmlns:a="http://schemas.openxmlformats.org/drawingml/2006/main">
               <a:ext uri="{FF2B5EF4-FFF2-40B4-BE49-F238E27FC236}">
-                <a16:creationId xmlns:a16="http://schemas.microsoft.com/office/drawing/2014/main" id="{AC320AAC-D6E9-4282-B97F-702E4ECB1E90}"/>
+                <a16:creationId xmlns:a16="http://schemas.microsoft.com/office/drawing/2014/main" id="{0E39E7F2-EA2E-44D4-99E2-216281F7F400}"/>
               </a:ext>
             </a:extLst>
           </p:cNvPr>
@@ -3579,7 +3579,7 @@
           <p:cNvPr id="6" name="">
             <a:extLst xmlns:a="http://schemas.openxmlformats.org/drawingml/2006/main">
               <a:ext uri="{FF2B5EF4-FFF2-40B4-BE49-F238E27FC236}">
-                <a16:creationId xmlns:a16="http://schemas.microsoft.com/office/drawing/2014/main" id="{5ECD7767-427C-444B-8BE7-67B69D3C0CAC}"/>
+                <a16:creationId xmlns:a16="http://schemas.microsoft.com/office/drawing/2014/main" id="{9961D74F-4C4D-4A63-9A6A-072B0FA2D7C0}"/>
               </a:ext>
             </a:extLst>
           </p:cNvPr>
@@ -3636,7 +3636,7 @@
           <p:cNvPr id="7" name="">
             <a:extLst xmlns:a="http://schemas.openxmlformats.org/drawingml/2006/main">
               <a:ext uri="{FF2B5EF4-FFF2-40B4-BE49-F238E27FC236}">
-                <a16:creationId xmlns:a16="http://schemas.microsoft.com/office/drawing/2014/main" id="{B665A1B7-6E21-4B19-9B5C-2BE96732139B}"/>
+                <a16:creationId xmlns:a16="http://schemas.microsoft.com/office/drawing/2014/main" id="{CBB2C9CE-8ABF-4559-A108-7B369755C47D}"/>
               </a:ext>
             </a:extLst>
           </p:cNvPr>
@@ -3693,7 +3693,7 @@
           <p:cNvPr id="8" name="">
             <a:extLst xmlns:a="http://schemas.openxmlformats.org/drawingml/2006/main">
               <a:ext uri="{FF2B5EF4-FFF2-40B4-BE49-F238E27FC236}">
-                <a16:creationId xmlns:a16="http://schemas.microsoft.com/office/drawing/2014/main" id="{A116E225-9031-49D0-913A-54748155BA3B}"/>
+                <a16:creationId xmlns:a16="http://schemas.microsoft.com/office/drawing/2014/main" id="{18937A2B-8F07-4D89-8C99-F4DBB3021144}"/>
               </a:ext>
             </a:extLst>
           </p:cNvPr>
@@ -3725,7 +3725,7 @@
           <p:cNvPr id="9" name="">
             <a:extLst xmlns:a="http://schemas.openxmlformats.org/drawingml/2006/main">
               <a:ext uri="{FF2B5EF4-FFF2-40B4-BE49-F238E27FC236}">
-                <a16:creationId xmlns:a16="http://schemas.microsoft.com/office/drawing/2014/main" id="{DED69803-FA67-406F-A42F-73606E589551}"/>
+                <a16:creationId xmlns:a16="http://schemas.microsoft.com/office/drawing/2014/main" id="{993C0C2B-06FB-4EC5-AC5F-15C4C63F6663}"/>
               </a:ext>
             </a:extLst>
           </p:cNvPr>
@@ -3782,7 +3782,7 @@
           <p:cNvPr id="10" name="">
             <a:extLst xmlns:a="http://schemas.openxmlformats.org/drawingml/2006/main">
               <a:ext uri="{FF2B5EF4-FFF2-40B4-BE49-F238E27FC236}">
-                <a16:creationId xmlns:a16="http://schemas.microsoft.com/office/drawing/2014/main" id="{3B8C32AA-3B56-4232-999A-A054A9E04ADF}"/>
+                <a16:creationId xmlns:a16="http://schemas.microsoft.com/office/drawing/2014/main" id="{BE055DBE-B1F3-45FD-A04C-03E62D0B68AB}"/>
               </a:ext>
             </a:extLst>
           </p:cNvPr>
@@ -3839,7 +3839,7 @@
           <p:cNvPr id="11" name="">
             <a:extLst xmlns:a="http://schemas.openxmlformats.org/drawingml/2006/main">
               <a:ext uri="{FF2B5EF4-FFF2-40B4-BE49-F238E27FC236}">
-                <a16:creationId xmlns:a16="http://schemas.microsoft.com/office/drawing/2014/main" id="{69AC8FC6-D608-41B3-BDEC-DDB39AE94748}"/>
+                <a16:creationId xmlns:a16="http://schemas.microsoft.com/office/drawing/2014/main" id="{20420946-113A-44C1-9B02-7D3640441700}"/>
               </a:ext>
             </a:extLst>
           </p:cNvPr>
@@ -3871,7 +3871,7 @@
           <p:cNvPr id="12" name="">
             <a:extLst xmlns:a="http://schemas.openxmlformats.org/drawingml/2006/main">
               <a:ext uri="{FF2B5EF4-FFF2-40B4-BE49-F238E27FC236}">
-                <a16:creationId xmlns:a16="http://schemas.microsoft.com/office/drawing/2014/main" id="{406E8656-19FE-410E-832B-E3A9BB986B62}"/>
+                <a16:creationId xmlns:a16="http://schemas.microsoft.com/office/drawing/2014/main" id="{ECB00D1C-24E7-4DA9-A2DA-EDE586C69306}"/>
               </a:ext>
             </a:extLst>
           </p:cNvPr>
@@ -3928,7 +3928,7 @@
           <p:cNvPr id="13" name="">
             <a:extLst xmlns:a="http://schemas.openxmlformats.org/drawingml/2006/main">
               <a:ext uri="{FF2B5EF4-FFF2-40B4-BE49-F238E27FC236}">
-                <a16:creationId xmlns:a16="http://schemas.microsoft.com/office/drawing/2014/main" id="{EE5BD34E-0FD4-49F3-8F62-40A46DB58B4F}"/>
+                <a16:creationId xmlns:a16="http://schemas.microsoft.com/office/drawing/2014/main" id="{75807409-4DBD-4865-89A6-4546DEB4CFA2}"/>
               </a:ext>
             </a:extLst>
           </p:cNvPr>
@@ -3985,7 +3985,7 @@
           <p:cNvPr id="14" name="">
             <a:extLst xmlns:a="http://schemas.openxmlformats.org/drawingml/2006/main">
               <a:ext uri="{FF2B5EF4-FFF2-40B4-BE49-F238E27FC236}">
-                <a16:creationId xmlns:a16="http://schemas.microsoft.com/office/drawing/2014/main" id="{AA84C676-F7F4-4BE9-A624-E13FF137555C}"/>
+                <a16:creationId xmlns:a16="http://schemas.microsoft.com/office/drawing/2014/main" id="{261BCBDA-EBA1-4AD7-9E7E-86A3A88FB54E}"/>
               </a:ext>
             </a:extLst>
           </p:cNvPr>
@@ -4017,7 +4017,7 @@
           <p:cNvPr id="15" name="">
             <a:extLst xmlns:a="http://schemas.openxmlformats.org/drawingml/2006/main">
               <a:ext uri="{FF2B5EF4-FFF2-40B4-BE49-F238E27FC236}">
-                <a16:creationId xmlns:a16="http://schemas.microsoft.com/office/drawing/2014/main" id="{1AC8EC17-0AED-4A9B-A65E-ABE3A4D2FA25}"/>
+                <a16:creationId xmlns:a16="http://schemas.microsoft.com/office/drawing/2014/main" id="{5FD82A6F-37DF-4CEC-BD42-F1C2376B4CC3}"/>
               </a:ext>
             </a:extLst>
           </p:cNvPr>
@@ -4074,7 +4074,7 @@
           <p:cNvPr id="16" name="">
             <a:extLst xmlns:a="http://schemas.openxmlformats.org/drawingml/2006/main">
               <a:ext uri="{FF2B5EF4-FFF2-40B4-BE49-F238E27FC236}">
-                <a16:creationId xmlns:a16="http://schemas.microsoft.com/office/drawing/2014/main" id="{5F9571F0-C1D1-4F85-8DB6-E86AC7E6D6E6}"/>
+                <a16:creationId xmlns:a16="http://schemas.microsoft.com/office/drawing/2014/main" id="{7E83D900-01EF-4410-AE2F-A695FE72C87C}"/>
               </a:ext>
             </a:extLst>
           </p:cNvPr>
@@ -4129,7 +4129,7 @@
     </p:spTree>
     <p:extLst>
       <p:ext uri="{BB962C8B-B14F-4D97-AF65-F5344CB8AC3E}">
-        <p14:creationId xmlns:p14="http://schemas.microsoft.com/office/powerpoint/2010/main" val="667658778"/>
+        <p14:creationId xmlns:p14="http://schemas.microsoft.com/office/powerpoint/2010/main" val="125997163"/>
       </p:ext>
     </p:extLst>
   </p:cSld>
@@ -4160,7 +4160,7 @@
           <p:cNvPr id="17" name="">
             <a:extLst xmlns:a="http://schemas.openxmlformats.org/drawingml/2006/main">
               <a:ext uri="{FF2B5EF4-FFF2-40B4-BE49-F238E27FC236}">
-                <a16:creationId xmlns:a16="http://schemas.microsoft.com/office/drawing/2014/main" id="{0C1CDCAE-57D6-4012-B1DC-A57B1B12E5BC}"/>
+                <a16:creationId xmlns:a16="http://schemas.microsoft.com/office/drawing/2014/main" id="{F73E9FC3-7506-43CD-88A2-EC83FF998349}"/>
               </a:ext>
             </a:extLst>
           </p:cNvPr>
@@ -4190,7 +4190,7 @@
           <p:cNvPr id="2" name="">
             <a:extLst xmlns:a="http://schemas.openxmlformats.org/drawingml/2006/main">
               <a:ext uri="{FF2B5EF4-FFF2-40B4-BE49-F238E27FC236}">
-                <a16:creationId xmlns:a16="http://schemas.microsoft.com/office/drawing/2014/main" id="{DAA1E0A6-CFDC-4217-9D5A-84A4CAA5F4FA}"/>
+                <a16:creationId xmlns:a16="http://schemas.microsoft.com/office/drawing/2014/main" id="{4046D17B-C457-44A0-96CF-C1A219482F9A}"/>
               </a:ext>
             </a:extLst>
           </p:cNvPr>
@@ -4247,7 +4247,7 @@
           <p:cNvPr id="3" name="">
             <a:extLst xmlns:a="http://schemas.openxmlformats.org/drawingml/2006/main">
               <a:ext uri="{FF2B5EF4-FFF2-40B4-BE49-F238E27FC236}">
-                <a16:creationId xmlns:a16="http://schemas.microsoft.com/office/drawing/2014/main" id="{F13121F8-9A45-4530-AA19-9EAAEC3B201A}"/>
+                <a16:creationId xmlns:a16="http://schemas.microsoft.com/office/drawing/2014/main" id="{ABF1980D-403B-4CFB-BB50-D8180291AF1A}"/>
               </a:ext>
             </a:extLst>
           </p:cNvPr>
@@ -4304,7 +4304,7 @@
           <p:cNvPr id="4" name="">
             <a:extLst xmlns:a="http://schemas.openxmlformats.org/drawingml/2006/main">
               <a:ext uri="{FF2B5EF4-FFF2-40B4-BE49-F238E27FC236}">
-                <a16:creationId xmlns:a16="http://schemas.microsoft.com/office/drawing/2014/main" id="{DFDC7356-ACEF-4ED5-9498-48D296B4AAFB}"/>
+                <a16:creationId xmlns:a16="http://schemas.microsoft.com/office/drawing/2014/main" id="{9F4404C5-B331-4ABC-935A-4395CCCDF55A}"/>
               </a:ext>
             </a:extLst>
           </p:cNvPr>
@@ -4361,7 +4361,7 @@
           <p:cNvPr id="5" name="">
             <a:extLst xmlns:a="http://schemas.openxmlformats.org/drawingml/2006/main">
               <a:ext uri="{FF2B5EF4-FFF2-40B4-BE49-F238E27FC236}">
-                <a16:creationId xmlns:a16="http://schemas.microsoft.com/office/drawing/2014/main" id="{D961BE6D-8F79-450D-B5EA-77DC17DD68CF}"/>
+                <a16:creationId xmlns:a16="http://schemas.microsoft.com/office/drawing/2014/main" id="{6D49D7A5-99DB-46AB-9FAD-782DBB997FC3}"/>
               </a:ext>
             </a:extLst>
           </p:cNvPr>
@@ -4418,7 +4418,7 @@
           <p:cNvPr id="6" name="">
             <a:extLst xmlns:a="http://schemas.openxmlformats.org/drawingml/2006/main">
               <a:ext uri="{FF2B5EF4-FFF2-40B4-BE49-F238E27FC236}">
-                <a16:creationId xmlns:a16="http://schemas.microsoft.com/office/drawing/2014/main" id="{20AEFBFD-E8CB-4E72-9AF2-A8E7483BFBCD}"/>
+                <a16:creationId xmlns:a16="http://schemas.microsoft.com/office/drawing/2014/main" id="{1CB90512-9BEA-45E9-9E42-29AB16B9F528}"/>
               </a:ext>
             </a:extLst>
           </p:cNvPr>
@@ -4475,7 +4475,7 @@
           <p:cNvPr id="7" name="">
             <a:extLst xmlns:a="http://schemas.openxmlformats.org/drawingml/2006/main">
               <a:ext uri="{FF2B5EF4-FFF2-40B4-BE49-F238E27FC236}">
-                <a16:creationId xmlns:a16="http://schemas.microsoft.com/office/drawing/2014/main" id="{353CDBC7-199A-49C9-A5D9-15F523723826}"/>
+                <a16:creationId xmlns:a16="http://schemas.microsoft.com/office/drawing/2014/main" id="{963EF64D-6604-45DE-B27A-1C58698F0610}"/>
               </a:ext>
             </a:extLst>
           </p:cNvPr>
@@ -4532,7 +4532,7 @@
           <p:cNvPr id="8" name="">
             <a:extLst xmlns:a="http://schemas.openxmlformats.org/drawingml/2006/main">
               <a:ext uri="{FF2B5EF4-FFF2-40B4-BE49-F238E27FC236}">
-                <a16:creationId xmlns:a16="http://schemas.microsoft.com/office/drawing/2014/main" id="{0657AA4B-9E55-4FEE-A941-53B8D06F0142}"/>
+                <a16:creationId xmlns:a16="http://schemas.microsoft.com/office/drawing/2014/main" id="{FAED4C52-E012-41DC-AA41-F97CB3CA7519}"/>
               </a:ext>
             </a:extLst>
           </p:cNvPr>
@@ -4564,7 +4564,7 @@
           <p:cNvPr id="9" name="">
             <a:extLst xmlns:a="http://schemas.openxmlformats.org/drawingml/2006/main">
               <a:ext uri="{FF2B5EF4-FFF2-40B4-BE49-F238E27FC236}">
-                <a16:creationId xmlns:a16="http://schemas.microsoft.com/office/drawing/2014/main" id="{32517722-F40A-4FC9-9129-5694D9F0DDC3}"/>
+                <a16:creationId xmlns:a16="http://schemas.microsoft.com/office/drawing/2014/main" id="{5F25A5D4-E593-4F9B-AC29-2405EFECDADB}"/>
               </a:ext>
             </a:extLst>
           </p:cNvPr>
@@ -4621,7 +4621,7 @@
           <p:cNvPr id="10" name="">
             <a:extLst xmlns:a="http://schemas.openxmlformats.org/drawingml/2006/main">
               <a:ext uri="{FF2B5EF4-FFF2-40B4-BE49-F238E27FC236}">
-                <a16:creationId xmlns:a16="http://schemas.microsoft.com/office/drawing/2014/main" id="{818BF79C-26B8-4C1C-863A-A887E39F6E8C}"/>
+                <a16:creationId xmlns:a16="http://schemas.microsoft.com/office/drawing/2014/main" id="{33ABA09E-AE66-492D-9A56-82C7A4998D82}"/>
               </a:ext>
             </a:extLst>
           </p:cNvPr>
@@ -4678,7 +4678,7 @@
           <p:cNvPr id="11" name="">
             <a:extLst xmlns:a="http://schemas.openxmlformats.org/drawingml/2006/main">
               <a:ext uri="{FF2B5EF4-FFF2-40B4-BE49-F238E27FC236}">
-                <a16:creationId xmlns:a16="http://schemas.microsoft.com/office/drawing/2014/main" id="{7A2A6E94-E962-42A6-ACB8-F9A98B9CA8D2}"/>
+                <a16:creationId xmlns:a16="http://schemas.microsoft.com/office/drawing/2014/main" id="{433CB35A-19C1-4780-A711-9884E245FBF9}"/>
               </a:ext>
             </a:extLst>
           </p:cNvPr>
@@ -4710,7 +4710,7 @@
           <p:cNvPr id="12" name="">
             <a:extLst xmlns:a="http://schemas.openxmlformats.org/drawingml/2006/main">
               <a:ext uri="{FF2B5EF4-FFF2-40B4-BE49-F238E27FC236}">
-                <a16:creationId xmlns:a16="http://schemas.microsoft.com/office/drawing/2014/main" id="{FB828F6F-B7B7-4A89-843B-70F6A021378D}"/>
+                <a16:creationId xmlns:a16="http://schemas.microsoft.com/office/drawing/2014/main" id="{80429E10-E78E-4F93-A362-6EDABF3ADE94}"/>
               </a:ext>
             </a:extLst>
           </p:cNvPr>
@@ -4767,7 +4767,7 @@
           <p:cNvPr id="13" name="">
             <a:extLst xmlns:a="http://schemas.openxmlformats.org/drawingml/2006/main">
               <a:ext uri="{FF2B5EF4-FFF2-40B4-BE49-F238E27FC236}">
-                <a16:creationId xmlns:a16="http://schemas.microsoft.com/office/drawing/2014/main" id="{61987CBA-7A98-442B-9D16-F1ECDE824888}"/>
+                <a16:creationId xmlns:a16="http://schemas.microsoft.com/office/drawing/2014/main" id="{AED4CD8D-EE00-41A2-A961-DC0318C95F36}"/>
               </a:ext>
             </a:extLst>
           </p:cNvPr>
@@ -4824,7 +4824,7 @@
           <p:cNvPr id="14" name="">
             <a:extLst xmlns:a="http://schemas.openxmlformats.org/drawingml/2006/main">
               <a:ext uri="{FF2B5EF4-FFF2-40B4-BE49-F238E27FC236}">
-                <a16:creationId xmlns:a16="http://schemas.microsoft.com/office/drawing/2014/main" id="{C4708C20-6639-4DB9-B423-715B904D64A8}"/>
+                <a16:creationId xmlns:a16="http://schemas.microsoft.com/office/drawing/2014/main" id="{B4F6CEA0-874D-4D54-BB5A-E9E458975E38}"/>
               </a:ext>
             </a:extLst>
           </p:cNvPr>
@@ -4856,7 +4856,7 @@
           <p:cNvPr id="15" name="">
             <a:extLst xmlns:a="http://schemas.openxmlformats.org/drawingml/2006/main">
               <a:ext uri="{FF2B5EF4-FFF2-40B4-BE49-F238E27FC236}">
-                <a16:creationId xmlns:a16="http://schemas.microsoft.com/office/drawing/2014/main" id="{9AF22306-3727-4AEA-B982-6022C2E3AA34}"/>
+                <a16:creationId xmlns:a16="http://schemas.microsoft.com/office/drawing/2014/main" id="{E01509EB-23EB-499D-B4FA-1FE5F03F481C}"/>
               </a:ext>
             </a:extLst>
           </p:cNvPr>
@@ -4913,7 +4913,7 @@
           <p:cNvPr id="16" name="">
             <a:extLst xmlns:a="http://schemas.openxmlformats.org/drawingml/2006/main">
               <a:ext uri="{FF2B5EF4-FFF2-40B4-BE49-F238E27FC236}">
-                <a16:creationId xmlns:a16="http://schemas.microsoft.com/office/drawing/2014/main" id="{6B40B567-892C-4751-99DC-9126287B847F}"/>
+                <a16:creationId xmlns:a16="http://schemas.microsoft.com/office/drawing/2014/main" id="{93B2C29E-B7BC-4D0B-AB35-EBC38803068D}"/>
               </a:ext>
             </a:extLst>
           </p:cNvPr>
@@ -4968,7 +4968,7 @@
     </p:spTree>
     <p:extLst>
       <p:ext uri="{BB962C8B-B14F-4D97-AF65-F5344CB8AC3E}">
-        <p14:creationId xmlns:p14="http://schemas.microsoft.com/office/powerpoint/2010/main" val="1781929121"/>
+        <p14:creationId xmlns:p14="http://schemas.microsoft.com/office/powerpoint/2010/main" val="1872433734"/>
       </p:ext>
     </p:extLst>
   </p:cSld>
@@ -4996,10 +4996,10 @@
       </p:grpSpPr>
       <p:sp>
         <p:nvSpPr>
-          <p:cNvPr id="12" name="">
-            <a:extLst xmlns:a="http://schemas.openxmlformats.org/drawingml/2006/main">
-              <a:ext uri="{FF2B5EF4-FFF2-40B4-BE49-F238E27FC236}">
-                <a16:creationId xmlns:a16="http://schemas.microsoft.com/office/drawing/2014/main" id="{98E0AE00-F033-455D-8945-BBC7100129FE}"/>
+          <p:cNvPr id="20" name="">
+            <a:extLst xmlns:a="http://schemas.openxmlformats.org/drawingml/2006/main">
+              <a:ext uri="{FF2B5EF4-FFF2-40B4-BE49-F238E27FC236}">
+                <a16:creationId xmlns:a16="http://schemas.microsoft.com/office/drawing/2014/main" id="{8BE8AFCF-331D-41B6-A880-C95CB7B3B847}"/>
               </a:ext>
             </a:extLst>
           </p:cNvPr>
@@ -5029,7 +5029,7 @@
           <p:cNvPr id="2" name="">
             <a:extLst xmlns:a="http://schemas.openxmlformats.org/drawingml/2006/main">
               <a:ext uri="{FF2B5EF4-FFF2-40B4-BE49-F238E27FC236}">
-                <a16:creationId xmlns:a16="http://schemas.microsoft.com/office/drawing/2014/main" id="{F72A69D6-F027-4DB6-BD8B-8F191F712A5D}"/>
+                <a16:creationId xmlns:a16="http://schemas.microsoft.com/office/drawing/2014/main" id="{6600EBC3-3ED5-42B2-9F14-40B13476A316}"/>
               </a:ext>
             </a:extLst>
           </p:cNvPr>
@@ -5086,7 +5086,7 @@
           <p:cNvPr id="3" name="">
             <a:extLst xmlns:a="http://schemas.openxmlformats.org/drawingml/2006/main">
               <a:ext uri="{FF2B5EF4-FFF2-40B4-BE49-F238E27FC236}">
-                <a16:creationId xmlns:a16="http://schemas.microsoft.com/office/drawing/2014/main" id="{C7A59380-F7E2-4F72-9D0E-CCADF7C35927}"/>
+                <a16:creationId xmlns:a16="http://schemas.microsoft.com/office/drawing/2014/main" id="{F6957A27-9982-4AAF-8890-F2D34847A0C6}"/>
               </a:ext>
             </a:extLst>
           </p:cNvPr>
@@ -5143,7 +5143,7 @@
           <p:cNvPr id="4" name="">
             <a:extLst xmlns:a="http://schemas.openxmlformats.org/drawingml/2006/main">
               <a:ext uri="{FF2B5EF4-FFF2-40B4-BE49-F238E27FC236}">
-                <a16:creationId xmlns:a16="http://schemas.microsoft.com/office/drawing/2014/main" id="{8BE4EB24-47C2-492E-BEB9-CF95993854DC}"/>
+                <a16:creationId xmlns:a16="http://schemas.microsoft.com/office/drawing/2014/main" id="{2A0470F7-CCDB-4848-A2A8-43CE07C7F99D}"/>
               </a:ext>
             </a:extLst>
           </p:cNvPr>
@@ -5200,7 +5200,7 @@
           <p:cNvPr id="5" name="">
             <a:extLst xmlns:a="http://schemas.openxmlformats.org/drawingml/2006/main">
               <a:ext uri="{FF2B5EF4-FFF2-40B4-BE49-F238E27FC236}">
-                <a16:creationId xmlns:a16="http://schemas.microsoft.com/office/drawing/2014/main" id="{4AAB3D9C-54E8-4A42-AC58-135CEFB145E8}"/>
+                <a16:creationId xmlns:a16="http://schemas.microsoft.com/office/drawing/2014/main" id="{3C8FD3EB-C003-4726-9484-5CF676CDEF6B}"/>
               </a:ext>
             </a:extLst>
           </p:cNvPr>
@@ -5257,7 +5257,7 @@
           <p:cNvPr id="6" name="">
             <a:extLst xmlns:a="http://schemas.openxmlformats.org/drawingml/2006/main">
               <a:ext uri="{FF2B5EF4-FFF2-40B4-BE49-F238E27FC236}">
-                <a16:creationId xmlns:a16="http://schemas.microsoft.com/office/drawing/2014/main" id="{41C20B2B-53D1-4501-A29B-7EB5B3266DA4}"/>
+                <a16:creationId xmlns:a16="http://schemas.microsoft.com/office/drawing/2014/main" id="{B24F8F92-434E-4E0E-9B52-6A84684EB679}"/>
               </a:ext>
             </a:extLst>
           </p:cNvPr>
@@ -5314,7 +5314,7 @@
           <p:cNvPr id="7" name="">
             <a:extLst xmlns:a="http://schemas.openxmlformats.org/drawingml/2006/main">
               <a:ext uri="{FF2B5EF4-FFF2-40B4-BE49-F238E27FC236}">
-                <a16:creationId xmlns:a16="http://schemas.microsoft.com/office/drawing/2014/main" id="{6A8B05FD-2E63-4B84-B4BD-9E52D13C8724}"/>
+                <a16:creationId xmlns:a16="http://schemas.microsoft.com/office/drawing/2014/main" id="{4C6E145F-C103-4FF8-8442-E1496CF6752E}"/>
               </a:ext>
             </a:extLst>
           </p:cNvPr>
@@ -5361,7 +5361,7 @@
                 <a:ea typeface="Bitstream Charter"/>
                 <a:cs typeface="Bitstream Charter"/>
               </a:rPr>
-              <a:t>Wayfinder preserves the version trail instead of silently selecting one document.</a:t>
+              <a:t>Wayfinder preserves the version trail, then checks the audience and effective date before identifying the applicable position.</a:t>
             </a:r>
           </a:p>
         </p:txBody>
@@ -5371,36 +5371,157 @@
           <p:cNvPr id="8" name="">
             <a:extLst xmlns:a="http://schemas.openxmlformats.org/drawingml/2006/main">
               <a:ext uri="{FF2B5EF4-FFF2-40B4-BE49-F238E27FC236}">
-                <a16:creationId xmlns:a16="http://schemas.microsoft.com/office/drawing/2014/main" id="{C025A108-F333-4025-B4C5-E2671325FC28}"/>
-              </a:ext>
-            </a:extLst>
-          </p:cNvPr>
-          <p:cNvSpPr>
-            <a:spLocks xmlns:a="http://schemas.openxmlformats.org/drawingml/2006/main" noGrp="1"/>
-          </p:cNvSpPr>
-          <p:nvPr/>
-        </p:nvSpPr>
-        <p:spPr>
-          <a:xfrm xmlns:a="http://schemas.openxmlformats.org/drawingml/2006/main">
-            <a:off x="723900" y="3905250"/>
-            <a:ext cx="2476500" cy="857250"/>
-          </a:xfrm>
-          <a:prstGeom xmlns:a="http://schemas.openxmlformats.org/drawingml/2006/main" prst="rect">
-            <a:avLst/>
-          </a:prstGeom>
-          <a:noFill xmlns:a="http://schemas.openxmlformats.org/drawingml/2006/main"/>
-          <a:ln xmlns:a="http://schemas.openxmlformats.org/drawingml/2006/main" w="0">
-            <a:noFill/>
-          </a:ln>
-        </p:spPr>
-        <p:txBody>
-          <a:bodyPr xmlns:a="http://schemas.openxmlformats.org/drawingml/2006/main">
-            <a:normAutofit fontScale="88158"/>
-          </a:bodyPr>
-          <a:lstStyle xmlns:a="http://schemas.openxmlformats.org/drawingml/2006/main"/>
-          <a:p xmlns:a="http://schemas.openxmlformats.org/drawingml/2006/main">
-            <a:pPr>
-              <a:defRPr sz="5700" b="1">
+                <a16:creationId xmlns:a16="http://schemas.microsoft.com/office/drawing/2014/main" id="{CD5ED0DA-B9CF-4DB1-B441-1C45D5AAC133}"/>
+              </a:ext>
+            </a:extLst>
+          </p:cNvPr>
+          <p:cNvSpPr>
+            <a:spLocks xmlns:a="http://schemas.openxmlformats.org/drawingml/2006/main" noGrp="1"/>
+          </p:cNvSpPr>
+          <p:nvPr/>
+        </p:nvSpPr>
+        <p:spPr>
+          <a:xfrm xmlns:a="http://schemas.openxmlformats.org/drawingml/2006/main">
+            <a:off x="723900" y="3733800"/>
+            <a:ext cx="4095750" cy="1352550"/>
+          </a:xfrm>
+          <a:prstGeom xmlns:a="http://schemas.openxmlformats.org/drawingml/2006/main" prst="roundRect">
+            <a:avLst>
+              <a:gd name="adj" fmla="val 5634"/>
+            </a:avLst>
+          </a:prstGeom>
+          <a:solidFill xmlns:a="http://schemas.openxmlformats.org/drawingml/2006/main">
+            <a:srgbClr val="F7F9FC"/>
+          </a:solidFill>
+          <a:ln xmlns:a="http://schemas.openxmlformats.org/drawingml/2006/main" w="9525">
+            <a:solidFill>
+              <a:srgbClr val="CBD5E1"/>
+            </a:solidFill>
+          </a:ln>
+        </p:spPr>
+      </p:sp>
+      <p:sp>
+        <p:nvSpPr>
+          <p:cNvPr id="9" name="">
+            <a:extLst xmlns:a="http://schemas.openxmlformats.org/drawingml/2006/main">
+              <a:ext uri="{FF2B5EF4-FFF2-40B4-BE49-F238E27FC236}">
+                <a16:creationId xmlns:a16="http://schemas.microsoft.com/office/drawing/2014/main" id="{16C6E642-B089-4543-A7F6-EAB7254E1F64}"/>
+              </a:ext>
+            </a:extLst>
+          </p:cNvPr>
+          <p:cNvSpPr>
+            <a:spLocks xmlns:a="http://schemas.openxmlformats.org/drawingml/2006/main" noGrp="1"/>
+          </p:cNvSpPr>
+          <p:nvPr/>
+        </p:nvSpPr>
+        <p:spPr>
+          <a:xfrm xmlns:a="http://schemas.openxmlformats.org/drawingml/2006/main">
+            <a:off x="723900" y="3733800"/>
+            <a:ext cx="4095750" cy="47625"/>
+          </a:xfrm>
+          <a:prstGeom xmlns:a="http://schemas.openxmlformats.org/drawingml/2006/main" prst="rect">
+            <a:avLst/>
+          </a:prstGeom>
+          <a:solidFill xmlns:a="http://schemas.openxmlformats.org/drawingml/2006/main">
+            <a:srgbClr val="8190A3"/>
+          </a:solidFill>
+          <a:ln xmlns:a="http://schemas.openxmlformats.org/drawingml/2006/main" w="0">
+            <a:noFill/>
+          </a:ln>
+        </p:spPr>
+      </p:sp>
+      <p:sp>
+        <p:nvSpPr>
+          <p:cNvPr id="10" name="">
+            <a:extLst xmlns:a="http://schemas.openxmlformats.org/drawingml/2006/main">
+              <a:ext uri="{FF2B5EF4-FFF2-40B4-BE49-F238E27FC236}">
+                <a16:creationId xmlns:a16="http://schemas.microsoft.com/office/drawing/2014/main" id="{416F626D-6E3C-4243-97A6-51E5CC6D7D3B}"/>
+              </a:ext>
+            </a:extLst>
+          </p:cNvPr>
+          <p:cNvSpPr>
+            <a:spLocks xmlns:a="http://schemas.openxmlformats.org/drawingml/2006/main" noGrp="1"/>
+          </p:cNvSpPr>
+          <p:nvPr/>
+        </p:nvSpPr>
+        <p:spPr>
+          <a:xfrm xmlns:a="http://schemas.openxmlformats.org/drawingml/2006/main">
+            <a:off x="933450" y="3962400"/>
+            <a:ext cx="2095500" cy="209550"/>
+          </a:xfrm>
+          <a:prstGeom xmlns:a="http://schemas.openxmlformats.org/drawingml/2006/main" prst="rect">
+            <a:avLst/>
+          </a:prstGeom>
+          <a:noFill xmlns:a="http://schemas.openxmlformats.org/drawingml/2006/main"/>
+          <a:ln xmlns:a="http://schemas.openxmlformats.org/drawingml/2006/main" w="0">
+            <a:noFill/>
+          </a:ln>
+        </p:spPr>
+        <p:txBody>
+          <a:bodyPr xmlns:a="http://schemas.openxmlformats.org/drawingml/2006/main">
+            <a:normAutofit fontScale="86111"/>
+          </a:bodyPr>
+          <a:lstStyle xmlns:a="http://schemas.openxmlformats.org/drawingml/2006/main"/>
+          <a:p xmlns:a="http://schemas.openxmlformats.org/drawingml/2006/main">
+            <a:pPr>
+              <a:defRPr sz="900" b="1">
+                <a:solidFill>
+                  <a:srgbClr val="627288"/>
+                </a:solidFill>
+                <a:latin typeface="Bitstream Charter"/>
+                <a:ea typeface="Bitstream Charter"/>
+                <a:cs typeface="Bitstream Charter"/>
+              </a:defRPr>
+            </a:pPr>
+            <a:r>
+              <a:rPr sz="900" b="1">
+                <a:solidFill>
+                  <a:srgbClr val="627288"/>
+                </a:solidFill>
+                <a:latin typeface="Bitstream Charter"/>
+                <a:ea typeface="Bitstream Charter"/>
+                <a:cs typeface="Bitstream Charter"/>
+              </a:rPr>
+              <a:t>OLDER GUIDANCE</a:t>
+            </a:r>
+          </a:p>
+        </p:txBody>
+      </p:sp>
+      <p:sp>
+        <p:nvSpPr>
+          <p:cNvPr id="11" name="">
+            <a:extLst xmlns:a="http://schemas.openxmlformats.org/drawingml/2006/main">
+              <a:ext uri="{FF2B5EF4-FFF2-40B4-BE49-F238E27FC236}">
+                <a16:creationId xmlns:a16="http://schemas.microsoft.com/office/drawing/2014/main" id="{27B3BF37-79A2-413D-9521-5E55D46A573D}"/>
+              </a:ext>
+            </a:extLst>
+          </p:cNvPr>
+          <p:cNvSpPr>
+            <a:spLocks xmlns:a="http://schemas.openxmlformats.org/drawingml/2006/main" noGrp="1"/>
+          </p:cNvSpPr>
+          <p:nvPr/>
+        </p:nvSpPr>
+        <p:spPr>
+          <a:xfrm xmlns:a="http://schemas.openxmlformats.org/drawingml/2006/main">
+            <a:off x="933450" y="4248150"/>
+            <a:ext cx="3238500" cy="428625"/>
+          </a:xfrm>
+          <a:prstGeom xmlns:a="http://schemas.openxmlformats.org/drawingml/2006/main" prst="rect">
+            <a:avLst/>
+          </a:prstGeom>
+          <a:noFill xmlns:a="http://schemas.openxmlformats.org/drawingml/2006/main"/>
+          <a:ln xmlns:a="http://schemas.openxmlformats.org/drawingml/2006/main" w="0">
+            <a:noFill/>
+          </a:ln>
+        </p:spPr>
+        <p:txBody>
+          <a:bodyPr xmlns:a="http://schemas.openxmlformats.org/drawingml/2006/main">
+            <a:normAutofit fontScale="95161"/>
+          </a:bodyPr>
+          <a:lstStyle xmlns:a="http://schemas.openxmlformats.org/drawingml/2006/main"/>
+          <a:p xmlns:a="http://schemas.openxmlformats.org/drawingml/2006/main">
+            <a:pPr>
+              <a:defRPr sz="2325" b="1">
                 <a:solidFill>
                   <a:srgbClr val="102C55"/>
                 </a:solidFill>
@@ -5410,7 +5531,7 @@
               </a:defRPr>
             </a:pPr>
             <a:r>
-              <a:rPr sz="5700" b="1">
+              <a:rPr sz="2325" b="1">
                 <a:solidFill>
                   <a:srgbClr val="102C55"/>
                 </a:solidFill>
@@ -5418,29 +5539,86 @@
                 <a:ea typeface="Bitstream Charter"/>
                 <a:cs typeface="Bitstream Charter"/>
               </a:rPr>
-              <a:t>50%</a:t>
-            </a:r>
-          </a:p>
-        </p:txBody>
-      </p:sp>
-      <p:sp>
-        <p:nvSpPr>
-          <p:cNvPr id="9" name="">
-            <a:extLst xmlns:a="http://schemas.openxmlformats.org/drawingml/2006/main">
-              <a:ext uri="{FF2B5EF4-FFF2-40B4-BE49-F238E27FC236}">
-                <a16:creationId xmlns:a16="http://schemas.microsoft.com/office/drawing/2014/main" id="{034F7D86-8C0C-49C4-A45B-C4ECC1EF18CC}"/>
-              </a:ext>
-            </a:extLst>
-          </p:cNvPr>
-          <p:cNvSpPr>
-            <a:spLocks xmlns:a="http://schemas.openxmlformats.org/drawingml/2006/main" noGrp="1"/>
-          </p:cNvSpPr>
-          <p:nvPr/>
-        </p:nvSpPr>
-        <p:spPr>
-          <a:xfrm xmlns:a="http://schemas.openxmlformats.org/drawingml/2006/main">
-            <a:off x="723900" y="4762500"/>
-            <a:ext cx="2857500" cy="323850"/>
+              <a:t>50% retention</a:t>
+            </a:r>
+          </a:p>
+        </p:txBody>
+      </p:sp>
+      <p:sp>
+        <p:nvSpPr>
+          <p:cNvPr id="12" name="">
+            <a:extLst xmlns:a="http://schemas.openxmlformats.org/drawingml/2006/main">
+              <a:ext uri="{FF2B5EF4-FFF2-40B4-BE49-F238E27FC236}">
+                <a16:creationId xmlns:a16="http://schemas.microsoft.com/office/drawing/2014/main" id="{0A266853-DE14-42A2-A780-683BB7EFA813}"/>
+              </a:ext>
+            </a:extLst>
+          </p:cNvPr>
+          <p:cNvSpPr>
+            <a:spLocks xmlns:a="http://schemas.openxmlformats.org/drawingml/2006/main" noGrp="1"/>
+          </p:cNvSpPr>
+          <p:nvPr/>
+        </p:nvSpPr>
+        <p:spPr>
+          <a:xfrm xmlns:a="http://schemas.openxmlformats.org/drawingml/2006/main">
+            <a:off x="933450" y="4762500"/>
+            <a:ext cx="2476500" cy="209550"/>
+          </a:xfrm>
+          <a:prstGeom xmlns:a="http://schemas.openxmlformats.org/drawingml/2006/main" prst="rect">
+            <a:avLst/>
+          </a:prstGeom>
+          <a:noFill xmlns:a="http://schemas.openxmlformats.org/drawingml/2006/main"/>
+          <a:ln xmlns:a="http://schemas.openxmlformats.org/drawingml/2006/main" w="0">
+            <a:noFill/>
+          </a:ln>
+        </p:spPr>
+        <p:txBody>
+          <a:bodyPr xmlns:a="http://schemas.openxmlformats.org/drawingml/2006/main">
+            <a:normAutofit fontScale="73809"/>
+          </a:bodyPr>
+          <a:lstStyle xmlns:a="http://schemas.openxmlformats.org/drawingml/2006/main"/>
+          <a:p xmlns:a="http://schemas.openxmlformats.org/drawingml/2006/main">
+            <a:pPr>
+              <a:defRPr sz="1050" b="1">
+                <a:solidFill>
+                  <a:srgbClr val="526177"/>
+                </a:solidFill>
+                <a:latin typeface="Bitstream Charter"/>
+                <a:ea typeface="Bitstream Charter"/>
+                <a:cs typeface="Bitstream Charter"/>
+              </a:defRPr>
+            </a:pPr>
+            <a:r>
+              <a:rPr sz="1050" b="1">
+                <a:solidFill>
+                  <a:srgbClr val="526177"/>
+                </a:solidFill>
+                <a:latin typeface="Bitstream Charter"/>
+                <a:ea typeface="Bitstream Charter"/>
+                <a:cs typeface="Bitstream Charter"/>
+              </a:rPr>
+              <a:t>2024 NBE FAQ</a:t>
+            </a:r>
+          </a:p>
+        </p:txBody>
+      </p:sp>
+      <p:sp>
+        <p:nvSpPr>
+          <p:cNvPr id="13" name="">
+            <a:extLst xmlns:a="http://schemas.openxmlformats.org/drawingml/2006/main">
+              <a:ext uri="{FF2B5EF4-FFF2-40B4-BE49-F238E27FC236}">
+                <a16:creationId xmlns:a16="http://schemas.microsoft.com/office/drawing/2014/main" id="{43C8CFB9-9D85-40AD-9F41-950AC136A358}"/>
+              </a:ext>
+            </a:extLst>
+          </p:cNvPr>
+          <p:cNvSpPr>
+            <a:spLocks xmlns:a="http://schemas.openxmlformats.org/drawingml/2006/main" noGrp="1"/>
+          </p:cNvSpPr>
+          <p:nvPr/>
+        </p:nvSpPr>
+        <p:spPr>
+          <a:xfrm xmlns:a="http://schemas.openxmlformats.org/drawingml/2006/main">
+            <a:off x="5010150" y="4171950"/>
+            <a:ext cx="762000" cy="571500"/>
           </a:xfrm>
           <a:prstGeom xmlns:a="http://schemas.openxmlformats.org/drawingml/2006/main" prst="rect">
             <a:avLst/>
@@ -5457,7 +5635,242 @@
           <a:lstStyle xmlns:a="http://schemas.openxmlformats.org/drawingml/2006/main"/>
           <a:p xmlns:a="http://schemas.openxmlformats.org/drawingml/2006/main">
             <a:pPr>
-              <a:defRPr sz="1350" b="1">
+              <a:defRPr sz="3000" b="1">
+                <a:solidFill>
+                  <a:srgbClr val="B8742A"/>
+                </a:solidFill>
+                <a:latin typeface="Bitstream Charter"/>
+                <a:ea typeface="Bitstream Charter"/>
+                <a:cs typeface="Bitstream Charter"/>
+              </a:defRPr>
+            </a:pPr>
+            <a:r>
+              <a:rPr sz="3000" b="1">
+                <a:solidFill>
+                  <a:srgbClr val="B8742A"/>
+                </a:solidFill>
+                <a:latin typeface="Bitstream Charter"/>
+                <a:ea typeface="Bitstream Charter"/>
+                <a:cs typeface="Bitstream Charter"/>
+              </a:rPr>
+              <a:t>→</a:t>
+            </a:r>
+          </a:p>
+        </p:txBody>
+      </p:sp>
+      <p:sp>
+        <p:nvSpPr>
+          <p:cNvPr id="14" name="">
+            <a:extLst xmlns:a="http://schemas.openxmlformats.org/drawingml/2006/main">
+              <a:ext uri="{FF2B5EF4-FFF2-40B4-BE49-F238E27FC236}">
+                <a16:creationId xmlns:a16="http://schemas.microsoft.com/office/drawing/2014/main" id="{CB7FB495-3140-4097-9843-E9C10A98C93B}"/>
+              </a:ext>
+            </a:extLst>
+          </p:cNvPr>
+          <p:cNvSpPr>
+            <a:spLocks xmlns:a="http://schemas.openxmlformats.org/drawingml/2006/main" noGrp="1"/>
+          </p:cNvSpPr>
+          <p:nvPr/>
+        </p:nvSpPr>
+        <p:spPr>
+          <a:xfrm xmlns:a="http://schemas.openxmlformats.org/drawingml/2006/main">
+            <a:off x="5981700" y="3733800"/>
+            <a:ext cx="4533900" cy="1352550"/>
+          </a:xfrm>
+          <a:prstGeom xmlns:a="http://schemas.openxmlformats.org/drawingml/2006/main" prst="roundRect">
+            <a:avLst>
+              <a:gd name="adj" fmla="val 5634"/>
+            </a:avLst>
+          </a:prstGeom>
+          <a:solidFill xmlns:a="http://schemas.openxmlformats.org/drawingml/2006/main">
+            <a:srgbClr val="FFF7ED"/>
+          </a:solidFill>
+          <a:ln xmlns:a="http://schemas.openxmlformats.org/drawingml/2006/main" w="9525">
+            <a:solidFill>
+              <a:srgbClr val="E7C79F"/>
+            </a:solidFill>
+          </a:ln>
+        </p:spPr>
+      </p:sp>
+      <p:sp>
+        <p:nvSpPr>
+          <p:cNvPr id="15" name="">
+            <a:extLst xmlns:a="http://schemas.openxmlformats.org/drawingml/2006/main">
+              <a:ext uri="{FF2B5EF4-FFF2-40B4-BE49-F238E27FC236}">
+                <a16:creationId xmlns:a16="http://schemas.microsoft.com/office/drawing/2014/main" id="{87EDF4AC-3BB9-4868-80BA-F2D6F3ACD223}"/>
+              </a:ext>
+            </a:extLst>
+          </p:cNvPr>
+          <p:cNvSpPr>
+            <a:spLocks xmlns:a="http://schemas.openxmlformats.org/drawingml/2006/main" noGrp="1"/>
+          </p:cNvSpPr>
+          <p:nvPr/>
+        </p:nvSpPr>
+        <p:spPr>
+          <a:xfrm xmlns:a="http://schemas.openxmlformats.org/drawingml/2006/main">
+            <a:off x="5981700" y="3733800"/>
+            <a:ext cx="4533900" cy="47625"/>
+          </a:xfrm>
+          <a:prstGeom xmlns:a="http://schemas.openxmlformats.org/drawingml/2006/main" prst="rect">
+            <a:avLst/>
+          </a:prstGeom>
+          <a:solidFill xmlns:a="http://schemas.openxmlformats.org/drawingml/2006/main">
+            <a:srgbClr val="B8742A"/>
+          </a:solidFill>
+          <a:ln xmlns:a="http://schemas.openxmlformats.org/drawingml/2006/main" w="0">
+            <a:noFill/>
+          </a:ln>
+        </p:spPr>
+      </p:sp>
+      <p:sp>
+        <p:nvSpPr>
+          <p:cNvPr id="16" name="">
+            <a:extLst xmlns:a="http://schemas.openxmlformats.org/drawingml/2006/main">
+              <a:ext uri="{FF2B5EF4-FFF2-40B4-BE49-F238E27FC236}">
+                <a16:creationId xmlns:a16="http://schemas.microsoft.com/office/drawing/2014/main" id="{1269D243-AC89-43AA-8C97-FAE307722CD8}"/>
+              </a:ext>
+            </a:extLst>
+          </p:cNvPr>
+          <p:cNvSpPr>
+            <a:spLocks xmlns:a="http://schemas.openxmlformats.org/drawingml/2006/main" noGrp="1"/>
+          </p:cNvSpPr>
+          <p:nvPr/>
+        </p:nvSpPr>
+        <p:spPr>
+          <a:xfrm xmlns:a="http://schemas.openxmlformats.org/drawingml/2006/main">
+            <a:off x="6191250" y="3962400"/>
+            <a:ext cx="3714750" cy="209550"/>
+          </a:xfrm>
+          <a:prstGeom xmlns:a="http://schemas.openxmlformats.org/drawingml/2006/main" prst="rect">
+            <a:avLst/>
+          </a:prstGeom>
+          <a:noFill xmlns:a="http://schemas.openxmlformats.org/drawingml/2006/main"/>
+          <a:ln xmlns:a="http://schemas.openxmlformats.org/drawingml/2006/main" w="0">
+            <a:noFill/>
+          </a:ln>
+        </p:spPr>
+        <p:txBody>
+          <a:bodyPr xmlns:a="http://schemas.openxmlformats.org/drawingml/2006/main">
+            <a:normAutofit fontScale="86111"/>
+          </a:bodyPr>
+          <a:lstStyle xmlns:a="http://schemas.openxmlformats.org/drawingml/2006/main"/>
+          <a:p xmlns:a="http://schemas.openxmlformats.org/drawingml/2006/main">
+            <a:pPr>
+              <a:defRPr sz="900" b="1">
+                <a:solidFill>
+                  <a:srgbClr val="B8742A"/>
+                </a:solidFill>
+                <a:latin typeface="Bitstream Charter"/>
+                <a:ea typeface="Bitstream Charter"/>
+                <a:cs typeface="Bitstream Charter"/>
+              </a:defRPr>
+            </a:pPr>
+            <a:r>
+              <a:rPr sz="900" b="1">
+                <a:solidFill>
+                  <a:srgbClr val="B8742A"/>
+                </a:solidFill>
+                <a:latin typeface="Bitstream Charter"/>
+                <a:ea typeface="Bitstream Charter"/>
+                <a:cs typeface="Bitstream Charter"/>
+              </a:rPr>
+              <a:t>CURRENT SERVICE-EXPORTER GUIDANCE</a:t>
+            </a:r>
+          </a:p>
+        </p:txBody>
+      </p:sp>
+      <p:sp>
+        <p:nvSpPr>
+          <p:cNvPr id="17" name="">
+            <a:extLst xmlns:a="http://schemas.openxmlformats.org/drawingml/2006/main">
+              <a:ext uri="{FF2B5EF4-FFF2-40B4-BE49-F238E27FC236}">
+                <a16:creationId xmlns:a16="http://schemas.microsoft.com/office/drawing/2014/main" id="{891C989D-F4E2-409B-AF0A-0B993679941B}"/>
+              </a:ext>
+            </a:extLst>
+          </p:cNvPr>
+          <p:cNvSpPr>
+            <a:spLocks xmlns:a="http://schemas.openxmlformats.org/drawingml/2006/main" noGrp="1"/>
+          </p:cNvSpPr>
+          <p:nvPr/>
+        </p:nvSpPr>
+        <p:spPr>
+          <a:xfrm xmlns:a="http://schemas.openxmlformats.org/drawingml/2006/main">
+            <a:off x="6191250" y="4248150"/>
+            <a:ext cx="3714750" cy="428625"/>
+          </a:xfrm>
+          <a:prstGeom xmlns:a="http://schemas.openxmlformats.org/drawingml/2006/main" prst="rect">
+            <a:avLst/>
+          </a:prstGeom>
+          <a:noFill xmlns:a="http://schemas.openxmlformats.org/drawingml/2006/main"/>
+          <a:ln xmlns:a="http://schemas.openxmlformats.org/drawingml/2006/main" w="0">
+            <a:noFill/>
+          </a:ln>
+        </p:spPr>
+        <p:txBody>
+          <a:bodyPr xmlns:a="http://schemas.openxmlformats.org/drawingml/2006/main">
+            <a:normAutofit fontScale="95161"/>
+          </a:bodyPr>
+          <a:lstStyle xmlns:a="http://schemas.openxmlformats.org/drawingml/2006/main"/>
+          <a:p xmlns:a="http://schemas.openxmlformats.org/drawingml/2006/main">
+            <a:pPr>
+              <a:defRPr sz="2325" b="1">
+                <a:solidFill>
+                  <a:srgbClr val="102C55"/>
+                </a:solidFill>
+                <a:latin typeface="Bitstream Charter"/>
+                <a:ea typeface="Bitstream Charter"/>
+                <a:cs typeface="Bitstream Charter"/>
+              </a:defRPr>
+            </a:pPr>
+            <a:r>
+              <a:rPr sz="2325" b="1">
+                <a:solidFill>
+                  <a:srgbClr val="102C55"/>
+                </a:solidFill>
+                <a:latin typeface="Bitstream Charter"/>
+                <a:ea typeface="Bitstream Charter"/>
+                <a:cs typeface="Bitstream Charter"/>
+              </a:rPr>
+              <a:t>100% retention</a:t>
+            </a:r>
+          </a:p>
+        </p:txBody>
+      </p:sp>
+      <p:sp>
+        <p:nvSpPr>
+          <p:cNvPr id="18" name="">
+            <a:extLst xmlns:a="http://schemas.openxmlformats.org/drawingml/2006/main">
+              <a:ext uri="{FF2B5EF4-FFF2-40B4-BE49-F238E27FC236}">
+                <a16:creationId xmlns:a16="http://schemas.microsoft.com/office/drawing/2014/main" id="{99769A2C-C8B4-4431-ABF9-B8B36A4F336D}"/>
+              </a:ext>
+            </a:extLst>
+          </p:cNvPr>
+          <p:cNvSpPr>
+            <a:spLocks xmlns:a="http://schemas.openxmlformats.org/drawingml/2006/main" noGrp="1"/>
+          </p:cNvSpPr>
+          <p:nvPr/>
+        </p:nvSpPr>
+        <p:spPr>
+          <a:xfrm xmlns:a="http://schemas.openxmlformats.org/drawingml/2006/main">
+            <a:off x="6191250" y="4762500"/>
+            <a:ext cx="2857500" cy="209550"/>
+          </a:xfrm>
+          <a:prstGeom xmlns:a="http://schemas.openxmlformats.org/drawingml/2006/main" prst="rect">
+            <a:avLst/>
+          </a:prstGeom>
+          <a:noFill xmlns:a="http://schemas.openxmlformats.org/drawingml/2006/main"/>
+          <a:ln xmlns:a="http://schemas.openxmlformats.org/drawingml/2006/main" w="0">
+            <a:noFill/>
+          </a:ln>
+        </p:spPr>
+        <p:txBody>
+          <a:bodyPr xmlns:a="http://schemas.openxmlformats.org/drawingml/2006/main">
+            <a:normAutofit fontScale="73809"/>
+          </a:bodyPr>
+          <a:lstStyle xmlns:a="http://schemas.openxmlformats.org/drawingml/2006/main"/>
+          <a:p xmlns:a="http://schemas.openxmlformats.org/drawingml/2006/main">
+            <a:pPr>
+              <a:defRPr sz="1050" b="1">
                 <a:solidFill>
                   <a:srgbClr val="526177"/>
                 </a:solidFill>
@@ -5467,7 +5880,7 @@
               </a:defRPr>
             </a:pPr>
             <a:r>
-              <a:rPr sz="1350" b="1">
+              <a:rPr sz="1050" b="1">
                 <a:solidFill>
                   <a:srgbClr val="526177"/>
                 </a:solidFill>
@@ -5475,86 +5888,29 @@
                 <a:ea typeface="Bitstream Charter"/>
                 <a:cs typeface="Bitstream Charter"/>
               </a:rPr>
-              <a:t>Older Published Position</a:t>
-            </a:r>
-          </a:p>
-        </p:txBody>
-      </p:sp>
-      <p:sp>
-        <p:nvSpPr>
-          <p:cNvPr id="10" name="">
-            <a:extLst xmlns:a="http://schemas.openxmlformats.org/drawingml/2006/main">
-              <a:ext uri="{FF2B5EF4-FFF2-40B4-BE49-F238E27FC236}">
-                <a16:creationId xmlns:a16="http://schemas.microsoft.com/office/drawing/2014/main" id="{EEC974B7-4FB4-4496-BC3B-58D54BCA9042}"/>
-              </a:ext>
-            </a:extLst>
-          </p:cNvPr>
-          <p:cNvSpPr>
-            <a:spLocks xmlns:a="http://schemas.openxmlformats.org/drawingml/2006/main" noGrp="1"/>
-          </p:cNvSpPr>
-          <p:nvPr/>
-        </p:nvSpPr>
-        <p:spPr>
-          <a:xfrm xmlns:a="http://schemas.openxmlformats.org/drawingml/2006/main">
-            <a:off x="5334000" y="3905250"/>
-            <a:ext cx="2857500" cy="857250"/>
-          </a:xfrm>
-          <a:prstGeom xmlns:a="http://schemas.openxmlformats.org/drawingml/2006/main" prst="rect">
-            <a:avLst/>
-          </a:prstGeom>
-          <a:noFill xmlns:a="http://schemas.openxmlformats.org/drawingml/2006/main"/>
-          <a:ln xmlns:a="http://schemas.openxmlformats.org/drawingml/2006/main" w="0">
-            <a:noFill/>
-          </a:ln>
-        </p:spPr>
-        <p:txBody>
-          <a:bodyPr xmlns:a="http://schemas.openxmlformats.org/drawingml/2006/main">
-            <a:normAutofit fontScale="88158"/>
-          </a:bodyPr>
-          <a:lstStyle xmlns:a="http://schemas.openxmlformats.org/drawingml/2006/main"/>
-          <a:p xmlns:a="http://schemas.openxmlformats.org/drawingml/2006/main">
-            <a:pPr>
-              <a:defRPr sz="5700" b="1">
-                <a:solidFill>
-                  <a:srgbClr val="B8742A"/>
-                </a:solidFill>
-                <a:latin typeface="Bitstream Charter"/>
-                <a:ea typeface="Bitstream Charter"/>
-                <a:cs typeface="Bitstream Charter"/>
-              </a:defRPr>
-            </a:pPr>
-            <a:r>
-              <a:rPr sz="5700" b="1">
-                <a:solidFill>
-                  <a:srgbClr val="B8742A"/>
-                </a:solidFill>
-                <a:latin typeface="Bitstream Charter"/>
-                <a:ea typeface="Bitstream Charter"/>
-                <a:cs typeface="Bitstream Charter"/>
-              </a:rPr>
-              <a:t>100%</a:t>
-            </a:r>
-          </a:p>
-        </p:txBody>
-      </p:sp>
-      <p:sp>
-        <p:nvSpPr>
-          <p:cNvPr id="11" name="">
-            <a:extLst xmlns:a="http://schemas.openxmlformats.org/drawingml/2006/main">
-              <a:ext uri="{FF2B5EF4-FFF2-40B4-BE49-F238E27FC236}">
-                <a16:creationId xmlns:a16="http://schemas.microsoft.com/office/drawing/2014/main" id="{8CB80BF3-FA72-4D80-BE65-C973F49C65BD}"/>
-              </a:ext>
-            </a:extLst>
-          </p:cNvPr>
-          <p:cNvSpPr>
-            <a:spLocks xmlns:a="http://schemas.openxmlformats.org/drawingml/2006/main" noGrp="1"/>
-          </p:cNvSpPr>
-          <p:nvPr/>
-        </p:nvSpPr>
-        <p:spPr>
-          <a:xfrm xmlns:a="http://schemas.openxmlformats.org/drawingml/2006/main">
-            <a:off x="5334000" y="4762500"/>
-            <a:ext cx="4000500" cy="323850"/>
+              <a:t>2026 NBE notice</a:t>
+            </a:r>
+          </a:p>
+        </p:txBody>
+      </p:sp>
+      <p:sp>
+        <p:nvSpPr>
+          <p:cNvPr id="19" name="">
+            <a:extLst xmlns:a="http://schemas.openxmlformats.org/drawingml/2006/main">
+              <a:ext uri="{FF2B5EF4-FFF2-40B4-BE49-F238E27FC236}">
+                <a16:creationId xmlns:a16="http://schemas.microsoft.com/office/drawing/2014/main" id="{FDEFB7C1-5C29-42C9-BF08-706C25438172}"/>
+              </a:ext>
+            </a:extLst>
+          </p:cNvPr>
+          <p:cNvSpPr>
+            <a:spLocks xmlns:a="http://schemas.openxmlformats.org/drawingml/2006/main" noGrp="1"/>
+          </p:cNvSpPr>
+          <p:nvPr/>
+        </p:nvSpPr>
+        <p:spPr>
+          <a:xfrm xmlns:a="http://schemas.openxmlformats.org/drawingml/2006/main">
+            <a:off x="723900" y="5286375"/>
+            <a:ext cx="8763000" cy="266700"/>
           </a:xfrm>
           <a:prstGeom xmlns:a="http://schemas.openxmlformats.org/drawingml/2006/main" prst="rect">
             <a:avLst/>
@@ -5571,25 +5927,25 @@
           <a:lstStyle xmlns:a="http://schemas.openxmlformats.org/drawingml/2006/main"/>
           <a:p xmlns:a="http://schemas.openxmlformats.org/drawingml/2006/main">
             <a:pPr>
-              <a:defRPr sz="1350" b="1">
-                <a:solidFill>
-                  <a:srgbClr val="526177"/>
-                </a:solidFill>
-                <a:latin typeface="Bitstream Charter"/>
-                <a:ea typeface="Bitstream Charter"/>
-                <a:cs typeface="Bitstream Charter"/>
-              </a:defRPr>
-            </a:pPr>
-            <a:r>
-              <a:rPr sz="1350" b="1">
-                <a:solidFill>
-                  <a:srgbClr val="526177"/>
-                </a:solidFill>
-                <a:latin typeface="Bitstream Charter"/>
-                <a:ea typeface="Bitstream Charter"/>
-                <a:cs typeface="Bitstream Charter"/>
-              </a:rPr>
-              <a:t>Current Service-Exporter Position</a:t>
+              <a:defRPr sz="1125" b="1">
+                <a:solidFill>
+                  <a:srgbClr val="20755A"/>
+                </a:solidFill>
+                <a:latin typeface="Bitstream Charter"/>
+                <a:ea typeface="Bitstream Charter"/>
+                <a:cs typeface="Bitstream Charter"/>
+              </a:defRPr>
+            </a:pPr>
+            <a:r>
+              <a:rPr sz="1125" b="1">
+                <a:solidFill>
+                  <a:srgbClr val="20755A"/>
+                </a:solidFill>
+                <a:latin typeface="Bitstream Charter"/>
+                <a:ea typeface="Bitstream Charter"/>
+                <a:cs typeface="Bitstream Charter"/>
+              </a:rPr>
+              <a:t>Applicability depends on the transaction date and audience.</a:t>
             </a:r>
           </a:p>
         </p:txBody>
@@ -5597,7 +5953,7 @@
     </p:spTree>
     <p:extLst>
       <p:ext uri="{BB962C8B-B14F-4D97-AF65-F5344CB8AC3E}">
-        <p14:creationId xmlns:p14="http://schemas.microsoft.com/office/powerpoint/2010/main" val="336489139"/>
+        <p14:creationId xmlns:p14="http://schemas.microsoft.com/office/powerpoint/2010/main" val="1927261492"/>
       </p:ext>
     </p:extLst>
   </p:cSld>
@@ -5628,7 +5984,7 @@
           <p:cNvPr id="20" name="">
             <a:extLst xmlns:a="http://schemas.openxmlformats.org/drawingml/2006/main">
               <a:ext uri="{FF2B5EF4-FFF2-40B4-BE49-F238E27FC236}">
-                <a16:creationId xmlns:a16="http://schemas.microsoft.com/office/drawing/2014/main" id="{30CA72CE-F013-4EFF-96BE-F6894126073C}"/>
+                <a16:creationId xmlns:a16="http://schemas.microsoft.com/office/drawing/2014/main" id="{950602F1-AD10-41C5-A5E1-F71EBC02A359}"/>
               </a:ext>
             </a:extLst>
           </p:cNvPr>
@@ -5658,7 +6014,7 @@
           <p:cNvPr id="2" name="">
             <a:extLst xmlns:a="http://schemas.openxmlformats.org/drawingml/2006/main">
               <a:ext uri="{FF2B5EF4-FFF2-40B4-BE49-F238E27FC236}">
-                <a16:creationId xmlns:a16="http://schemas.microsoft.com/office/drawing/2014/main" id="{2E309D77-4EBE-4804-9CD2-4E5D5A263D08}"/>
+                <a16:creationId xmlns:a16="http://schemas.microsoft.com/office/drawing/2014/main" id="{382DF835-6F29-448C-9917-031E164E8840}"/>
               </a:ext>
             </a:extLst>
           </p:cNvPr>
@@ -5715,7 +6071,7 @@
           <p:cNvPr id="3" name="">
             <a:extLst xmlns:a="http://schemas.openxmlformats.org/drawingml/2006/main">
               <a:ext uri="{FF2B5EF4-FFF2-40B4-BE49-F238E27FC236}">
-                <a16:creationId xmlns:a16="http://schemas.microsoft.com/office/drawing/2014/main" id="{24D3E9CE-F54A-4DBF-87F4-75E8164585C7}"/>
+                <a16:creationId xmlns:a16="http://schemas.microsoft.com/office/drawing/2014/main" id="{4664A7ED-2A39-4115-985C-DDEB1C75F805}"/>
               </a:ext>
             </a:extLst>
           </p:cNvPr>
@@ -5772,7 +6128,7 @@
           <p:cNvPr id="4" name="">
             <a:extLst xmlns:a="http://schemas.openxmlformats.org/drawingml/2006/main">
               <a:ext uri="{FF2B5EF4-FFF2-40B4-BE49-F238E27FC236}">
-                <a16:creationId xmlns:a16="http://schemas.microsoft.com/office/drawing/2014/main" id="{E4860157-7B07-4F82-BAF9-E2064F8C2885}"/>
+                <a16:creationId xmlns:a16="http://schemas.microsoft.com/office/drawing/2014/main" id="{8A675967-2ADE-4995-B12E-FFE2639F492D}"/>
               </a:ext>
             </a:extLst>
           </p:cNvPr>
@@ -5829,7 +6185,7 @@
           <p:cNvPr id="5" name="">
             <a:extLst xmlns:a="http://schemas.openxmlformats.org/drawingml/2006/main">
               <a:ext uri="{FF2B5EF4-FFF2-40B4-BE49-F238E27FC236}">
-                <a16:creationId xmlns:a16="http://schemas.microsoft.com/office/drawing/2014/main" id="{937B8404-F24A-4711-B8F9-F99CA3702CF1}"/>
+                <a16:creationId xmlns:a16="http://schemas.microsoft.com/office/drawing/2014/main" id="{90F6DC38-1C83-4472-85DF-0C16268ED088}"/>
               </a:ext>
             </a:extLst>
           </p:cNvPr>
@@ -5886,7 +6242,7 @@
           <p:cNvPr id="6" name="">
             <a:extLst xmlns:a="http://schemas.openxmlformats.org/drawingml/2006/main">
               <a:ext uri="{FF2B5EF4-FFF2-40B4-BE49-F238E27FC236}">
-                <a16:creationId xmlns:a16="http://schemas.microsoft.com/office/drawing/2014/main" id="{25E47093-0D54-4EEB-A686-74D068603F83}"/>
+                <a16:creationId xmlns:a16="http://schemas.microsoft.com/office/drawing/2014/main" id="{43D3729E-BED4-4FB7-B552-375648B087EE}"/>
               </a:ext>
             </a:extLst>
           </p:cNvPr>
@@ -5943,7 +6299,7 @@
           <p:cNvPr id="7" name="">
             <a:extLst xmlns:a="http://schemas.openxmlformats.org/drawingml/2006/main">
               <a:ext uri="{FF2B5EF4-FFF2-40B4-BE49-F238E27FC236}">
-                <a16:creationId xmlns:a16="http://schemas.microsoft.com/office/drawing/2014/main" id="{D2568F44-AF8E-4B47-9BCC-5727B44870ED}"/>
+                <a16:creationId xmlns:a16="http://schemas.microsoft.com/office/drawing/2014/main" id="{B5491C44-AC0F-4FDC-A650-2E5417C04FA5}"/>
               </a:ext>
             </a:extLst>
           </p:cNvPr>
@@ -6000,7 +6356,7 @@
           <p:cNvPr id="8" name="">
             <a:extLst xmlns:a="http://schemas.openxmlformats.org/drawingml/2006/main">
               <a:ext uri="{FF2B5EF4-FFF2-40B4-BE49-F238E27FC236}">
-                <a16:creationId xmlns:a16="http://schemas.microsoft.com/office/drawing/2014/main" id="{80996D53-1E7E-41B1-8972-F84D894DBDC0}"/>
+                <a16:creationId xmlns:a16="http://schemas.microsoft.com/office/drawing/2014/main" id="{263FD77E-5F4F-4131-8D9A-C2B94E027078}"/>
               </a:ext>
             </a:extLst>
           </p:cNvPr>
@@ -6032,7 +6388,7 @@
           <p:cNvPr id="9" name="">
             <a:extLst xmlns:a="http://schemas.openxmlformats.org/drawingml/2006/main">
               <a:ext uri="{FF2B5EF4-FFF2-40B4-BE49-F238E27FC236}">
-                <a16:creationId xmlns:a16="http://schemas.microsoft.com/office/drawing/2014/main" id="{2F652181-31DF-4336-8275-F0B2A87518FD}"/>
+                <a16:creationId xmlns:a16="http://schemas.microsoft.com/office/drawing/2014/main" id="{F3788FFA-80CA-4DB2-A348-3B39311EDDB2}"/>
               </a:ext>
             </a:extLst>
           </p:cNvPr>
@@ -6089,7 +6445,7 @@
           <p:cNvPr id="10" name="">
             <a:extLst xmlns:a="http://schemas.openxmlformats.org/drawingml/2006/main">
               <a:ext uri="{FF2B5EF4-FFF2-40B4-BE49-F238E27FC236}">
-                <a16:creationId xmlns:a16="http://schemas.microsoft.com/office/drawing/2014/main" id="{17A42D8F-0F67-4BCB-ADF1-13CBF4005A34}"/>
+                <a16:creationId xmlns:a16="http://schemas.microsoft.com/office/drawing/2014/main" id="{8C820F6B-6B4C-4847-B614-F1B02C06054E}"/>
               </a:ext>
             </a:extLst>
           </p:cNvPr>
@@ -6146,7 +6502,7 @@
           <p:cNvPr id="11" name="">
             <a:extLst xmlns:a="http://schemas.openxmlformats.org/drawingml/2006/main">
               <a:ext uri="{FF2B5EF4-FFF2-40B4-BE49-F238E27FC236}">
-                <a16:creationId xmlns:a16="http://schemas.microsoft.com/office/drawing/2014/main" id="{8C31BAC2-401A-4A31-A6D5-9C0486A15B2A}"/>
+                <a16:creationId xmlns:a16="http://schemas.microsoft.com/office/drawing/2014/main" id="{7E139C3B-6250-4588-AF2F-BF4D1F9C9A6B}"/>
               </a:ext>
             </a:extLst>
           </p:cNvPr>
@@ -6178,7 +6534,7 @@
           <p:cNvPr id="12" name="">
             <a:extLst xmlns:a="http://schemas.openxmlformats.org/drawingml/2006/main">
               <a:ext uri="{FF2B5EF4-FFF2-40B4-BE49-F238E27FC236}">
-                <a16:creationId xmlns:a16="http://schemas.microsoft.com/office/drawing/2014/main" id="{15FCA2CF-F159-4FB9-BCD0-82B8B54E21DE}"/>
+                <a16:creationId xmlns:a16="http://schemas.microsoft.com/office/drawing/2014/main" id="{86D8CF07-EB7B-4F6B-9C7E-A50D5F501932}"/>
               </a:ext>
             </a:extLst>
           </p:cNvPr>
@@ -6235,7 +6591,7 @@
           <p:cNvPr id="13" name="">
             <a:extLst xmlns:a="http://schemas.openxmlformats.org/drawingml/2006/main">
               <a:ext uri="{FF2B5EF4-FFF2-40B4-BE49-F238E27FC236}">
-                <a16:creationId xmlns:a16="http://schemas.microsoft.com/office/drawing/2014/main" id="{E4F28D60-D5C2-4676-99E2-918B5CEA0C6C}"/>
+                <a16:creationId xmlns:a16="http://schemas.microsoft.com/office/drawing/2014/main" id="{06B9D277-BA25-4DF8-AE0B-13D2FE458032}"/>
               </a:ext>
             </a:extLst>
           </p:cNvPr>
@@ -6292,7 +6648,7 @@
           <p:cNvPr id="14" name="">
             <a:extLst xmlns:a="http://schemas.openxmlformats.org/drawingml/2006/main">
               <a:ext uri="{FF2B5EF4-FFF2-40B4-BE49-F238E27FC236}">
-                <a16:creationId xmlns:a16="http://schemas.microsoft.com/office/drawing/2014/main" id="{49F2F351-9892-4D59-8C78-6CB6E57DB02A}"/>
+                <a16:creationId xmlns:a16="http://schemas.microsoft.com/office/drawing/2014/main" id="{3988AB4E-4D6B-4000-9BD3-99B96D9CC0CD}"/>
               </a:ext>
             </a:extLst>
           </p:cNvPr>
@@ -6324,7 +6680,7 @@
           <p:cNvPr id="15" name="">
             <a:extLst xmlns:a="http://schemas.openxmlformats.org/drawingml/2006/main">
               <a:ext uri="{FF2B5EF4-FFF2-40B4-BE49-F238E27FC236}">
-                <a16:creationId xmlns:a16="http://schemas.microsoft.com/office/drawing/2014/main" id="{CE20AD51-8FC4-4EBE-9EB8-5C6A3B6286E6}"/>
+                <a16:creationId xmlns:a16="http://schemas.microsoft.com/office/drawing/2014/main" id="{B7A8BA42-CE7F-47CD-B713-0CA2515B228D}"/>
               </a:ext>
             </a:extLst>
           </p:cNvPr>
@@ -6381,7 +6737,7 @@
           <p:cNvPr id="16" name="">
             <a:extLst xmlns:a="http://schemas.openxmlformats.org/drawingml/2006/main">
               <a:ext uri="{FF2B5EF4-FFF2-40B4-BE49-F238E27FC236}">
-                <a16:creationId xmlns:a16="http://schemas.microsoft.com/office/drawing/2014/main" id="{F41CBB6C-DA77-4172-A55C-54701E386A6D}"/>
+                <a16:creationId xmlns:a16="http://schemas.microsoft.com/office/drawing/2014/main" id="{511A6215-A170-4896-9B16-F51AD96C383E}"/>
               </a:ext>
             </a:extLst>
           </p:cNvPr>
@@ -6438,7 +6794,7 @@
           <p:cNvPr id="17" name="">
             <a:extLst xmlns:a="http://schemas.openxmlformats.org/drawingml/2006/main">
               <a:ext uri="{FF2B5EF4-FFF2-40B4-BE49-F238E27FC236}">
-                <a16:creationId xmlns:a16="http://schemas.microsoft.com/office/drawing/2014/main" id="{8F2E104E-85B5-43DB-BD36-179231C0A1B3}"/>
+                <a16:creationId xmlns:a16="http://schemas.microsoft.com/office/drawing/2014/main" id="{6DD4CF24-9E9D-4656-B7F6-677E954F4CB7}"/>
               </a:ext>
             </a:extLst>
           </p:cNvPr>
@@ -6470,7 +6826,7 @@
           <p:cNvPr id="18" name="">
             <a:extLst xmlns:a="http://schemas.openxmlformats.org/drawingml/2006/main">
               <a:ext uri="{FF2B5EF4-FFF2-40B4-BE49-F238E27FC236}">
-                <a16:creationId xmlns:a16="http://schemas.microsoft.com/office/drawing/2014/main" id="{327CBEFD-A41C-456D-BF82-18DB3E1D7A4F}"/>
+                <a16:creationId xmlns:a16="http://schemas.microsoft.com/office/drawing/2014/main" id="{3A8C007A-9033-4B29-8F61-33177AD95DFB}"/>
               </a:ext>
             </a:extLst>
           </p:cNvPr>
@@ -6527,7 +6883,7 @@
           <p:cNvPr id="19" name="">
             <a:extLst xmlns:a="http://schemas.openxmlformats.org/drawingml/2006/main">
               <a:ext uri="{FF2B5EF4-FFF2-40B4-BE49-F238E27FC236}">
-                <a16:creationId xmlns:a16="http://schemas.microsoft.com/office/drawing/2014/main" id="{6C70F4EC-08B6-4C50-89FE-08ECD5F7E429}"/>
+                <a16:creationId xmlns:a16="http://schemas.microsoft.com/office/drawing/2014/main" id="{E0D586BD-87A3-45CB-9526-AACF9AB8266E}"/>
               </a:ext>
             </a:extLst>
           </p:cNvPr>
@@ -6582,7 +6938,7 @@
     </p:spTree>
     <p:extLst>
       <p:ext uri="{BB962C8B-B14F-4D97-AF65-F5344CB8AC3E}">
-        <p14:creationId xmlns:p14="http://schemas.microsoft.com/office/powerpoint/2010/main" val="482320580"/>
+        <p14:creationId xmlns:p14="http://schemas.microsoft.com/office/powerpoint/2010/main" val="376865046"/>
       </p:ext>
     </p:extLst>
   </p:cSld>
@@ -6610,10 +6966,10 @@
       </p:grpSpPr>
       <p:sp>
         <p:nvSpPr>
-          <p:cNvPr id="18" name="">
-            <a:extLst xmlns:a="http://schemas.openxmlformats.org/drawingml/2006/main">
-              <a:ext uri="{FF2B5EF4-FFF2-40B4-BE49-F238E27FC236}">
-                <a16:creationId xmlns:a16="http://schemas.microsoft.com/office/drawing/2014/main" id="{26BC6F18-A043-4C13-A5CB-609C49DFC1B0}"/>
+          <p:cNvPr id="23" name="">
+            <a:extLst xmlns:a="http://schemas.openxmlformats.org/drawingml/2006/main">
+              <a:ext uri="{FF2B5EF4-FFF2-40B4-BE49-F238E27FC236}">
+                <a16:creationId xmlns:a16="http://schemas.microsoft.com/office/drawing/2014/main" id="{CD01A588-282E-423C-9779-DE1421AC6F08}"/>
               </a:ext>
             </a:extLst>
           </p:cNvPr>
@@ -6643,7 +6999,7 @@
           <p:cNvPr id="2" name="">
             <a:extLst xmlns:a="http://schemas.openxmlformats.org/drawingml/2006/main">
               <a:ext uri="{FF2B5EF4-FFF2-40B4-BE49-F238E27FC236}">
-                <a16:creationId xmlns:a16="http://schemas.microsoft.com/office/drawing/2014/main" id="{478A0AF4-5F49-4BF7-884F-B1E1C6339438}"/>
+                <a16:creationId xmlns:a16="http://schemas.microsoft.com/office/drawing/2014/main" id="{B48F38A3-B2B5-47E4-A852-B162E3E46C7D}"/>
               </a:ext>
             </a:extLst>
           </p:cNvPr>
@@ -6700,7 +7056,7 @@
           <p:cNvPr id="3" name="">
             <a:extLst xmlns:a="http://schemas.openxmlformats.org/drawingml/2006/main">
               <a:ext uri="{FF2B5EF4-FFF2-40B4-BE49-F238E27FC236}">
-                <a16:creationId xmlns:a16="http://schemas.microsoft.com/office/drawing/2014/main" id="{D72F63A6-7CDC-4247-831C-5E10A11F94D3}"/>
+                <a16:creationId xmlns:a16="http://schemas.microsoft.com/office/drawing/2014/main" id="{B7C54153-85FC-475D-9C0D-5E5E27030943}"/>
               </a:ext>
             </a:extLst>
           </p:cNvPr>
@@ -6757,7 +7113,7 @@
           <p:cNvPr id="4" name="">
             <a:extLst xmlns:a="http://schemas.openxmlformats.org/drawingml/2006/main">
               <a:ext uri="{FF2B5EF4-FFF2-40B4-BE49-F238E27FC236}">
-                <a16:creationId xmlns:a16="http://schemas.microsoft.com/office/drawing/2014/main" id="{3358350E-F51D-4091-BF57-594C2E1051E5}"/>
+                <a16:creationId xmlns:a16="http://schemas.microsoft.com/office/drawing/2014/main" id="{F1AF778F-B4F6-4BC7-BD8B-52B2E530D874}"/>
               </a:ext>
             </a:extLst>
           </p:cNvPr>
@@ -6814,7 +7170,7 @@
           <p:cNvPr id="5" name="">
             <a:extLst xmlns:a="http://schemas.openxmlformats.org/drawingml/2006/main">
               <a:ext uri="{FF2B5EF4-FFF2-40B4-BE49-F238E27FC236}">
-                <a16:creationId xmlns:a16="http://schemas.microsoft.com/office/drawing/2014/main" id="{D701A808-51A8-4477-AA85-45C5105345AD}"/>
+                <a16:creationId xmlns:a16="http://schemas.microsoft.com/office/drawing/2014/main" id="{5F9B4CA9-1995-4E60-B639-F885EDACFAC3}"/>
               </a:ext>
             </a:extLst>
           </p:cNvPr>
@@ -6871,7 +7227,7 @@
           <p:cNvPr id="6" name="">
             <a:extLst xmlns:a="http://schemas.openxmlformats.org/drawingml/2006/main">
               <a:ext uri="{FF2B5EF4-FFF2-40B4-BE49-F238E27FC236}">
-                <a16:creationId xmlns:a16="http://schemas.microsoft.com/office/drawing/2014/main" id="{05CC0106-C273-4598-86E7-B94E3CF55814}"/>
+                <a16:creationId xmlns:a16="http://schemas.microsoft.com/office/drawing/2014/main" id="{8F7D17D8-99BA-4492-ADD2-214891ECD03F}"/>
               </a:ext>
             </a:extLst>
           </p:cNvPr>
@@ -6928,7 +7284,7 @@
           <p:cNvPr id="7" name="">
             <a:extLst xmlns:a="http://schemas.openxmlformats.org/drawingml/2006/main">
               <a:ext uri="{FF2B5EF4-FFF2-40B4-BE49-F238E27FC236}">
-                <a16:creationId xmlns:a16="http://schemas.microsoft.com/office/drawing/2014/main" id="{63F2C011-14AA-4550-BB5B-E458DB8A2864}"/>
+                <a16:creationId xmlns:a16="http://schemas.microsoft.com/office/drawing/2014/main" id="{D94B49F8-DF27-4D03-8E45-D9A45FBD99EB}"/>
               </a:ext>
             </a:extLst>
           </p:cNvPr>
@@ -6975,7 +7331,7 @@
                 <a:ea typeface="Bitstream Charter"/>
                 <a:cs typeface="Bitstream Charter"/>
               </a:rPr>
-              <a:t>A user describes the export transaction, confirms material facts, and receives the current position, required documents, deadlines, and an expert question package.</a:t>
+              <a:t>The prototype guides a user from transaction facts to a source-cited action plan through three clear stages.</a:t>
             </a:r>
           </a:p>
         </p:txBody>
@@ -6985,81 +7341,56 @@
           <p:cNvPr id="8" name="">
             <a:extLst xmlns:a="http://schemas.openxmlformats.org/drawingml/2006/main">
               <a:ext uri="{FF2B5EF4-FFF2-40B4-BE49-F238E27FC236}">
-                <a16:creationId xmlns:a16="http://schemas.microsoft.com/office/drawing/2014/main" id="{C520D1D6-7586-4AAF-87AF-743F5AB610C9}"/>
-              </a:ext>
-            </a:extLst>
-          </p:cNvPr>
-          <p:cNvSpPr>
-            <a:spLocks xmlns:a="http://schemas.openxmlformats.org/drawingml/2006/main" noGrp="1"/>
-          </p:cNvSpPr>
-          <p:nvPr/>
-        </p:nvSpPr>
-        <p:spPr>
-          <a:xfrm xmlns:a="http://schemas.openxmlformats.org/drawingml/2006/main">
-            <a:off x="8001000" y="3857625"/>
-            <a:ext cx="3143250" cy="952500"/>
-          </a:xfrm>
-          <a:prstGeom xmlns:a="http://schemas.openxmlformats.org/drawingml/2006/main" prst="rect">
-            <a:avLst/>
-          </a:prstGeom>
-          <a:noFill xmlns:a="http://schemas.openxmlformats.org/drawingml/2006/main"/>
-          <a:ln xmlns:a="http://schemas.openxmlformats.org/drawingml/2006/main" w="0">
-            <a:noFill/>
-          </a:ln>
-        </p:spPr>
-        <p:txBody>
-          <a:bodyPr xmlns:a="http://schemas.openxmlformats.org/drawingml/2006/main">
-            <a:normAutofit fontScale="100000"/>
-          </a:bodyPr>
-          <a:lstStyle xmlns:a="http://schemas.openxmlformats.org/drawingml/2006/main"/>
-          <a:p xmlns:a="http://schemas.openxmlformats.org/drawingml/2006/main">
-            <a:pPr>
-              <a:defRPr sz="5400" b="1">
-                <a:solidFill>
-                  <a:srgbClr val="B8742A"/>
-                </a:solidFill>
-                <a:latin typeface="Bitstream Charter"/>
-                <a:ea typeface="Bitstream Charter"/>
-                <a:cs typeface="Bitstream Charter"/>
-              </a:defRPr>
-            </a:pPr>
-            <a:r>
-              <a:rPr sz="5400" b="1">
-                <a:solidFill>
-                  <a:srgbClr val="B8742A"/>
-                </a:solidFill>
-                <a:latin typeface="Bitstream Charter"/>
-                <a:ea typeface="Bitstream Charter"/>
-                <a:cs typeface="Bitstream Charter"/>
-              </a:rPr>
-              <a:t>10 MIN</a:t>
-            </a:r>
-          </a:p>
-        </p:txBody>
-      </p:sp>
-      <p:sp>
-        <p:nvSpPr>
-          <p:cNvPr id="9" name="">
-            <a:extLst xmlns:a="http://schemas.openxmlformats.org/drawingml/2006/main">
-              <a:ext uri="{FF2B5EF4-FFF2-40B4-BE49-F238E27FC236}">
-                <a16:creationId xmlns:a16="http://schemas.microsoft.com/office/drawing/2014/main" id="{6BD6C1B3-F19F-4CD8-8DB7-A7D7400B104F}"/>
-              </a:ext>
-            </a:extLst>
-          </p:cNvPr>
-          <p:cNvSpPr>
-            <a:spLocks xmlns:a="http://schemas.openxmlformats.org/drawingml/2006/main" noGrp="1"/>
-          </p:cNvSpPr>
-          <p:nvPr/>
-        </p:nvSpPr>
-        <p:spPr>
-          <a:xfrm xmlns:a="http://schemas.openxmlformats.org/drawingml/2006/main">
-            <a:off x="723900" y="3838575"/>
-            <a:ext cx="180975" cy="180975"/>
+                <a16:creationId xmlns:a16="http://schemas.microsoft.com/office/drawing/2014/main" id="{AE50549C-566F-4A8A-BFD0-DC5E46AF1E08}"/>
+              </a:ext>
+            </a:extLst>
+          </p:cNvPr>
+          <p:cNvSpPr>
+            <a:spLocks xmlns:a="http://schemas.openxmlformats.org/drawingml/2006/main" noGrp="1"/>
+          </p:cNvSpPr>
+          <p:nvPr/>
+        </p:nvSpPr>
+        <p:spPr>
+          <a:xfrm xmlns:a="http://schemas.openxmlformats.org/drawingml/2006/main">
+            <a:off x="723900" y="3752850"/>
+            <a:ext cx="3048000" cy="1676400"/>
           </a:xfrm>
           <a:prstGeom xmlns:a="http://schemas.openxmlformats.org/drawingml/2006/main" prst="roundRect">
             <a:avLst>
-              <a:gd name="adj" fmla="val 42105"/>
+              <a:gd name="adj" fmla="val 4545"/>
             </a:avLst>
+          </a:prstGeom>
+          <a:solidFill xmlns:a="http://schemas.openxmlformats.org/drawingml/2006/main">
+            <a:srgbClr val="F4F7FB"/>
+          </a:solidFill>
+          <a:ln xmlns:a="http://schemas.openxmlformats.org/drawingml/2006/main" w="9525">
+            <a:solidFill>
+              <a:srgbClr val="CBD5E1"/>
+            </a:solidFill>
+          </a:ln>
+        </p:spPr>
+      </p:sp>
+      <p:sp>
+        <p:nvSpPr>
+          <p:cNvPr id="9" name="">
+            <a:extLst xmlns:a="http://schemas.openxmlformats.org/drawingml/2006/main">
+              <a:ext uri="{FF2B5EF4-FFF2-40B4-BE49-F238E27FC236}">
+                <a16:creationId xmlns:a16="http://schemas.microsoft.com/office/drawing/2014/main" id="{F49DA355-6C02-4027-B7E5-C26CCA439129}"/>
+              </a:ext>
+            </a:extLst>
+          </p:cNvPr>
+          <p:cNvSpPr>
+            <a:spLocks xmlns:a="http://schemas.openxmlformats.org/drawingml/2006/main" noGrp="1"/>
+          </p:cNvSpPr>
+          <p:nvPr/>
+        </p:nvSpPr>
+        <p:spPr>
+          <a:xfrm xmlns:a="http://schemas.openxmlformats.org/drawingml/2006/main">
+            <a:off x="723900" y="3752850"/>
+            <a:ext cx="3048000" cy="47625"/>
+          </a:xfrm>
+          <a:prstGeom xmlns:a="http://schemas.openxmlformats.org/drawingml/2006/main" prst="rect">
+            <a:avLst/>
           </a:prstGeom>
           <a:solidFill xmlns:a="http://schemas.openxmlformats.org/drawingml/2006/main">
             <a:srgbClr val="B8742A"/>
@@ -7074,38 +7405,38 @@
           <p:cNvPr id="10" name="">
             <a:extLst xmlns:a="http://schemas.openxmlformats.org/drawingml/2006/main">
               <a:ext uri="{FF2B5EF4-FFF2-40B4-BE49-F238E27FC236}">
-                <a16:creationId xmlns:a16="http://schemas.microsoft.com/office/drawing/2014/main" id="{6AF73077-5940-4DB0-9C4B-C3E7145A3CC0}"/>
-              </a:ext>
-            </a:extLst>
-          </p:cNvPr>
-          <p:cNvSpPr>
-            <a:spLocks xmlns:a="http://schemas.openxmlformats.org/drawingml/2006/main" noGrp="1"/>
-          </p:cNvSpPr>
-          <p:nvPr/>
-        </p:nvSpPr>
-        <p:spPr>
-          <a:xfrm xmlns:a="http://schemas.openxmlformats.org/drawingml/2006/main">
-            <a:off x="733425" y="3819525"/>
-            <a:ext cx="161925" cy="171450"/>
-          </a:xfrm>
-          <a:prstGeom xmlns:a="http://schemas.openxmlformats.org/drawingml/2006/main" prst="rect">
-            <a:avLst/>
-          </a:prstGeom>
-          <a:noFill xmlns:a="http://schemas.openxmlformats.org/drawingml/2006/main"/>
-          <a:ln xmlns:a="http://schemas.openxmlformats.org/drawingml/2006/main" w="0">
-            <a:noFill/>
-          </a:ln>
-        </p:spPr>
-        <p:txBody>
-          <a:bodyPr xmlns:a="http://schemas.openxmlformats.org/drawingml/2006/main">
-            <a:normAutofit fontScale="10000"/>
+                <a16:creationId xmlns:a16="http://schemas.microsoft.com/office/drawing/2014/main" id="{5FF7B6DF-4968-48F5-91FA-462269E7BA97}"/>
+              </a:ext>
+            </a:extLst>
+          </p:cNvPr>
+          <p:cNvSpPr>
+            <a:spLocks xmlns:a="http://schemas.openxmlformats.org/drawingml/2006/main" noGrp="1"/>
+          </p:cNvSpPr>
+          <p:nvPr/>
+        </p:nvSpPr>
+        <p:spPr>
+          <a:xfrm xmlns:a="http://schemas.openxmlformats.org/drawingml/2006/main">
+            <a:off x="933450" y="3981450"/>
+            <a:ext cx="476250" cy="190500"/>
+          </a:xfrm>
+          <a:prstGeom xmlns:a="http://schemas.openxmlformats.org/drawingml/2006/main" prst="rect">
+            <a:avLst/>
+          </a:prstGeom>
+          <a:noFill xmlns:a="http://schemas.openxmlformats.org/drawingml/2006/main"/>
+          <a:ln xmlns:a="http://schemas.openxmlformats.org/drawingml/2006/main" w="0">
+            <a:noFill/>
+          </a:ln>
+        </p:spPr>
+        <p:txBody>
+          <a:bodyPr xmlns:a="http://schemas.openxmlformats.org/drawingml/2006/main">
+            <a:normAutofit fontScale="72222"/>
           </a:bodyPr>
           <a:lstStyle xmlns:a="http://schemas.openxmlformats.org/drawingml/2006/main"/>
           <a:p xmlns:a="http://schemas.openxmlformats.org/drawingml/2006/main">
             <a:pPr>
               <a:defRPr sz="900" b="1">
                 <a:solidFill>
-                  <a:srgbClr val="FFFFFF"/>
+                  <a:srgbClr val="B8742A"/>
                 </a:solidFill>
                 <a:latin typeface="Bitstream Charter"/>
                 <a:ea typeface="Bitstream Charter"/>
@@ -7115,13 +7446,13 @@
             <a:r>
               <a:rPr sz="900" b="1">
                 <a:solidFill>
-                  <a:srgbClr val="FFFFFF"/>
-                </a:solidFill>
-                <a:latin typeface="Bitstream Charter"/>
-                <a:ea typeface="Bitstream Charter"/>
-                <a:cs typeface="Bitstream Charter"/>
-              </a:rPr>
-              <a:t>✓</a:t>
+                  <a:srgbClr val="B8742A"/>
+                </a:solidFill>
+                <a:latin typeface="Bitstream Charter"/>
+                <a:ea typeface="Bitstream Charter"/>
+                <a:cs typeface="Bitstream Charter"/>
+              </a:rPr>
+              <a:t>01</a:t>
             </a:r>
           </a:p>
         </p:txBody>
@@ -7131,19 +7462,19 @@
           <p:cNvPr id="11" name="">
             <a:extLst xmlns:a="http://schemas.openxmlformats.org/drawingml/2006/main">
               <a:ext uri="{FF2B5EF4-FFF2-40B4-BE49-F238E27FC236}">
-                <a16:creationId xmlns:a16="http://schemas.microsoft.com/office/drawing/2014/main" id="{A09D5461-93C0-4206-90AC-568B14A2725A}"/>
-              </a:ext>
-            </a:extLst>
-          </p:cNvPr>
-          <p:cNvSpPr>
-            <a:spLocks xmlns:a="http://schemas.openxmlformats.org/drawingml/2006/main" noGrp="1"/>
-          </p:cNvSpPr>
-          <p:nvPr/>
-        </p:nvSpPr>
-        <p:spPr>
-          <a:xfrm xmlns:a="http://schemas.openxmlformats.org/drawingml/2006/main">
-            <a:off x="1047750" y="3790950"/>
-            <a:ext cx="9486900" cy="514350"/>
+                <a16:creationId xmlns:a16="http://schemas.microsoft.com/office/drawing/2014/main" id="{B8DD18EB-1035-4350-B7C5-30FF2AEB0E4C}"/>
+              </a:ext>
+            </a:extLst>
+          </p:cNvPr>
+          <p:cNvSpPr>
+            <a:spLocks xmlns:a="http://schemas.openxmlformats.org/drawingml/2006/main" noGrp="1"/>
+          </p:cNvSpPr>
+          <p:nvPr/>
+        </p:nvSpPr>
+        <p:spPr>
+          <a:xfrm xmlns:a="http://schemas.openxmlformats.org/drawingml/2006/main">
+            <a:off x="933450" y="4286250"/>
+            <a:ext cx="2628900" cy="457200"/>
           </a:xfrm>
           <a:prstGeom xmlns:a="http://schemas.openxmlformats.org/drawingml/2006/main" prst="rect">
             <a:avLst/>
@@ -7160,25 +7491,25 @@
           <a:lstStyle xmlns:a="http://schemas.openxmlformats.org/drawingml/2006/main"/>
           <a:p xmlns:a="http://schemas.openxmlformats.org/drawingml/2006/main">
             <a:pPr>
-              <a:defRPr sz="1350" b="0">
-                <a:solidFill>
-                  <a:srgbClr val="394B61"/>
-                </a:solidFill>
-                <a:latin typeface="Bitstream Charter"/>
-                <a:ea typeface="Bitstream Charter"/>
-                <a:cs typeface="Bitstream Charter"/>
-              </a:defRPr>
-            </a:pPr>
-            <a:r>
-              <a:rPr sz="1350" b="0">
-                <a:solidFill>
-                  <a:srgbClr val="394B61"/>
-                </a:solidFill>
-                <a:latin typeface="Bitstream Charter"/>
-                <a:ea typeface="Bitstream Charter"/>
-                <a:cs typeface="Bitstream Charter"/>
-              </a:rPr>
-              <a:t>Current-rule verification</a:t>
+              <a:defRPr sz="1500" b="1">
+                <a:solidFill>
+                  <a:srgbClr val="102C55"/>
+                </a:solidFill>
+                <a:latin typeface="Bitstream Charter"/>
+                <a:ea typeface="Bitstream Charter"/>
+                <a:cs typeface="Bitstream Charter"/>
+              </a:defRPr>
+            </a:pPr>
+            <a:r>
+              <a:rPr sz="1500" b="1">
+                <a:solidFill>
+                  <a:srgbClr val="102C55"/>
+                </a:solidFill>
+                <a:latin typeface="Bitstream Charter"/>
+                <a:ea typeface="Bitstream Charter"/>
+                <a:cs typeface="Bitstream Charter"/>
+              </a:rPr>
+              <a:t>Describe The Transaction</a:t>
             </a:r>
           </a:p>
         </p:txBody>
@@ -7188,24 +7519,113 @@
           <p:cNvPr id="12" name="">
             <a:extLst xmlns:a="http://schemas.openxmlformats.org/drawingml/2006/main">
               <a:ext uri="{FF2B5EF4-FFF2-40B4-BE49-F238E27FC236}">
-                <a16:creationId xmlns:a16="http://schemas.microsoft.com/office/drawing/2014/main" id="{011E8A5F-3640-4DBF-9D65-02AE1C896ACB}"/>
-              </a:ext>
-            </a:extLst>
-          </p:cNvPr>
-          <p:cNvSpPr>
-            <a:spLocks xmlns:a="http://schemas.openxmlformats.org/drawingml/2006/main" noGrp="1"/>
-          </p:cNvSpPr>
-          <p:nvPr/>
-        </p:nvSpPr>
-        <p:spPr>
-          <a:xfrm xmlns:a="http://schemas.openxmlformats.org/drawingml/2006/main">
-            <a:off x="723900" y="4581525"/>
-            <a:ext cx="180975" cy="180975"/>
+                <a16:creationId xmlns:a16="http://schemas.microsoft.com/office/drawing/2014/main" id="{B86733B7-47CA-4A69-8A85-5FE4BD8CC318}"/>
+              </a:ext>
+            </a:extLst>
+          </p:cNvPr>
+          <p:cNvSpPr>
+            <a:spLocks xmlns:a="http://schemas.openxmlformats.org/drawingml/2006/main" noGrp="1"/>
+          </p:cNvSpPr>
+          <p:nvPr/>
+        </p:nvSpPr>
+        <p:spPr>
+          <a:xfrm xmlns:a="http://schemas.openxmlformats.org/drawingml/2006/main">
+            <a:off x="933450" y="4857750"/>
+            <a:ext cx="2628900" cy="457200"/>
+          </a:xfrm>
+          <a:prstGeom xmlns:a="http://schemas.openxmlformats.org/drawingml/2006/main" prst="rect">
+            <a:avLst/>
+          </a:prstGeom>
+          <a:noFill xmlns:a="http://schemas.openxmlformats.org/drawingml/2006/main"/>
+          <a:ln xmlns:a="http://schemas.openxmlformats.org/drawingml/2006/main" w="0">
+            <a:noFill/>
+          </a:ln>
+        </p:spPr>
+        <p:txBody>
+          <a:bodyPr xmlns:a="http://schemas.openxmlformats.org/drawingml/2006/main">
+            <a:normAutofit fontScale="100000"/>
+          </a:bodyPr>
+          <a:lstStyle xmlns:a="http://schemas.openxmlformats.org/drawingml/2006/main"/>
+          <a:p xmlns:a="http://schemas.openxmlformats.org/drawingml/2006/main">
+            <a:pPr>
+              <a:defRPr sz="1050" b="0">
+                <a:solidFill>
+                  <a:srgbClr val="526177"/>
+                </a:solidFill>
+                <a:latin typeface="Bitstream Charter"/>
+                <a:ea typeface="Bitstream Charter"/>
+                <a:cs typeface="Bitstream Charter"/>
+              </a:defRPr>
+            </a:pPr>
+            <a:r>
+              <a:rPr sz="1050" b="0">
+                <a:solidFill>
+                  <a:srgbClr val="526177"/>
+                </a:solidFill>
+                <a:latin typeface="Bitstream Charter"/>
+                <a:ea typeface="Bitstream Charter"/>
+                <a:cs typeface="Bitstream Charter"/>
+              </a:rPr>
+              <a:t>Confirm the service, payment route, date, and business profile.</a:t>
+            </a:r>
+          </a:p>
+        </p:txBody>
+      </p:sp>
+      <p:sp>
+        <p:nvSpPr>
+          <p:cNvPr id="13" name="">
+            <a:extLst xmlns:a="http://schemas.openxmlformats.org/drawingml/2006/main">
+              <a:ext uri="{FF2B5EF4-FFF2-40B4-BE49-F238E27FC236}">
+                <a16:creationId xmlns:a16="http://schemas.microsoft.com/office/drawing/2014/main" id="{2C813FC0-A9BA-482B-8BF6-8FB786E5A92A}"/>
+              </a:ext>
+            </a:extLst>
+          </p:cNvPr>
+          <p:cNvSpPr>
+            <a:spLocks xmlns:a="http://schemas.openxmlformats.org/drawingml/2006/main" noGrp="1"/>
+          </p:cNvSpPr>
+          <p:nvPr/>
+        </p:nvSpPr>
+        <p:spPr>
+          <a:xfrm xmlns:a="http://schemas.openxmlformats.org/drawingml/2006/main">
+            <a:off x="4057650" y="3752850"/>
+            <a:ext cx="3048000" cy="1676400"/>
           </a:xfrm>
           <a:prstGeom xmlns:a="http://schemas.openxmlformats.org/drawingml/2006/main" prst="roundRect">
             <a:avLst>
-              <a:gd name="adj" fmla="val 42105"/>
+              <a:gd name="adj" fmla="val 4545"/>
             </a:avLst>
+          </a:prstGeom>
+          <a:solidFill xmlns:a="http://schemas.openxmlformats.org/drawingml/2006/main">
+            <a:srgbClr val="F4F7FB"/>
+          </a:solidFill>
+          <a:ln xmlns:a="http://schemas.openxmlformats.org/drawingml/2006/main" w="9525">
+            <a:solidFill>
+              <a:srgbClr val="CBD5E1"/>
+            </a:solidFill>
+          </a:ln>
+        </p:spPr>
+      </p:sp>
+      <p:sp>
+        <p:nvSpPr>
+          <p:cNvPr id="14" name="">
+            <a:extLst xmlns:a="http://schemas.openxmlformats.org/drawingml/2006/main">
+              <a:ext uri="{FF2B5EF4-FFF2-40B4-BE49-F238E27FC236}">
+                <a16:creationId xmlns:a16="http://schemas.microsoft.com/office/drawing/2014/main" id="{9AE781CA-C87D-452E-8075-8A087787840F}"/>
+              </a:ext>
+            </a:extLst>
+          </p:cNvPr>
+          <p:cNvSpPr>
+            <a:spLocks xmlns:a="http://schemas.openxmlformats.org/drawingml/2006/main" noGrp="1"/>
+          </p:cNvSpPr>
+          <p:nvPr/>
+        </p:nvSpPr>
+        <p:spPr>
+          <a:xfrm xmlns:a="http://schemas.openxmlformats.org/drawingml/2006/main">
+            <a:off x="4057650" y="3752850"/>
+            <a:ext cx="3048000" cy="47625"/>
+          </a:xfrm>
+          <a:prstGeom xmlns:a="http://schemas.openxmlformats.org/drawingml/2006/main" prst="rect">
+            <a:avLst/>
           </a:prstGeom>
           <a:solidFill xmlns:a="http://schemas.openxmlformats.org/drawingml/2006/main">
             <a:srgbClr val="B8742A"/>
@@ -7217,41 +7637,41 @@
       </p:sp>
       <p:sp>
         <p:nvSpPr>
-          <p:cNvPr id="13" name="">
-            <a:extLst xmlns:a="http://schemas.openxmlformats.org/drawingml/2006/main">
-              <a:ext uri="{FF2B5EF4-FFF2-40B4-BE49-F238E27FC236}">
-                <a16:creationId xmlns:a16="http://schemas.microsoft.com/office/drawing/2014/main" id="{48A63F35-0B2C-411E-92B4-60F2980C18E0}"/>
-              </a:ext>
-            </a:extLst>
-          </p:cNvPr>
-          <p:cNvSpPr>
-            <a:spLocks xmlns:a="http://schemas.openxmlformats.org/drawingml/2006/main" noGrp="1"/>
-          </p:cNvSpPr>
-          <p:nvPr/>
-        </p:nvSpPr>
-        <p:spPr>
-          <a:xfrm xmlns:a="http://schemas.openxmlformats.org/drawingml/2006/main">
-            <a:off x="733425" y="4562475"/>
-            <a:ext cx="161925" cy="171450"/>
-          </a:xfrm>
-          <a:prstGeom xmlns:a="http://schemas.openxmlformats.org/drawingml/2006/main" prst="rect">
-            <a:avLst/>
-          </a:prstGeom>
-          <a:noFill xmlns:a="http://schemas.openxmlformats.org/drawingml/2006/main"/>
-          <a:ln xmlns:a="http://schemas.openxmlformats.org/drawingml/2006/main" w="0">
-            <a:noFill/>
-          </a:ln>
-        </p:spPr>
-        <p:txBody>
-          <a:bodyPr xmlns:a="http://schemas.openxmlformats.org/drawingml/2006/main">
-            <a:normAutofit fontScale="10000"/>
+          <p:cNvPr id="15" name="">
+            <a:extLst xmlns:a="http://schemas.openxmlformats.org/drawingml/2006/main">
+              <a:ext uri="{FF2B5EF4-FFF2-40B4-BE49-F238E27FC236}">
+                <a16:creationId xmlns:a16="http://schemas.microsoft.com/office/drawing/2014/main" id="{C9976F67-1C33-4CE0-B104-B4093EF7E2A1}"/>
+              </a:ext>
+            </a:extLst>
+          </p:cNvPr>
+          <p:cNvSpPr>
+            <a:spLocks xmlns:a="http://schemas.openxmlformats.org/drawingml/2006/main" noGrp="1"/>
+          </p:cNvSpPr>
+          <p:nvPr/>
+        </p:nvSpPr>
+        <p:spPr>
+          <a:xfrm xmlns:a="http://schemas.openxmlformats.org/drawingml/2006/main">
+            <a:off x="4267200" y="3981450"/>
+            <a:ext cx="476250" cy="190500"/>
+          </a:xfrm>
+          <a:prstGeom xmlns:a="http://schemas.openxmlformats.org/drawingml/2006/main" prst="rect">
+            <a:avLst/>
+          </a:prstGeom>
+          <a:noFill xmlns:a="http://schemas.openxmlformats.org/drawingml/2006/main"/>
+          <a:ln xmlns:a="http://schemas.openxmlformats.org/drawingml/2006/main" w="0">
+            <a:noFill/>
+          </a:ln>
+        </p:spPr>
+        <p:txBody>
+          <a:bodyPr xmlns:a="http://schemas.openxmlformats.org/drawingml/2006/main">
+            <a:normAutofit fontScale="72222"/>
           </a:bodyPr>
           <a:lstStyle xmlns:a="http://schemas.openxmlformats.org/drawingml/2006/main"/>
           <a:p xmlns:a="http://schemas.openxmlformats.org/drawingml/2006/main">
             <a:pPr>
               <a:defRPr sz="900" b="1">
                 <a:solidFill>
-                  <a:srgbClr val="FFFFFF"/>
+                  <a:srgbClr val="B8742A"/>
                 </a:solidFill>
                 <a:latin typeface="Bitstream Charter"/>
                 <a:ea typeface="Bitstream Charter"/>
@@ -7261,35 +7681,35 @@
             <a:r>
               <a:rPr sz="900" b="1">
                 <a:solidFill>
-                  <a:srgbClr val="FFFFFF"/>
-                </a:solidFill>
-                <a:latin typeface="Bitstream Charter"/>
-                <a:ea typeface="Bitstream Charter"/>
-                <a:cs typeface="Bitstream Charter"/>
-              </a:rPr>
-              <a:t>✓</a:t>
-            </a:r>
-          </a:p>
-        </p:txBody>
-      </p:sp>
-      <p:sp>
-        <p:nvSpPr>
-          <p:cNvPr id="14" name="">
-            <a:extLst xmlns:a="http://schemas.openxmlformats.org/drawingml/2006/main">
-              <a:ext uri="{FF2B5EF4-FFF2-40B4-BE49-F238E27FC236}">
-                <a16:creationId xmlns:a16="http://schemas.microsoft.com/office/drawing/2014/main" id="{1A6C8CF5-1A31-42A8-BE18-B0A986800BDC}"/>
-              </a:ext>
-            </a:extLst>
-          </p:cNvPr>
-          <p:cNvSpPr>
-            <a:spLocks xmlns:a="http://schemas.openxmlformats.org/drawingml/2006/main" noGrp="1"/>
-          </p:cNvSpPr>
-          <p:nvPr/>
-        </p:nvSpPr>
-        <p:spPr>
-          <a:xfrm xmlns:a="http://schemas.openxmlformats.org/drawingml/2006/main">
-            <a:off x="1047750" y="4533900"/>
-            <a:ext cx="9486900" cy="514350"/>
+                  <a:srgbClr val="B8742A"/>
+                </a:solidFill>
+                <a:latin typeface="Bitstream Charter"/>
+                <a:ea typeface="Bitstream Charter"/>
+                <a:cs typeface="Bitstream Charter"/>
+              </a:rPr>
+              <a:t>02</a:t>
+            </a:r>
+          </a:p>
+        </p:txBody>
+      </p:sp>
+      <p:sp>
+        <p:nvSpPr>
+          <p:cNvPr id="16" name="">
+            <a:extLst xmlns:a="http://schemas.openxmlformats.org/drawingml/2006/main">
+              <a:ext uri="{FF2B5EF4-FFF2-40B4-BE49-F238E27FC236}">
+                <a16:creationId xmlns:a16="http://schemas.microsoft.com/office/drawing/2014/main" id="{7AAB3928-8A6B-4F45-A6B9-3E7614BAB4DD}"/>
+              </a:ext>
+            </a:extLst>
+          </p:cNvPr>
+          <p:cNvSpPr>
+            <a:spLocks xmlns:a="http://schemas.openxmlformats.org/drawingml/2006/main" noGrp="1"/>
+          </p:cNvSpPr>
+          <p:nvPr/>
+        </p:nvSpPr>
+        <p:spPr>
+          <a:xfrm xmlns:a="http://schemas.openxmlformats.org/drawingml/2006/main">
+            <a:off x="4267200" y="4286250"/>
+            <a:ext cx="2628900" cy="457200"/>
           </a:xfrm>
           <a:prstGeom xmlns:a="http://schemas.openxmlformats.org/drawingml/2006/main" prst="rect">
             <a:avLst/>
@@ -7306,52 +7726,141 @@
           <a:lstStyle xmlns:a="http://schemas.openxmlformats.org/drawingml/2006/main"/>
           <a:p xmlns:a="http://schemas.openxmlformats.org/drawingml/2006/main">
             <a:pPr>
-              <a:defRPr sz="1350" b="0">
-                <a:solidFill>
-                  <a:srgbClr val="394B61"/>
-                </a:solidFill>
-                <a:latin typeface="Bitstream Charter"/>
-                <a:ea typeface="Bitstream Charter"/>
-                <a:cs typeface="Bitstream Charter"/>
-              </a:defRPr>
-            </a:pPr>
-            <a:r>
-              <a:rPr sz="1350" b="0">
-                <a:solidFill>
-                  <a:srgbClr val="394B61"/>
-                </a:solidFill>
-                <a:latin typeface="Bitstream Charter"/>
-                <a:ea typeface="Bitstream Charter"/>
-                <a:cs typeface="Bitstream Charter"/>
-              </a:rPr>
-              <a:t>Previous-versus-current comparison</a:t>
-            </a:r>
-          </a:p>
-        </p:txBody>
-      </p:sp>
-      <p:sp>
-        <p:nvSpPr>
-          <p:cNvPr id="15" name="">
-            <a:extLst xmlns:a="http://schemas.openxmlformats.org/drawingml/2006/main">
-              <a:ext uri="{FF2B5EF4-FFF2-40B4-BE49-F238E27FC236}">
-                <a16:creationId xmlns:a16="http://schemas.microsoft.com/office/drawing/2014/main" id="{CA1DB8B0-6F7C-4B9E-803C-81020CC0BEB9}"/>
-              </a:ext>
-            </a:extLst>
-          </p:cNvPr>
-          <p:cNvSpPr>
-            <a:spLocks xmlns:a="http://schemas.openxmlformats.org/drawingml/2006/main" noGrp="1"/>
-          </p:cNvSpPr>
-          <p:nvPr/>
-        </p:nvSpPr>
-        <p:spPr>
-          <a:xfrm xmlns:a="http://schemas.openxmlformats.org/drawingml/2006/main">
-            <a:off x="723900" y="5324475"/>
-            <a:ext cx="180975" cy="180975"/>
+              <a:defRPr sz="1500" b="1">
+                <a:solidFill>
+                  <a:srgbClr val="102C55"/>
+                </a:solidFill>
+                <a:latin typeface="Bitstream Charter"/>
+                <a:ea typeface="Bitstream Charter"/>
+                <a:cs typeface="Bitstream Charter"/>
+              </a:defRPr>
+            </a:pPr>
+            <a:r>
+              <a:rPr sz="1500" b="1">
+                <a:solidFill>
+                  <a:srgbClr val="102C55"/>
+                </a:solidFill>
+                <a:latin typeface="Bitstream Charter"/>
+                <a:ea typeface="Bitstream Charter"/>
+                <a:cs typeface="Bitstream Charter"/>
+              </a:rPr>
+              <a:t>Verify The Current Position</a:t>
+            </a:r>
+          </a:p>
+        </p:txBody>
+      </p:sp>
+      <p:sp>
+        <p:nvSpPr>
+          <p:cNvPr id="17" name="">
+            <a:extLst xmlns:a="http://schemas.openxmlformats.org/drawingml/2006/main">
+              <a:ext uri="{FF2B5EF4-FFF2-40B4-BE49-F238E27FC236}">
+                <a16:creationId xmlns:a16="http://schemas.microsoft.com/office/drawing/2014/main" id="{7B6E43C6-283E-46C6-B537-630E9DA7C70A}"/>
+              </a:ext>
+            </a:extLst>
+          </p:cNvPr>
+          <p:cNvSpPr>
+            <a:spLocks xmlns:a="http://schemas.openxmlformats.org/drawingml/2006/main" noGrp="1"/>
+          </p:cNvSpPr>
+          <p:nvPr/>
+        </p:nvSpPr>
+        <p:spPr>
+          <a:xfrm xmlns:a="http://schemas.openxmlformats.org/drawingml/2006/main">
+            <a:off x="4267200" y="4857750"/>
+            <a:ext cx="2628900" cy="457200"/>
+          </a:xfrm>
+          <a:prstGeom xmlns:a="http://schemas.openxmlformats.org/drawingml/2006/main" prst="rect">
+            <a:avLst/>
+          </a:prstGeom>
+          <a:noFill xmlns:a="http://schemas.openxmlformats.org/drawingml/2006/main"/>
+          <a:ln xmlns:a="http://schemas.openxmlformats.org/drawingml/2006/main" w="0">
+            <a:noFill/>
+          </a:ln>
+        </p:spPr>
+        <p:txBody>
+          <a:bodyPr xmlns:a="http://schemas.openxmlformats.org/drawingml/2006/main">
+            <a:normAutofit fontScale="100000"/>
+          </a:bodyPr>
+          <a:lstStyle xmlns:a="http://schemas.openxmlformats.org/drawingml/2006/main"/>
+          <a:p xmlns:a="http://schemas.openxmlformats.org/drawingml/2006/main">
+            <a:pPr>
+              <a:defRPr sz="1050" b="0">
+                <a:solidFill>
+                  <a:srgbClr val="526177"/>
+                </a:solidFill>
+                <a:latin typeface="Bitstream Charter"/>
+                <a:ea typeface="Bitstream Charter"/>
+                <a:cs typeface="Bitstream Charter"/>
+              </a:defRPr>
+            </a:pPr>
+            <a:r>
+              <a:rPr sz="1050" b="0">
+                <a:solidFill>
+                  <a:srgbClr val="526177"/>
+                </a:solidFill>
+                <a:latin typeface="Bitstream Charter"/>
+                <a:ea typeface="Bitstream Charter"/>
+                <a:cs typeface="Bitstream Charter"/>
+              </a:rPr>
+              <a:t>Compare applicable official publications and expose the source trail.</a:t>
+            </a:r>
+          </a:p>
+        </p:txBody>
+      </p:sp>
+      <p:sp>
+        <p:nvSpPr>
+          <p:cNvPr id="18" name="">
+            <a:extLst xmlns:a="http://schemas.openxmlformats.org/drawingml/2006/main">
+              <a:ext uri="{FF2B5EF4-FFF2-40B4-BE49-F238E27FC236}">
+                <a16:creationId xmlns:a16="http://schemas.microsoft.com/office/drawing/2014/main" id="{1186E38F-FAC1-4473-A128-6FBCD7594126}"/>
+              </a:ext>
+            </a:extLst>
+          </p:cNvPr>
+          <p:cNvSpPr>
+            <a:spLocks xmlns:a="http://schemas.openxmlformats.org/drawingml/2006/main" noGrp="1"/>
+          </p:cNvSpPr>
+          <p:nvPr/>
+        </p:nvSpPr>
+        <p:spPr>
+          <a:xfrm xmlns:a="http://schemas.openxmlformats.org/drawingml/2006/main">
+            <a:off x="7391400" y="3752850"/>
+            <a:ext cx="3048000" cy="1676400"/>
           </a:xfrm>
           <a:prstGeom xmlns:a="http://schemas.openxmlformats.org/drawingml/2006/main" prst="roundRect">
             <a:avLst>
-              <a:gd name="adj" fmla="val 42105"/>
+              <a:gd name="adj" fmla="val 4545"/>
             </a:avLst>
+          </a:prstGeom>
+          <a:solidFill xmlns:a="http://schemas.openxmlformats.org/drawingml/2006/main">
+            <a:srgbClr val="F4F7FB"/>
+          </a:solidFill>
+          <a:ln xmlns:a="http://schemas.openxmlformats.org/drawingml/2006/main" w="9525">
+            <a:solidFill>
+              <a:srgbClr val="CBD5E1"/>
+            </a:solidFill>
+          </a:ln>
+        </p:spPr>
+      </p:sp>
+      <p:sp>
+        <p:nvSpPr>
+          <p:cNvPr id="19" name="">
+            <a:extLst xmlns:a="http://schemas.openxmlformats.org/drawingml/2006/main">
+              <a:ext uri="{FF2B5EF4-FFF2-40B4-BE49-F238E27FC236}">
+                <a16:creationId xmlns:a16="http://schemas.microsoft.com/office/drawing/2014/main" id="{E1C9673A-4DB4-4040-9852-C32560672047}"/>
+              </a:ext>
+            </a:extLst>
+          </p:cNvPr>
+          <p:cNvSpPr>
+            <a:spLocks xmlns:a="http://schemas.openxmlformats.org/drawingml/2006/main" noGrp="1"/>
+          </p:cNvSpPr>
+          <p:nvPr/>
+        </p:nvSpPr>
+        <p:spPr>
+          <a:xfrm xmlns:a="http://schemas.openxmlformats.org/drawingml/2006/main">
+            <a:off x="7391400" y="3752850"/>
+            <a:ext cx="3048000" cy="47625"/>
+          </a:xfrm>
+          <a:prstGeom xmlns:a="http://schemas.openxmlformats.org/drawingml/2006/main" prst="rect">
+            <a:avLst/>
           </a:prstGeom>
           <a:solidFill xmlns:a="http://schemas.openxmlformats.org/drawingml/2006/main">
             <a:srgbClr val="B8742A"/>
@@ -7363,41 +7872,41 @@
       </p:sp>
       <p:sp>
         <p:nvSpPr>
-          <p:cNvPr id="16" name="">
-            <a:extLst xmlns:a="http://schemas.openxmlformats.org/drawingml/2006/main">
-              <a:ext uri="{FF2B5EF4-FFF2-40B4-BE49-F238E27FC236}">
-                <a16:creationId xmlns:a16="http://schemas.microsoft.com/office/drawing/2014/main" id="{E0973D7C-3B4C-42F8-90E3-5FBC54AAE944}"/>
-              </a:ext>
-            </a:extLst>
-          </p:cNvPr>
-          <p:cNvSpPr>
-            <a:spLocks xmlns:a="http://schemas.openxmlformats.org/drawingml/2006/main" noGrp="1"/>
-          </p:cNvSpPr>
-          <p:nvPr/>
-        </p:nvSpPr>
-        <p:spPr>
-          <a:xfrm xmlns:a="http://schemas.openxmlformats.org/drawingml/2006/main">
-            <a:off x="733425" y="5305425"/>
-            <a:ext cx="161925" cy="171450"/>
-          </a:xfrm>
-          <a:prstGeom xmlns:a="http://schemas.openxmlformats.org/drawingml/2006/main" prst="rect">
-            <a:avLst/>
-          </a:prstGeom>
-          <a:noFill xmlns:a="http://schemas.openxmlformats.org/drawingml/2006/main"/>
-          <a:ln xmlns:a="http://schemas.openxmlformats.org/drawingml/2006/main" w="0">
-            <a:noFill/>
-          </a:ln>
-        </p:spPr>
-        <p:txBody>
-          <a:bodyPr xmlns:a="http://schemas.openxmlformats.org/drawingml/2006/main">
-            <a:normAutofit fontScale="10000"/>
+          <p:cNvPr id="20" name="">
+            <a:extLst xmlns:a="http://schemas.openxmlformats.org/drawingml/2006/main">
+              <a:ext uri="{FF2B5EF4-FFF2-40B4-BE49-F238E27FC236}">
+                <a16:creationId xmlns:a16="http://schemas.microsoft.com/office/drawing/2014/main" id="{3DF5A4D7-C46E-4B7D-87AA-64EE0CA6F9F7}"/>
+              </a:ext>
+            </a:extLst>
+          </p:cNvPr>
+          <p:cNvSpPr>
+            <a:spLocks xmlns:a="http://schemas.openxmlformats.org/drawingml/2006/main" noGrp="1"/>
+          </p:cNvSpPr>
+          <p:nvPr/>
+        </p:nvSpPr>
+        <p:spPr>
+          <a:xfrm xmlns:a="http://schemas.openxmlformats.org/drawingml/2006/main">
+            <a:off x="7600950" y="3981450"/>
+            <a:ext cx="476250" cy="190500"/>
+          </a:xfrm>
+          <a:prstGeom xmlns:a="http://schemas.openxmlformats.org/drawingml/2006/main" prst="rect">
+            <a:avLst/>
+          </a:prstGeom>
+          <a:noFill xmlns:a="http://schemas.openxmlformats.org/drawingml/2006/main"/>
+          <a:ln xmlns:a="http://schemas.openxmlformats.org/drawingml/2006/main" w="0">
+            <a:noFill/>
+          </a:ln>
+        </p:spPr>
+        <p:txBody>
+          <a:bodyPr xmlns:a="http://schemas.openxmlformats.org/drawingml/2006/main">
+            <a:normAutofit fontScale="72222"/>
           </a:bodyPr>
           <a:lstStyle xmlns:a="http://schemas.openxmlformats.org/drawingml/2006/main"/>
           <a:p xmlns:a="http://schemas.openxmlformats.org/drawingml/2006/main">
             <a:pPr>
               <a:defRPr sz="900" b="1">
                 <a:solidFill>
-                  <a:srgbClr val="FFFFFF"/>
+                  <a:srgbClr val="B8742A"/>
                 </a:solidFill>
                 <a:latin typeface="Bitstream Charter"/>
                 <a:ea typeface="Bitstream Charter"/>
@@ -7407,35 +7916,35 @@
             <a:r>
               <a:rPr sz="900" b="1">
                 <a:solidFill>
-                  <a:srgbClr val="FFFFFF"/>
-                </a:solidFill>
-                <a:latin typeface="Bitstream Charter"/>
-                <a:ea typeface="Bitstream Charter"/>
-                <a:cs typeface="Bitstream Charter"/>
-              </a:rPr>
-              <a:t>✓</a:t>
-            </a:r>
-          </a:p>
-        </p:txBody>
-      </p:sp>
-      <p:sp>
-        <p:nvSpPr>
-          <p:cNvPr id="17" name="">
-            <a:extLst xmlns:a="http://schemas.openxmlformats.org/drawingml/2006/main">
-              <a:ext uri="{FF2B5EF4-FFF2-40B4-BE49-F238E27FC236}">
-                <a16:creationId xmlns:a16="http://schemas.microsoft.com/office/drawing/2014/main" id="{198DACAC-D43F-487C-8AE1-74EB144A7778}"/>
-              </a:ext>
-            </a:extLst>
-          </p:cNvPr>
-          <p:cNvSpPr>
-            <a:spLocks xmlns:a="http://schemas.openxmlformats.org/drawingml/2006/main" noGrp="1"/>
-          </p:cNvSpPr>
-          <p:nvPr/>
-        </p:nvSpPr>
-        <p:spPr>
-          <a:xfrm xmlns:a="http://schemas.openxmlformats.org/drawingml/2006/main">
-            <a:off x="1047750" y="5276850"/>
-            <a:ext cx="9486900" cy="514350"/>
+                  <a:srgbClr val="B8742A"/>
+                </a:solidFill>
+                <a:latin typeface="Bitstream Charter"/>
+                <a:ea typeface="Bitstream Charter"/>
+                <a:cs typeface="Bitstream Charter"/>
+              </a:rPr>
+              <a:t>03</a:t>
+            </a:r>
+          </a:p>
+        </p:txBody>
+      </p:sp>
+      <p:sp>
+        <p:nvSpPr>
+          <p:cNvPr id="21" name="">
+            <a:extLst xmlns:a="http://schemas.openxmlformats.org/drawingml/2006/main">
+              <a:ext uri="{FF2B5EF4-FFF2-40B4-BE49-F238E27FC236}">
+                <a16:creationId xmlns:a16="http://schemas.microsoft.com/office/drawing/2014/main" id="{5C574AF0-1F1B-4DAB-869F-E3CA3B82C8A1}"/>
+              </a:ext>
+            </a:extLst>
+          </p:cNvPr>
+          <p:cNvSpPr>
+            <a:spLocks xmlns:a="http://schemas.openxmlformats.org/drawingml/2006/main" noGrp="1"/>
+          </p:cNvSpPr>
+          <p:nvPr/>
+        </p:nvSpPr>
+        <p:spPr>
+          <a:xfrm xmlns:a="http://schemas.openxmlformats.org/drawingml/2006/main">
+            <a:off x="7600950" y="4286250"/>
+            <a:ext cx="2628900" cy="457200"/>
           </a:xfrm>
           <a:prstGeom xmlns:a="http://schemas.openxmlformats.org/drawingml/2006/main" prst="rect">
             <a:avLst/>
@@ -7452,25 +7961,82 @@
           <a:lstStyle xmlns:a="http://schemas.openxmlformats.org/drawingml/2006/main"/>
           <a:p xmlns:a="http://schemas.openxmlformats.org/drawingml/2006/main">
             <a:pPr>
-              <a:defRPr sz="1350" b="0">
-                <a:solidFill>
-                  <a:srgbClr val="394B61"/>
-                </a:solidFill>
-                <a:latin typeface="Bitstream Charter"/>
-                <a:ea typeface="Bitstream Charter"/>
-                <a:cs typeface="Bitstream Charter"/>
-              </a:defRPr>
-            </a:pPr>
-            <a:r>
-              <a:rPr sz="1350" b="0">
-                <a:solidFill>
-                  <a:srgbClr val="394B61"/>
-                </a:solidFill>
-                <a:latin typeface="Bitstream Charter"/>
-                <a:ea typeface="Bitstream Charter"/>
-                <a:cs typeface="Bitstream Charter"/>
-              </a:rPr>
-              <a:t>Action checklist and evidence pack</a:t>
+              <a:defRPr sz="1500" b="1">
+                <a:solidFill>
+                  <a:srgbClr val="102C55"/>
+                </a:solidFill>
+                <a:latin typeface="Bitstream Charter"/>
+                <a:ea typeface="Bitstream Charter"/>
+                <a:cs typeface="Bitstream Charter"/>
+              </a:defRPr>
+            </a:pPr>
+            <a:r>
+              <a:rPr sz="1500" b="1">
+                <a:solidFill>
+                  <a:srgbClr val="102C55"/>
+                </a:solidFill>
+                <a:latin typeface="Bitstream Charter"/>
+                <a:ea typeface="Bitstream Charter"/>
+                <a:cs typeface="Bitstream Charter"/>
+              </a:rPr>
+              <a:t>Receive The Action Plan</a:t>
+            </a:r>
+          </a:p>
+        </p:txBody>
+      </p:sp>
+      <p:sp>
+        <p:nvSpPr>
+          <p:cNvPr id="22" name="">
+            <a:extLst xmlns:a="http://schemas.openxmlformats.org/drawingml/2006/main">
+              <a:ext uri="{FF2B5EF4-FFF2-40B4-BE49-F238E27FC236}">
+                <a16:creationId xmlns:a16="http://schemas.microsoft.com/office/drawing/2014/main" id="{A37FA64C-DD91-4A79-94B7-5EAECE0C7AA7}"/>
+              </a:ext>
+            </a:extLst>
+          </p:cNvPr>
+          <p:cNvSpPr>
+            <a:spLocks xmlns:a="http://schemas.openxmlformats.org/drawingml/2006/main" noGrp="1"/>
+          </p:cNvSpPr>
+          <p:nvPr/>
+        </p:nvSpPr>
+        <p:spPr>
+          <a:xfrm xmlns:a="http://schemas.openxmlformats.org/drawingml/2006/main">
+            <a:off x="7600950" y="4857750"/>
+            <a:ext cx="2628900" cy="457200"/>
+          </a:xfrm>
+          <a:prstGeom xmlns:a="http://schemas.openxmlformats.org/drawingml/2006/main" prst="rect">
+            <a:avLst/>
+          </a:prstGeom>
+          <a:noFill xmlns:a="http://schemas.openxmlformats.org/drawingml/2006/main"/>
+          <a:ln xmlns:a="http://schemas.openxmlformats.org/drawingml/2006/main" w="0">
+            <a:noFill/>
+          </a:ln>
+        </p:spPr>
+        <p:txBody>
+          <a:bodyPr xmlns:a="http://schemas.openxmlformats.org/drawingml/2006/main">
+            <a:normAutofit fontScale="100000"/>
+          </a:bodyPr>
+          <a:lstStyle xmlns:a="http://schemas.openxmlformats.org/drawingml/2006/main"/>
+          <a:p xmlns:a="http://schemas.openxmlformats.org/drawingml/2006/main">
+            <a:pPr>
+              <a:defRPr sz="1050" b="0">
+                <a:solidFill>
+                  <a:srgbClr val="526177"/>
+                </a:solidFill>
+                <a:latin typeface="Bitstream Charter"/>
+                <a:ea typeface="Bitstream Charter"/>
+                <a:cs typeface="Bitstream Charter"/>
+              </a:defRPr>
+            </a:pPr>
+            <a:r>
+              <a:rPr sz="1050" b="0">
+                <a:solidFill>
+                  <a:srgbClr val="526177"/>
+                </a:solidFill>
+                <a:latin typeface="Bitstream Charter"/>
+                <a:ea typeface="Bitstream Charter"/>
+                <a:cs typeface="Bitstream Charter"/>
+              </a:rPr>
+              <a:t>Get required documents, deadlines, and any question held for expert review.</a:t>
             </a:r>
           </a:p>
         </p:txBody>
@@ -7478,7 +8044,7 @@
     </p:spTree>
     <p:extLst>
       <p:ext uri="{BB962C8B-B14F-4D97-AF65-F5344CB8AC3E}">
-        <p14:creationId xmlns:p14="http://schemas.microsoft.com/office/powerpoint/2010/main" val="634512218"/>
+        <p14:creationId xmlns:p14="http://schemas.microsoft.com/office/powerpoint/2010/main" val="2040084793"/>
       </p:ext>
     </p:extLst>
   </p:cSld>
@@ -7509,7 +8075,7 @@
           <p:cNvPr id="20" name="">
             <a:extLst xmlns:a="http://schemas.openxmlformats.org/drawingml/2006/main">
               <a:ext uri="{FF2B5EF4-FFF2-40B4-BE49-F238E27FC236}">
-                <a16:creationId xmlns:a16="http://schemas.microsoft.com/office/drawing/2014/main" id="{C09963BB-3E45-49D4-8298-FA3F64AC3931}"/>
+                <a16:creationId xmlns:a16="http://schemas.microsoft.com/office/drawing/2014/main" id="{0DF3F5C3-BFF2-482C-9D16-7BA399F12DCE}"/>
               </a:ext>
             </a:extLst>
           </p:cNvPr>
@@ -7539,7 +8105,7 @@
           <p:cNvPr id="2" name="">
             <a:extLst xmlns:a="http://schemas.openxmlformats.org/drawingml/2006/main">
               <a:ext uri="{FF2B5EF4-FFF2-40B4-BE49-F238E27FC236}">
-                <a16:creationId xmlns:a16="http://schemas.microsoft.com/office/drawing/2014/main" id="{9D08A1D8-618F-41D9-85A0-CED8168E0549}"/>
+                <a16:creationId xmlns:a16="http://schemas.microsoft.com/office/drawing/2014/main" id="{4395894D-A324-4A49-B893-8919A628AF5A}"/>
               </a:ext>
             </a:extLst>
           </p:cNvPr>
@@ -7596,7 +8162,7 @@
           <p:cNvPr id="3" name="">
             <a:extLst xmlns:a="http://schemas.openxmlformats.org/drawingml/2006/main">
               <a:ext uri="{FF2B5EF4-FFF2-40B4-BE49-F238E27FC236}">
-                <a16:creationId xmlns:a16="http://schemas.microsoft.com/office/drawing/2014/main" id="{781ADD5E-CE31-4295-87DB-C32BAAAFE6C7}"/>
+                <a16:creationId xmlns:a16="http://schemas.microsoft.com/office/drawing/2014/main" id="{BA4F45AE-96FD-4EE4-8F71-703F89983E9C}"/>
               </a:ext>
             </a:extLst>
           </p:cNvPr>
@@ -7653,7 +8219,7 @@
           <p:cNvPr id="4" name="">
             <a:extLst xmlns:a="http://schemas.openxmlformats.org/drawingml/2006/main">
               <a:ext uri="{FF2B5EF4-FFF2-40B4-BE49-F238E27FC236}">
-                <a16:creationId xmlns:a16="http://schemas.microsoft.com/office/drawing/2014/main" id="{EB101225-AEAF-4A17-812F-1EE8719CB136}"/>
+                <a16:creationId xmlns:a16="http://schemas.microsoft.com/office/drawing/2014/main" id="{88E7CC7B-43E3-4AA7-A9B6-68ABB03D52CF}"/>
               </a:ext>
             </a:extLst>
           </p:cNvPr>
@@ -7710,7 +8276,7 @@
           <p:cNvPr id="5" name="">
             <a:extLst xmlns:a="http://schemas.openxmlformats.org/drawingml/2006/main">
               <a:ext uri="{FF2B5EF4-FFF2-40B4-BE49-F238E27FC236}">
-                <a16:creationId xmlns:a16="http://schemas.microsoft.com/office/drawing/2014/main" id="{FAA47B80-3FBB-412F-A68C-8A9ADFEE6623}"/>
+                <a16:creationId xmlns:a16="http://schemas.microsoft.com/office/drawing/2014/main" id="{F95EFF96-B496-444F-9FDB-D1CC19F8C31C}"/>
               </a:ext>
             </a:extLst>
           </p:cNvPr>
@@ -7767,7 +8333,7 @@
           <p:cNvPr id="6" name="">
             <a:extLst xmlns:a="http://schemas.openxmlformats.org/drawingml/2006/main">
               <a:ext uri="{FF2B5EF4-FFF2-40B4-BE49-F238E27FC236}">
-                <a16:creationId xmlns:a16="http://schemas.microsoft.com/office/drawing/2014/main" id="{3187D09F-7B2D-4D5E-B257-E912DB9A6CCE}"/>
+                <a16:creationId xmlns:a16="http://schemas.microsoft.com/office/drawing/2014/main" id="{8EF6E2AB-27D8-4425-80F4-5AEFC8BBDAC9}"/>
               </a:ext>
             </a:extLst>
           </p:cNvPr>
@@ -7824,7 +8390,7 @@
           <p:cNvPr id="7" name="">
             <a:extLst xmlns:a="http://schemas.openxmlformats.org/drawingml/2006/main">
               <a:ext uri="{FF2B5EF4-FFF2-40B4-BE49-F238E27FC236}">
-                <a16:creationId xmlns:a16="http://schemas.microsoft.com/office/drawing/2014/main" id="{2286B417-CD17-4CDD-A803-2AD16C536CE9}"/>
+                <a16:creationId xmlns:a16="http://schemas.microsoft.com/office/drawing/2014/main" id="{74792C47-35C7-448B-8361-A039966E807C}"/>
               </a:ext>
             </a:extLst>
           </p:cNvPr>
@@ -7881,7 +8447,7 @@
           <p:cNvPr id="8" name="">
             <a:extLst xmlns:a="http://schemas.openxmlformats.org/drawingml/2006/main">
               <a:ext uri="{FF2B5EF4-FFF2-40B4-BE49-F238E27FC236}">
-                <a16:creationId xmlns:a16="http://schemas.microsoft.com/office/drawing/2014/main" id="{BF61333F-A2BD-44BB-90E1-4C47808D6E82}"/>
+                <a16:creationId xmlns:a16="http://schemas.microsoft.com/office/drawing/2014/main" id="{53334881-D656-4E02-9F1C-87C83309ACAF}"/>
               </a:ext>
             </a:extLst>
           </p:cNvPr>
@@ -7913,7 +8479,7 @@
           <p:cNvPr id="9" name="">
             <a:extLst xmlns:a="http://schemas.openxmlformats.org/drawingml/2006/main">
               <a:ext uri="{FF2B5EF4-FFF2-40B4-BE49-F238E27FC236}">
-                <a16:creationId xmlns:a16="http://schemas.microsoft.com/office/drawing/2014/main" id="{EDD15E24-6E34-4AE5-B840-573418BF0B9A}"/>
+                <a16:creationId xmlns:a16="http://schemas.microsoft.com/office/drawing/2014/main" id="{502BD9E2-8111-4673-BEE8-4F8088AFBF09}"/>
               </a:ext>
             </a:extLst>
           </p:cNvPr>
@@ -7970,7 +8536,7 @@
           <p:cNvPr id="10" name="">
             <a:extLst xmlns:a="http://schemas.openxmlformats.org/drawingml/2006/main">
               <a:ext uri="{FF2B5EF4-FFF2-40B4-BE49-F238E27FC236}">
-                <a16:creationId xmlns:a16="http://schemas.microsoft.com/office/drawing/2014/main" id="{D4AA74A9-036E-449D-93C1-57C1858D9427}"/>
+                <a16:creationId xmlns:a16="http://schemas.microsoft.com/office/drawing/2014/main" id="{CD02D08B-9B7B-4ADF-9A35-CC010099F19E}"/>
               </a:ext>
             </a:extLst>
           </p:cNvPr>
@@ -8027,7 +8593,7 @@
           <p:cNvPr id="11" name="">
             <a:extLst xmlns:a="http://schemas.openxmlformats.org/drawingml/2006/main">
               <a:ext uri="{FF2B5EF4-FFF2-40B4-BE49-F238E27FC236}">
-                <a16:creationId xmlns:a16="http://schemas.microsoft.com/office/drawing/2014/main" id="{EC5763E1-CC80-48E8-846C-E87BFE352A65}"/>
+                <a16:creationId xmlns:a16="http://schemas.microsoft.com/office/drawing/2014/main" id="{03552DC7-AEA5-43A5-894B-C18B2092A814}"/>
               </a:ext>
             </a:extLst>
           </p:cNvPr>
@@ -8059,7 +8625,7 @@
           <p:cNvPr id="12" name="">
             <a:extLst xmlns:a="http://schemas.openxmlformats.org/drawingml/2006/main">
               <a:ext uri="{FF2B5EF4-FFF2-40B4-BE49-F238E27FC236}">
-                <a16:creationId xmlns:a16="http://schemas.microsoft.com/office/drawing/2014/main" id="{CC5BE7F2-7395-4600-9578-F6A21896149F}"/>
+                <a16:creationId xmlns:a16="http://schemas.microsoft.com/office/drawing/2014/main" id="{D4EA3563-7CE2-4848-AE2E-F2E156746426}"/>
               </a:ext>
             </a:extLst>
           </p:cNvPr>
@@ -8116,7 +8682,7 @@
           <p:cNvPr id="13" name="">
             <a:extLst xmlns:a="http://schemas.openxmlformats.org/drawingml/2006/main">
               <a:ext uri="{FF2B5EF4-FFF2-40B4-BE49-F238E27FC236}">
-                <a16:creationId xmlns:a16="http://schemas.microsoft.com/office/drawing/2014/main" id="{8EA29542-E125-4FFA-BA38-B20044235435}"/>
+                <a16:creationId xmlns:a16="http://schemas.microsoft.com/office/drawing/2014/main" id="{D9F59D9A-182E-4AA9-9F94-9EC9CFE078F8}"/>
               </a:ext>
             </a:extLst>
           </p:cNvPr>
@@ -8173,7 +8739,7 @@
           <p:cNvPr id="14" name="">
             <a:extLst xmlns:a="http://schemas.openxmlformats.org/drawingml/2006/main">
               <a:ext uri="{FF2B5EF4-FFF2-40B4-BE49-F238E27FC236}">
-                <a16:creationId xmlns:a16="http://schemas.microsoft.com/office/drawing/2014/main" id="{9686AD80-8F48-4E88-AC95-2E2B3B0F6BD8}"/>
+                <a16:creationId xmlns:a16="http://schemas.microsoft.com/office/drawing/2014/main" id="{168C6782-C7E5-4265-AC61-37D512A0A871}"/>
               </a:ext>
             </a:extLst>
           </p:cNvPr>
@@ -8205,7 +8771,7 @@
           <p:cNvPr id="15" name="">
             <a:extLst xmlns:a="http://schemas.openxmlformats.org/drawingml/2006/main">
               <a:ext uri="{FF2B5EF4-FFF2-40B4-BE49-F238E27FC236}">
-                <a16:creationId xmlns:a16="http://schemas.microsoft.com/office/drawing/2014/main" id="{FDA1F320-5B5E-447C-8A2E-9C661DA0F7D5}"/>
+                <a16:creationId xmlns:a16="http://schemas.microsoft.com/office/drawing/2014/main" id="{DBE1DE09-EE69-4294-92CC-F8DA0821BFD1}"/>
               </a:ext>
             </a:extLst>
           </p:cNvPr>
@@ -8262,7 +8828,7 @@
           <p:cNvPr id="16" name="">
             <a:extLst xmlns:a="http://schemas.openxmlformats.org/drawingml/2006/main">
               <a:ext uri="{FF2B5EF4-FFF2-40B4-BE49-F238E27FC236}">
-                <a16:creationId xmlns:a16="http://schemas.microsoft.com/office/drawing/2014/main" id="{ED5C2754-9AD5-4663-8192-420327B1E11F}"/>
+                <a16:creationId xmlns:a16="http://schemas.microsoft.com/office/drawing/2014/main" id="{B9F08DA4-8E20-46DF-93F4-30D34B7C0A13}"/>
               </a:ext>
             </a:extLst>
           </p:cNvPr>
@@ -8319,7 +8885,7 @@
           <p:cNvPr id="17" name="">
             <a:extLst xmlns:a="http://schemas.openxmlformats.org/drawingml/2006/main">
               <a:ext uri="{FF2B5EF4-FFF2-40B4-BE49-F238E27FC236}">
-                <a16:creationId xmlns:a16="http://schemas.microsoft.com/office/drawing/2014/main" id="{F35CFDCE-4F04-4910-B8B0-856597B7D246}"/>
+                <a16:creationId xmlns:a16="http://schemas.microsoft.com/office/drawing/2014/main" id="{7A538BEB-07CE-4CFC-A00E-3568AF6E35D4}"/>
               </a:ext>
             </a:extLst>
           </p:cNvPr>
@@ -8351,7 +8917,7 @@
           <p:cNvPr id="18" name="">
             <a:extLst xmlns:a="http://schemas.openxmlformats.org/drawingml/2006/main">
               <a:ext uri="{FF2B5EF4-FFF2-40B4-BE49-F238E27FC236}">
-                <a16:creationId xmlns:a16="http://schemas.microsoft.com/office/drawing/2014/main" id="{264264A8-9B71-429B-821B-71CA2CDAB7BA}"/>
+                <a16:creationId xmlns:a16="http://schemas.microsoft.com/office/drawing/2014/main" id="{7C6C0B49-9082-4F83-BB53-DC8AF4FFB991}"/>
               </a:ext>
             </a:extLst>
           </p:cNvPr>
@@ -8408,7 +8974,7 @@
           <p:cNvPr id="19" name="">
             <a:extLst xmlns:a="http://schemas.openxmlformats.org/drawingml/2006/main">
               <a:ext uri="{FF2B5EF4-FFF2-40B4-BE49-F238E27FC236}">
-                <a16:creationId xmlns:a16="http://schemas.microsoft.com/office/drawing/2014/main" id="{0DB8BD8F-A54B-449D-8311-BC339BF69637}"/>
+                <a16:creationId xmlns:a16="http://schemas.microsoft.com/office/drawing/2014/main" id="{4E455696-8779-440C-9AA5-E52931ECA405}"/>
               </a:ext>
             </a:extLst>
           </p:cNvPr>
@@ -8463,7 +9029,7 @@
     </p:spTree>
     <p:extLst>
       <p:ext uri="{BB962C8B-B14F-4D97-AF65-F5344CB8AC3E}">
-        <p14:creationId xmlns:p14="http://schemas.microsoft.com/office/powerpoint/2010/main" val="1908688784"/>
+        <p14:creationId xmlns:p14="http://schemas.microsoft.com/office/powerpoint/2010/main" val="1666338328"/>
       </p:ext>
     </p:extLst>
   </p:cSld>
@@ -8494,7 +9060,7 @@
           <p:cNvPr id="20" name="">
             <a:extLst xmlns:a="http://schemas.openxmlformats.org/drawingml/2006/main">
               <a:ext uri="{FF2B5EF4-FFF2-40B4-BE49-F238E27FC236}">
-                <a16:creationId xmlns:a16="http://schemas.microsoft.com/office/drawing/2014/main" id="{BFBB66C7-D908-4E0B-B6BF-23D7084DBF36}"/>
+                <a16:creationId xmlns:a16="http://schemas.microsoft.com/office/drawing/2014/main" id="{3BDFFDB4-96C3-4B51-971E-16FA87ED655D}"/>
               </a:ext>
             </a:extLst>
           </p:cNvPr>
@@ -8524,7 +9090,7 @@
           <p:cNvPr id="2" name="">
             <a:extLst xmlns:a="http://schemas.openxmlformats.org/drawingml/2006/main">
               <a:ext uri="{FF2B5EF4-FFF2-40B4-BE49-F238E27FC236}">
-                <a16:creationId xmlns:a16="http://schemas.microsoft.com/office/drawing/2014/main" id="{256E3FE3-4B0B-4AEC-AECE-0AD6B566C01A}"/>
+                <a16:creationId xmlns:a16="http://schemas.microsoft.com/office/drawing/2014/main" id="{65C1C758-EF0A-48C0-88EE-5DB0D4BB0533}"/>
               </a:ext>
             </a:extLst>
           </p:cNvPr>
@@ -8581,7 +9147,7 @@
           <p:cNvPr id="3" name="">
             <a:extLst xmlns:a="http://schemas.openxmlformats.org/drawingml/2006/main">
               <a:ext uri="{FF2B5EF4-FFF2-40B4-BE49-F238E27FC236}">
-                <a16:creationId xmlns:a16="http://schemas.microsoft.com/office/drawing/2014/main" id="{2EF12520-6BE5-445F-8529-9FE3D805B3F3}"/>
+                <a16:creationId xmlns:a16="http://schemas.microsoft.com/office/drawing/2014/main" id="{A0C1D678-006B-437E-AD9B-EDC7B566B5D3}"/>
               </a:ext>
             </a:extLst>
           </p:cNvPr>
@@ -8638,7 +9204,7 @@
           <p:cNvPr id="4" name="">
             <a:extLst xmlns:a="http://schemas.openxmlformats.org/drawingml/2006/main">
               <a:ext uri="{FF2B5EF4-FFF2-40B4-BE49-F238E27FC236}">
-                <a16:creationId xmlns:a16="http://schemas.microsoft.com/office/drawing/2014/main" id="{578C9D6B-9D54-489F-994F-EC7D5D953FA1}"/>
+                <a16:creationId xmlns:a16="http://schemas.microsoft.com/office/drawing/2014/main" id="{F0071B70-1F2D-4C40-A760-69062B47D985}"/>
               </a:ext>
             </a:extLst>
           </p:cNvPr>
@@ -8695,7 +9261,7 @@
           <p:cNvPr id="5" name="">
             <a:extLst xmlns:a="http://schemas.openxmlformats.org/drawingml/2006/main">
               <a:ext uri="{FF2B5EF4-FFF2-40B4-BE49-F238E27FC236}">
-                <a16:creationId xmlns:a16="http://schemas.microsoft.com/office/drawing/2014/main" id="{06421E00-50CA-4BAF-8E77-9CBADA9514E7}"/>
+                <a16:creationId xmlns:a16="http://schemas.microsoft.com/office/drawing/2014/main" id="{D45ECABA-9279-4544-AECA-2E63E3301AB6}"/>
               </a:ext>
             </a:extLst>
           </p:cNvPr>
@@ -8752,7 +9318,7 @@
           <p:cNvPr id="6" name="">
             <a:extLst xmlns:a="http://schemas.openxmlformats.org/drawingml/2006/main">
               <a:ext uri="{FF2B5EF4-FFF2-40B4-BE49-F238E27FC236}">
-                <a16:creationId xmlns:a16="http://schemas.microsoft.com/office/drawing/2014/main" id="{5F8442AD-FA75-46EE-A699-76841D201DF5}"/>
+                <a16:creationId xmlns:a16="http://schemas.microsoft.com/office/drawing/2014/main" id="{36742BFC-3C7B-427A-9638-A9B093F70A2F}"/>
               </a:ext>
             </a:extLst>
           </p:cNvPr>
@@ -8809,7 +9375,7 @@
           <p:cNvPr id="7" name="">
             <a:extLst xmlns:a="http://schemas.openxmlformats.org/drawingml/2006/main">
               <a:ext uri="{FF2B5EF4-FFF2-40B4-BE49-F238E27FC236}">
-                <a16:creationId xmlns:a16="http://schemas.microsoft.com/office/drawing/2014/main" id="{CCB517AD-1D20-42B5-82A7-8D98A9C1A715}"/>
+                <a16:creationId xmlns:a16="http://schemas.microsoft.com/office/drawing/2014/main" id="{7082D74E-B633-4B45-9799-2D8E8708DE95}"/>
               </a:ext>
             </a:extLst>
           </p:cNvPr>
@@ -8866,7 +9432,7 @@
           <p:cNvPr id="8" name="">
             <a:extLst xmlns:a="http://schemas.openxmlformats.org/drawingml/2006/main">
               <a:ext uri="{FF2B5EF4-FFF2-40B4-BE49-F238E27FC236}">
-                <a16:creationId xmlns:a16="http://schemas.microsoft.com/office/drawing/2014/main" id="{0F4A8177-AFE6-4A96-B990-8D5BEA36BD94}"/>
+                <a16:creationId xmlns:a16="http://schemas.microsoft.com/office/drawing/2014/main" id="{D18BC034-07C1-400B-93AD-290CAFCBF56A}"/>
               </a:ext>
             </a:extLst>
           </p:cNvPr>
@@ -8898,7 +9464,7 @@
           <p:cNvPr id="9" name="">
             <a:extLst xmlns:a="http://schemas.openxmlformats.org/drawingml/2006/main">
               <a:ext uri="{FF2B5EF4-FFF2-40B4-BE49-F238E27FC236}">
-                <a16:creationId xmlns:a16="http://schemas.microsoft.com/office/drawing/2014/main" id="{3E51ED30-6EF7-495F-A175-B2EC98FE503E}"/>
+                <a16:creationId xmlns:a16="http://schemas.microsoft.com/office/drawing/2014/main" id="{70F0DAE7-7152-4DD9-9E1A-8CB2D412967C}"/>
               </a:ext>
             </a:extLst>
           </p:cNvPr>
@@ -8955,7 +9521,7 @@
           <p:cNvPr id="10" name="">
             <a:extLst xmlns:a="http://schemas.openxmlformats.org/drawingml/2006/main">
               <a:ext uri="{FF2B5EF4-FFF2-40B4-BE49-F238E27FC236}">
-                <a16:creationId xmlns:a16="http://schemas.microsoft.com/office/drawing/2014/main" id="{0BFEB930-4588-463C-BFB1-60FD4334C99A}"/>
+                <a16:creationId xmlns:a16="http://schemas.microsoft.com/office/drawing/2014/main" id="{26F7A778-44DF-4B7A-9843-78FB01CAD499}"/>
               </a:ext>
             </a:extLst>
           </p:cNvPr>
@@ -9012,7 +9578,7 @@
           <p:cNvPr id="11" name="">
             <a:extLst xmlns:a="http://schemas.openxmlformats.org/drawingml/2006/main">
               <a:ext uri="{FF2B5EF4-FFF2-40B4-BE49-F238E27FC236}">
-                <a16:creationId xmlns:a16="http://schemas.microsoft.com/office/drawing/2014/main" id="{713CA97D-A236-4026-A03E-405DF12C0E9B}"/>
+                <a16:creationId xmlns:a16="http://schemas.microsoft.com/office/drawing/2014/main" id="{36911D06-9C56-44F9-B230-F6EF06D71F82}"/>
               </a:ext>
             </a:extLst>
           </p:cNvPr>
@@ -9044,7 +9610,7 @@
           <p:cNvPr id="12" name="">
             <a:extLst xmlns:a="http://schemas.openxmlformats.org/drawingml/2006/main">
               <a:ext uri="{FF2B5EF4-FFF2-40B4-BE49-F238E27FC236}">
-                <a16:creationId xmlns:a16="http://schemas.microsoft.com/office/drawing/2014/main" id="{CAC1E7AA-2419-4089-9D83-ACF5B1ECD2E9}"/>
+                <a16:creationId xmlns:a16="http://schemas.microsoft.com/office/drawing/2014/main" id="{D5FC6532-C640-4588-A15C-A80895BECE34}"/>
               </a:ext>
             </a:extLst>
           </p:cNvPr>
@@ -9101,7 +9667,7 @@
           <p:cNvPr id="13" name="">
             <a:extLst xmlns:a="http://schemas.openxmlformats.org/drawingml/2006/main">
               <a:ext uri="{FF2B5EF4-FFF2-40B4-BE49-F238E27FC236}">
-                <a16:creationId xmlns:a16="http://schemas.microsoft.com/office/drawing/2014/main" id="{2D7AA124-6FFB-443A-9A2F-4BE0FEF0B9B4}"/>
+                <a16:creationId xmlns:a16="http://schemas.microsoft.com/office/drawing/2014/main" id="{767FE482-C0F5-47B7-897B-DE602D6D265B}"/>
               </a:ext>
             </a:extLst>
           </p:cNvPr>
@@ -9158,7 +9724,7 @@
           <p:cNvPr id="14" name="">
             <a:extLst xmlns:a="http://schemas.openxmlformats.org/drawingml/2006/main">
               <a:ext uri="{FF2B5EF4-FFF2-40B4-BE49-F238E27FC236}">
-                <a16:creationId xmlns:a16="http://schemas.microsoft.com/office/drawing/2014/main" id="{110F7152-4004-4352-9468-2E309B118992}"/>
+                <a16:creationId xmlns:a16="http://schemas.microsoft.com/office/drawing/2014/main" id="{B954CF40-C4AA-4AA1-A06B-8D317214F8F3}"/>
               </a:ext>
             </a:extLst>
           </p:cNvPr>
@@ -9190,7 +9756,7 @@
           <p:cNvPr id="15" name="">
             <a:extLst xmlns:a="http://schemas.openxmlformats.org/drawingml/2006/main">
               <a:ext uri="{FF2B5EF4-FFF2-40B4-BE49-F238E27FC236}">
-                <a16:creationId xmlns:a16="http://schemas.microsoft.com/office/drawing/2014/main" id="{F2707BED-5A9A-4A26-AA96-6DD08D494777}"/>
+                <a16:creationId xmlns:a16="http://schemas.microsoft.com/office/drawing/2014/main" id="{49CBBFD9-5B1A-4C7B-B018-BE2500FBBB99}"/>
               </a:ext>
             </a:extLst>
           </p:cNvPr>
@@ -9247,7 +9813,7 @@
           <p:cNvPr id="16" name="">
             <a:extLst xmlns:a="http://schemas.openxmlformats.org/drawingml/2006/main">
               <a:ext uri="{FF2B5EF4-FFF2-40B4-BE49-F238E27FC236}">
-                <a16:creationId xmlns:a16="http://schemas.microsoft.com/office/drawing/2014/main" id="{CE6A763A-76EE-451C-B6E2-7E899E958F85}"/>
+                <a16:creationId xmlns:a16="http://schemas.microsoft.com/office/drawing/2014/main" id="{3D7E65A3-AC39-4E06-8E90-2437FDC0785F}"/>
               </a:ext>
             </a:extLst>
           </p:cNvPr>
@@ -9304,7 +9870,7 @@
           <p:cNvPr id="17" name="">
             <a:extLst xmlns:a="http://schemas.openxmlformats.org/drawingml/2006/main">
               <a:ext uri="{FF2B5EF4-FFF2-40B4-BE49-F238E27FC236}">
-                <a16:creationId xmlns:a16="http://schemas.microsoft.com/office/drawing/2014/main" id="{82E87205-F0FB-4D72-B5CB-7DAAF56AC852}"/>
+                <a16:creationId xmlns:a16="http://schemas.microsoft.com/office/drawing/2014/main" id="{329AD645-1637-4E49-82C6-62C464A10A11}"/>
               </a:ext>
             </a:extLst>
           </p:cNvPr>
@@ -9336,7 +9902,7 @@
           <p:cNvPr id="18" name="">
             <a:extLst xmlns:a="http://schemas.openxmlformats.org/drawingml/2006/main">
               <a:ext uri="{FF2B5EF4-FFF2-40B4-BE49-F238E27FC236}">
-                <a16:creationId xmlns:a16="http://schemas.microsoft.com/office/drawing/2014/main" id="{611847E3-2120-4CA6-B90D-63C0C23FF9FC}"/>
+                <a16:creationId xmlns:a16="http://schemas.microsoft.com/office/drawing/2014/main" id="{D4114436-8553-4556-95B2-604511F9461F}"/>
               </a:ext>
             </a:extLst>
           </p:cNvPr>
@@ -9393,7 +9959,7 @@
           <p:cNvPr id="19" name="">
             <a:extLst xmlns:a="http://schemas.openxmlformats.org/drawingml/2006/main">
               <a:ext uri="{FF2B5EF4-FFF2-40B4-BE49-F238E27FC236}">
-                <a16:creationId xmlns:a16="http://schemas.microsoft.com/office/drawing/2014/main" id="{61B0E359-DCC8-4AF8-B4CF-F525747D0835}"/>
+                <a16:creationId xmlns:a16="http://schemas.microsoft.com/office/drawing/2014/main" id="{85D97A24-1878-49AB-A891-36C044C3FE6D}"/>
               </a:ext>
             </a:extLst>
           </p:cNvPr>
@@ -9448,7 +10014,7 @@
     </p:spTree>
     <p:extLst>
       <p:ext uri="{BB962C8B-B14F-4D97-AF65-F5344CB8AC3E}">
-        <p14:creationId xmlns:p14="http://schemas.microsoft.com/office/powerpoint/2010/main" val="105063588"/>
+        <p14:creationId xmlns:p14="http://schemas.microsoft.com/office/powerpoint/2010/main" val="1342800532"/>
       </p:ext>
     </p:extLst>
   </p:cSld>
@@ -9479,7 +10045,7 @@
           <p:cNvPr id="17" name="">
             <a:extLst xmlns:a="http://schemas.openxmlformats.org/drawingml/2006/main">
               <a:ext uri="{FF2B5EF4-FFF2-40B4-BE49-F238E27FC236}">
-                <a16:creationId xmlns:a16="http://schemas.microsoft.com/office/drawing/2014/main" id="{7A78D4BE-589E-4637-8FD6-B254C6D7A5AB}"/>
+                <a16:creationId xmlns:a16="http://schemas.microsoft.com/office/drawing/2014/main" id="{D82F3B70-4174-4C2D-BEC8-10F89DF63CE7}"/>
               </a:ext>
             </a:extLst>
           </p:cNvPr>
@@ -9509,7 +10075,7 @@
           <p:cNvPr id="2" name="">
             <a:extLst xmlns:a="http://schemas.openxmlformats.org/drawingml/2006/main">
               <a:ext uri="{FF2B5EF4-FFF2-40B4-BE49-F238E27FC236}">
-                <a16:creationId xmlns:a16="http://schemas.microsoft.com/office/drawing/2014/main" id="{4B58C5FB-E773-4700-A821-B7C885A33E35}"/>
+                <a16:creationId xmlns:a16="http://schemas.microsoft.com/office/drawing/2014/main" id="{3AC50E17-4986-4866-975C-5731B3665DC2}"/>
               </a:ext>
             </a:extLst>
           </p:cNvPr>
@@ -9566,7 +10132,7 @@
           <p:cNvPr id="3" name="">
             <a:extLst xmlns:a="http://schemas.openxmlformats.org/drawingml/2006/main">
               <a:ext uri="{FF2B5EF4-FFF2-40B4-BE49-F238E27FC236}">
-                <a16:creationId xmlns:a16="http://schemas.microsoft.com/office/drawing/2014/main" id="{C1677EF5-AB1A-4881-A427-1382851B902D}"/>
+                <a16:creationId xmlns:a16="http://schemas.microsoft.com/office/drawing/2014/main" id="{B517584B-EE85-48D2-B40F-263E000A722A}"/>
               </a:ext>
             </a:extLst>
           </p:cNvPr>
@@ -9623,7 +10189,7 @@
           <p:cNvPr id="4" name="">
             <a:extLst xmlns:a="http://schemas.openxmlformats.org/drawingml/2006/main">
               <a:ext uri="{FF2B5EF4-FFF2-40B4-BE49-F238E27FC236}">
-                <a16:creationId xmlns:a16="http://schemas.microsoft.com/office/drawing/2014/main" id="{A3C6BF6F-E0EF-4892-8398-44515A94996C}"/>
+                <a16:creationId xmlns:a16="http://schemas.microsoft.com/office/drawing/2014/main" id="{C82A4E3E-2863-4A64-972A-231263E3AF9C}"/>
               </a:ext>
             </a:extLst>
           </p:cNvPr>
@@ -9680,7 +10246,7 @@
           <p:cNvPr id="5" name="">
             <a:extLst xmlns:a="http://schemas.openxmlformats.org/drawingml/2006/main">
               <a:ext uri="{FF2B5EF4-FFF2-40B4-BE49-F238E27FC236}">
-                <a16:creationId xmlns:a16="http://schemas.microsoft.com/office/drawing/2014/main" id="{1BBCAD94-7CF2-4E61-9C24-4255EF7E6927}"/>
+                <a16:creationId xmlns:a16="http://schemas.microsoft.com/office/drawing/2014/main" id="{FCA46E9F-3125-4AFC-8E05-1D2A9E2368B0}"/>
               </a:ext>
             </a:extLst>
           </p:cNvPr>
@@ -9737,7 +10303,7 @@
           <p:cNvPr id="6" name="">
             <a:extLst xmlns:a="http://schemas.openxmlformats.org/drawingml/2006/main">
               <a:ext uri="{FF2B5EF4-FFF2-40B4-BE49-F238E27FC236}">
-                <a16:creationId xmlns:a16="http://schemas.microsoft.com/office/drawing/2014/main" id="{2FCC7467-F857-47EF-9517-592747B70D0A}"/>
+                <a16:creationId xmlns:a16="http://schemas.microsoft.com/office/drawing/2014/main" id="{070E9A96-3752-4115-B51F-1C96BAD24108}"/>
               </a:ext>
             </a:extLst>
           </p:cNvPr>
@@ -9794,7 +10360,7 @@
           <p:cNvPr id="7" name="">
             <a:extLst xmlns:a="http://schemas.openxmlformats.org/drawingml/2006/main">
               <a:ext uri="{FF2B5EF4-FFF2-40B4-BE49-F238E27FC236}">
-                <a16:creationId xmlns:a16="http://schemas.microsoft.com/office/drawing/2014/main" id="{F11229A2-0D2F-41A8-9FF1-1058D0559295}"/>
+                <a16:creationId xmlns:a16="http://schemas.microsoft.com/office/drawing/2014/main" id="{33293BE1-EC6D-4179-891C-633D37DFB1AE}"/>
               </a:ext>
             </a:extLst>
           </p:cNvPr>
@@ -9851,7 +10417,7 @@
           <p:cNvPr id="8" name="">
             <a:extLst xmlns:a="http://schemas.openxmlformats.org/drawingml/2006/main">
               <a:ext uri="{FF2B5EF4-FFF2-40B4-BE49-F238E27FC236}">
-                <a16:creationId xmlns:a16="http://schemas.microsoft.com/office/drawing/2014/main" id="{6F25AE26-65D6-4FEE-99F0-76F89BC765FA}"/>
+                <a16:creationId xmlns:a16="http://schemas.microsoft.com/office/drawing/2014/main" id="{E3C606F0-F02F-41E1-8A69-8FDABB30D2CF}"/>
               </a:ext>
             </a:extLst>
           </p:cNvPr>
@@ -9883,7 +10449,7 @@
           <p:cNvPr id="9" name="">
             <a:extLst xmlns:a="http://schemas.openxmlformats.org/drawingml/2006/main">
               <a:ext uri="{FF2B5EF4-FFF2-40B4-BE49-F238E27FC236}">
-                <a16:creationId xmlns:a16="http://schemas.microsoft.com/office/drawing/2014/main" id="{108BE967-37C4-4086-B722-401355C513CF}"/>
+                <a16:creationId xmlns:a16="http://schemas.microsoft.com/office/drawing/2014/main" id="{2B78D46B-3112-4F63-9FE6-B82E9CFCF20C}"/>
               </a:ext>
             </a:extLst>
           </p:cNvPr>
@@ -9940,7 +10506,7 @@
           <p:cNvPr id="10" name="">
             <a:extLst xmlns:a="http://schemas.openxmlformats.org/drawingml/2006/main">
               <a:ext uri="{FF2B5EF4-FFF2-40B4-BE49-F238E27FC236}">
-                <a16:creationId xmlns:a16="http://schemas.microsoft.com/office/drawing/2014/main" id="{36B5207A-DBC7-4DED-9A3E-A1237983FD96}"/>
+                <a16:creationId xmlns:a16="http://schemas.microsoft.com/office/drawing/2014/main" id="{7F6A1BC4-CFA5-4178-9C34-370051F2250A}"/>
               </a:ext>
             </a:extLst>
           </p:cNvPr>
@@ -9997,7 +10563,7 @@
           <p:cNvPr id="11" name="">
             <a:extLst xmlns:a="http://schemas.openxmlformats.org/drawingml/2006/main">
               <a:ext uri="{FF2B5EF4-FFF2-40B4-BE49-F238E27FC236}">
-                <a16:creationId xmlns:a16="http://schemas.microsoft.com/office/drawing/2014/main" id="{357A9732-C940-415B-9C3E-B0D80DE87269}"/>
+                <a16:creationId xmlns:a16="http://schemas.microsoft.com/office/drawing/2014/main" id="{81D6205E-B7FE-4CCD-9CB1-613F0CF9E6AD}"/>
               </a:ext>
             </a:extLst>
           </p:cNvPr>
@@ -10029,7 +10595,7 @@
           <p:cNvPr id="12" name="">
             <a:extLst xmlns:a="http://schemas.openxmlformats.org/drawingml/2006/main">
               <a:ext uri="{FF2B5EF4-FFF2-40B4-BE49-F238E27FC236}">
-                <a16:creationId xmlns:a16="http://schemas.microsoft.com/office/drawing/2014/main" id="{C5FF2F14-A043-4346-AC1D-A2CCB0D427EA}"/>
+                <a16:creationId xmlns:a16="http://schemas.microsoft.com/office/drawing/2014/main" id="{BAFC787F-F6F4-4C13-B663-B02884BEA8FD}"/>
               </a:ext>
             </a:extLst>
           </p:cNvPr>
@@ -10086,7 +10652,7 @@
           <p:cNvPr id="13" name="">
             <a:extLst xmlns:a="http://schemas.openxmlformats.org/drawingml/2006/main">
               <a:ext uri="{FF2B5EF4-FFF2-40B4-BE49-F238E27FC236}">
-                <a16:creationId xmlns:a16="http://schemas.microsoft.com/office/drawing/2014/main" id="{29053AF6-4EF6-4C45-95A5-C2D285449B45}"/>
+                <a16:creationId xmlns:a16="http://schemas.microsoft.com/office/drawing/2014/main" id="{6F9F7F96-CF40-4187-85D0-35CCF28309F5}"/>
               </a:ext>
             </a:extLst>
           </p:cNvPr>
@@ -10143,7 +10709,7 @@
           <p:cNvPr id="14" name="">
             <a:extLst xmlns:a="http://schemas.openxmlformats.org/drawingml/2006/main">
               <a:ext uri="{FF2B5EF4-FFF2-40B4-BE49-F238E27FC236}">
-                <a16:creationId xmlns:a16="http://schemas.microsoft.com/office/drawing/2014/main" id="{3BD63B28-CB9B-4E56-8BC7-36980CAB42DD}"/>
+                <a16:creationId xmlns:a16="http://schemas.microsoft.com/office/drawing/2014/main" id="{6B1AA7CA-ECC4-439B-8E3E-784E45A6CD52}"/>
               </a:ext>
             </a:extLst>
           </p:cNvPr>
@@ -10175,7 +10741,7 @@
           <p:cNvPr id="15" name="">
             <a:extLst xmlns:a="http://schemas.openxmlformats.org/drawingml/2006/main">
               <a:ext uri="{FF2B5EF4-FFF2-40B4-BE49-F238E27FC236}">
-                <a16:creationId xmlns:a16="http://schemas.microsoft.com/office/drawing/2014/main" id="{72E29F66-90E4-40D3-BE4F-88A446DC2A70}"/>
+                <a16:creationId xmlns:a16="http://schemas.microsoft.com/office/drawing/2014/main" id="{9F315456-8E87-4EED-B1C3-C6D4BF4D6FCC}"/>
               </a:ext>
             </a:extLst>
           </p:cNvPr>
@@ -10232,7 +10798,7 @@
           <p:cNvPr id="16" name="">
             <a:extLst xmlns:a="http://schemas.openxmlformats.org/drawingml/2006/main">
               <a:ext uri="{FF2B5EF4-FFF2-40B4-BE49-F238E27FC236}">
-                <a16:creationId xmlns:a16="http://schemas.microsoft.com/office/drawing/2014/main" id="{782D53BD-4F28-4372-9E86-4AFEEBB9C2C4}"/>
+                <a16:creationId xmlns:a16="http://schemas.microsoft.com/office/drawing/2014/main" id="{CE595CBF-DCEC-41E9-AB57-A8B8A1B70127}"/>
               </a:ext>
             </a:extLst>
           </p:cNvPr>
@@ -10287,7 +10853,7 @@
     </p:spTree>
     <p:extLst>
       <p:ext uri="{BB962C8B-B14F-4D97-AF65-F5344CB8AC3E}">
-        <p14:creationId xmlns:p14="http://schemas.microsoft.com/office/powerpoint/2010/main" val="1513231194"/>
+        <p14:creationId xmlns:p14="http://schemas.microsoft.com/office/powerpoint/2010/main" val="701305140"/>
       </p:ext>
     </p:extLst>
   </p:cSld>

</xml_diff>